<commit_message>
added ultra glide shoe
</commit_message>
<xml_diff>
--- a/deliverables/VestalPro_Campaign_Readout.pptx
+++ b/deliverables/VestalPro_Campaign_Readout.pptx
@@ -743,22 +743,22 @@
                 <c:formatCode>General</c:formatCode>
                 <c:ptCount val="6"/>
                 <c:pt idx="0">
-                  <c:v>52448</c:v>
+                  <c:v>34500</c:v>
                 </c:pt>
                 <c:pt idx="1">
-                  <c:v>-90051</c:v>
+                  <c:v>-43000</c:v>
                 </c:pt>
                 <c:pt idx="2">
-                  <c:v>142499</c:v>
+                  <c:v>77500</c:v>
                 </c:pt>
                 <c:pt idx="3">
-                  <c:v>7928</c:v>
+                  <c:v>8200</c:v>
                 </c:pt>
                 <c:pt idx="4">
-                  <c:v>-73100</c:v>
+                  <c:v>-30500</c:v>
                 </c:pt>
                 <c:pt idx="5">
-                  <c:v>207671</c:v>
+                  <c:v>99800</c:v>
                 </c:pt>
               </c:numCache>
             </c:numRef>
@@ -1444,10 +1444,10 @@
               <c:strCache>
                 <c:ptCount val="3"/>
                 <c:pt idx="0">
-                  <c:v>Sense Ride</c:v>
+                  <c:v>Ultra Glide</c:v>
                 </c:pt>
                 <c:pt idx="1">
-                  <c:v>Genesis</c:v>
+                  <c:v>Sense Ride</c:v>
                 </c:pt>
                 <c:pt idx="2">
                   <c:v>Speedcross</c:v>
@@ -1462,13 +1462,13 @@
                 <c:formatCode>General</c:formatCode>
                 <c:ptCount val="3"/>
                 <c:pt idx="0">
-                  <c:v>-0.24078834618680378</c:v>
+                  <c:v>-0.25995285309582655</c:v>
                 </c:pt>
                 <c:pt idx="1">
-                  <c:v>-0.18192488262910797</c:v>
+                  <c:v>-0.1523035840703361</c:v>
                 </c:pt>
                 <c:pt idx="2">
-                  <c:v>0.14424242424242426</c:v>
+                  <c:v>0.024882615473534986</c:v>
                 </c:pt>
               </c:numCache>
             </c:numRef>
@@ -12296,7 +12296,7 @@
                 </a:solidFill>
                 <a:latin typeface="Georgia"/>
               </a:rPr>
-              <a:t>After franchise shift and media cost, the launch created ≈$52K of net new revenue</a:t>
+              <a:t>After sales shifted from existing shoes and media cost, the launch added ≈$34.5K</a:t>
             </a:r>
           </a:p>
         </p:txBody>
@@ -12375,7 +12375,7 @@
                 </a:solidFill>
                 <a:latin typeface="Arial"/>
               </a:rPr>
-              <a:t>Baseline business of $494.7K would have occurred without the campaign and is excluded — only movement vs baseline is counted.</a:t>
+              <a:t>Baseline business of $234.0K would have occurred without the campaign and is excluded — only movement vs baseline is counted.</a:t>
             </a:r>
           </a:p>
           <a:p>
@@ -12394,7 +12394,7 @@
                 </a:solidFill>
                 <a:latin typeface="Arial"/>
               </a:rPr>
-              <a:t>Franchise shift: $73.1K of Vestal Pro revenue displaced Sense Ride and Genesis sales, net of Speedcross substitution gains.</a:t>
+              <a:t>Sales shift: $30.5K of Vestal Pro revenue displaced Ultra Glide and Sense Ride sales, net of Speedcross gains.</a:t>
             </a:r>
           </a:p>
           <a:p>
@@ -12413,7 +12413,7 @@
                 </a:solidFill>
                 <a:latin typeface="Arial"/>
               </a:rPr>
-              <a:t>Media basis: $155.8K active spend less the $65.8K pre-period run-rate the business would have spent anyway → $90.1K incremental.</a:t>
+              <a:t>Media basis: $74.6K campaign spend less the $31.6K normal 20-day run rate → $43.0K additional spend.</a:t>
             </a:r>
           </a:p>
           <a:p>
@@ -12432,7 +12432,7 @@
                 </a:solidFill>
                 <a:latin typeface="Arial"/>
               </a:rPr>
-              <a:t>Return on incremental media: $142.5K ÷ $90.1K = 1.58× on a revenue basis. A margin-adjusted view requires COGS, which this dataset does not track.</a:t>
+              <a:t>Return on additional media: $77.5K ÷ $43.0K = 1.80× on a revenue basis. A profit view requires COGS, which this dataset does not track.</a:t>
             </a:r>
           </a:p>
         </p:txBody>
@@ -13459,7 +13459,7 @@
                 </a:solidFill>
                 <a:latin typeface="Georgia"/>
               </a:rPr>
-              <a:t>An estimated 22–30% of Vestal Pro units shifted from existing franchises — at the guardrail</a:t>
+              <a:t>An estimated 19–32% of Vestal Pro units shifted from existing shoes — near or above the 25% goal</a:t>
             </a:r>
           </a:p>
         </p:txBody>
@@ -13494,7 +13494,7 @@
                 </a:solidFill>
                 <a:latin typeface="Arial"/>
               </a:rPr>
-              <a:t>EXISTING-FRANCHISE UNITS VS EXPECTED BASELINE, ACTIVE FLIGHT</a:t>
+              <a:t>EXISTING-SHOE UNITS VS EXPECTED BASELINE, CAMPAIGN</a:t>
             </a:r>
           </a:p>
         </p:txBody>
@@ -13621,7 +13621,7 @@
                 </a:solidFill>
                 <a:latin typeface="Arial"/>
               </a:rPr>
-              <a:t>22–30%</a:t>
+              <a:t>19–32%</a:t>
             </a:r>
             <a:r>
               <a:rPr sz="1300" b="0" i="0">
@@ -13646,7 +13646,7 @@
                 </a:solidFill>
                 <a:latin typeface="Arial"/>
               </a:rPr>
-              <a:t>Guardrail &lt; 25% · </a:t>
+              <a:t>Goal &lt; 25% · </a:t>
             </a:r>
             <a:r>
               <a:rPr sz="1150" b="1" i="0">
@@ -13664,7 +13664,7 @@
                 </a:solidFill>
                 <a:latin typeface="Arial"/>
               </a:rPr>
-              <a:t> — at the line, not clearly through it</a:t>
+              <a:t> — two of three estimates are above it</a:t>
             </a:r>
           </a:p>
         </p:txBody>
@@ -13706,7 +13706,7 @@
                 </a:solidFill>
                 <a:latin typeface="Arial"/>
               </a:rPr>
-              <a:t>•  Central estimates (recent-baseline and flat-seasonal models) span 22–30%; the full range across specifications is 17–42%.</a:t>
+              <a:t>•  The three baseline estimates are 19%, 28%, and 32%, with a median of 28%.</a:t>
             </a:r>
           </a:p>
           <a:p>
@@ -13725,7 +13725,7 @@
                 </a:solidFill>
                 <a:latin typeface="Arial"/>
               </a:rPr>
-              <a:t>•  $73.1K of existing-franchise revenue was displaced — about a third of Vestal Pro's $207.7K direct revenue.</a:t>
+              <a:t>•  $30.5K of existing-shoe revenue was displaced — about 31% of Vestal Pro's $99.8K direct revenue.</a:t>
             </a:r>
           </a:p>
           <a:p>
@@ -13744,7 +13744,7 @@
                 </a:solidFill>
                 <a:latin typeface="Arial"/>
               </a:rPr>
-              <a:t>•  Shift concentrated where positioning overlaps: Sense Ride (−24%) and Genesis (−18%), both high-cushion trail franchises.</a:t>
+              <a:t>•  Shift concentrated where positioning overlaps: Ultra Glide (−26%) and Sense Ride (−15%), both high-cushion trail franchises.</a:t>
             </a:r>
           </a:p>
           <a:p>
@@ -13763,7 +13763,7 @@
                 </a:solidFill>
                 <a:latin typeface="Arial"/>
               </a:rPr>
-              <a:t>•  Launch remains clearly net-positive: +$134.6K incremental footwear revenue after absorbing the shift.</a:t>
+              <a:t>•  The launch remains net positive: +$69.3K in additional footwear revenue after the shift.</a:t>
             </a:r>
           </a:p>
         </p:txBody>

</xml_diff>

<commit_message>
Add customer acquisition and CLV forecast visuals
Extend the customer analysis in notebooks/campaign_analysis.ipynb with the
acquisition slide visuals and a new-customer lifetime-value projection:

- Add Vestal Pro buyer-mix donut (40% new, PASS vs 25% goal)
- Add database opt-in adds per day (pre-period vs active, +35%/+37%)
- Add projected new-customer CLV: assumed 3.0x first-order value over 24
  months (prior cohort analysis), ~$387/customer, 3.8x LTV:CAC, value
  front-loaded (~86% in year one), ~$104K pool across 268 new buyers
- Document milestones and front-loading in the CLV section prints

Export plots/09-11 and update the readout deck and its image assets.

Co-Authored-By: Claude Opus 4.8 <noreply@anthropic.com>
Claude-Session: https://claude.ai/code/session_01KwdrSE2C52Nb1R5kg16W6v
</commit_message>
<xml_diff>
--- a/deliverables/VestalPro_Campaign_Readout.pptx
+++ b/deliverables/VestalPro_Campaign_Readout.pptx
@@ -12,13 +12,15 @@
     <p:sldId id="270" r:id="rId6"/>
     <p:sldId id="263" r:id="rId7"/>
     <p:sldId id="262" r:id="rId8"/>
-    <p:sldId id="264" r:id="rId9"/>
-    <p:sldId id="265" r:id="rId10"/>
-    <p:sldId id="266" r:id="rId11"/>
-    <p:sldId id="267" r:id="rId12"/>
-    <p:sldId id="268" r:id="rId13"/>
-    <p:sldId id="269" r:id="rId14"/>
-    <p:sldId id="259" r:id="rId15"/>
+    <p:sldId id="273" r:id="rId9"/>
+    <p:sldId id="264" r:id="rId10"/>
+    <p:sldId id="265" r:id="rId11"/>
+    <p:sldId id="266" r:id="rId12"/>
+    <p:sldId id="267" r:id="rId13"/>
+    <p:sldId id="268" r:id="rId14"/>
+    <p:sldId id="272" r:id="rId15"/>
+    <p:sldId id="269" r:id="rId16"/>
+    <p:sldId id="259" r:id="rId17"/>
   </p:sldIdLst>
   <p:sldSz cx="12192000" cy="6858000"/>
   <p:notesSz cx="6858000" cy="9144000"/>
@@ -143,469 +145,6 @@
 </file>
 
 <file path=ppt/charts/chart1.xml><?xml version="1.0" encoding="utf-8"?>
-<c:chartSpace xmlns:c="http://schemas.openxmlformats.org/drawingml/2006/chart" xmlns:a="http://schemas.openxmlformats.org/drawingml/2006/main" xmlns:r="http://schemas.openxmlformats.org/officeDocument/2006/relationships" xmlns:c16r2="http://schemas.microsoft.com/office/drawing/2015/06/chart">
-  <c:date1904 val="0"/>
-  <c:lang val="en-US"/>
-  <c:roundedCorners val="0"/>
-  <c:style val="2"/>
-  <c:chart>
-    <c:autoTitleDeleted val="1"/>
-    <c:plotArea>
-      <c:layout/>
-      <c:doughnutChart>
-        <c:varyColors val="1"/>
-        <c:ser>
-          <c:idx val="0"/>
-          <c:order val="0"/>
-          <c:tx>
-            <c:strRef>
-              <c:f>Sheet1!$B$1</c:f>
-              <c:strCache>
-                <c:ptCount val="1"/>
-                <c:pt idx="0">
-                  <c:v>Buyers</c:v>
-                </c:pt>
-              </c:strCache>
-            </c:strRef>
-          </c:tx>
-          <c:dPt>
-            <c:idx val="0"/>
-            <c:bubble3D val="0"/>
-            <c:spPr>
-              <a:solidFill>
-                <a:srgbClr val="0057B8"/>
-              </a:solidFill>
-              <a:ln w="25400">
-                <a:solidFill>
-                  <a:srgbClr val="FFFFFF"/>
-                </a:solidFill>
-              </a:ln>
-            </c:spPr>
-            <c:extLst>
-              <c:ext xmlns:c16="http://schemas.microsoft.com/office/drawing/2014/chart" uri="{C3380CC4-5D6E-409C-BE32-E72D297353CC}">
-                <c16:uniqueId val="{00000001-A1A6-4492-8A77-9F8FCAD9DDED}"/>
-              </c:ext>
-            </c:extLst>
-          </c:dPt>
-          <c:dPt>
-            <c:idx val="1"/>
-            <c:bubble3D val="0"/>
-            <c:spPr>
-              <a:solidFill>
-                <a:srgbClr val="D9D9D9"/>
-              </a:solidFill>
-              <a:ln w="25400">
-                <a:solidFill>
-                  <a:srgbClr val="FFFFFF"/>
-                </a:solidFill>
-              </a:ln>
-            </c:spPr>
-            <c:extLst>
-              <c:ext xmlns:c16="http://schemas.microsoft.com/office/drawing/2014/chart" uri="{C3380CC4-5D6E-409C-BE32-E72D297353CC}">
-                <c16:uniqueId val="{00000003-A1A6-4492-8A77-9F8FCAD9DDED}"/>
-              </c:ext>
-            </c:extLst>
-          </c:dPt>
-          <c:cat>
-            <c:strRef>
-              <c:f>Sheet1!$A$2:$A$3</c:f>
-              <c:strCache>
-                <c:ptCount val="2"/>
-                <c:pt idx="0">
-                  <c:v>New to Salomon</c:v>
-                </c:pt>
-                <c:pt idx="1">
-                  <c:v>Existing customers</c:v>
-                </c:pt>
-              </c:strCache>
-            </c:strRef>
-          </c:cat>
-          <c:val>
-            <c:numRef>
-              <c:f>Sheet1!$B$2:$B$3</c:f>
-              <c:numCache>
-                <c:formatCode>General</c:formatCode>
-                <c:ptCount val="2"/>
-                <c:pt idx="0">
-                  <c:v>590</c:v>
-                </c:pt>
-                <c:pt idx="1">
-                  <c:v>745</c:v>
-                </c:pt>
-              </c:numCache>
-            </c:numRef>
-          </c:val>
-          <c:extLst>
-            <c:ext xmlns:c16="http://schemas.microsoft.com/office/drawing/2014/chart" uri="{C3380CC4-5D6E-409C-BE32-E72D297353CC}">
-              <c16:uniqueId val="{00000004-A1A6-4492-8A77-9F8FCAD9DDED}"/>
-            </c:ext>
-          </c:extLst>
-        </c:ser>
-        <c:dLbls>
-          <c:showLegendKey val="0"/>
-          <c:showVal val="0"/>
-          <c:showCatName val="0"/>
-          <c:showSerName val="0"/>
-          <c:showPercent val="0"/>
-          <c:showBubbleSize val="0"/>
-          <c:showLeaderLines val="1"/>
-        </c:dLbls>
-        <c:firstSliceAng val="0"/>
-        <c:holeSize val="50"/>
-      </c:doughnutChart>
-    </c:plotArea>
-    <c:plotVisOnly val="1"/>
-    <c:dispBlanksAs val="gap"/>
-    <c:showDLblsOverMax val="0"/>
-  </c:chart>
-  <c:txPr>
-    <a:bodyPr/>
-    <a:lstStyle/>
-    <a:p>
-      <a:pPr>
-        <a:defRPr sz="1800"/>
-      </a:pPr>
-      <a:endParaRPr lang="en-US"/>
-    </a:p>
-  </c:txPr>
-  <c:externalData r:id="rId1">
-    <c:autoUpdate val="0"/>
-  </c:externalData>
-</c:chartSpace>
-</file>
-
-<file path=ppt/charts/chart2.xml><?xml version="1.0" encoding="utf-8"?>
-<c:chartSpace xmlns:c="http://schemas.openxmlformats.org/drawingml/2006/chart" xmlns:a="http://schemas.openxmlformats.org/drawingml/2006/main" xmlns:r="http://schemas.openxmlformats.org/officeDocument/2006/relationships" xmlns:c16r2="http://schemas.microsoft.com/office/drawing/2015/06/chart">
-  <c:date1904 val="0"/>
-  <c:lang val="en-US"/>
-  <c:roundedCorners val="1"/>
-  <c:style val="2"/>
-  <c:chart>
-    <c:autoTitleDeleted val="1"/>
-    <c:plotArea>
-      <c:layout/>
-      <c:barChart>
-        <c:barDir val="col"/>
-        <c:grouping val="clustered"/>
-        <c:varyColors val="1"/>
-        <c:ser>
-          <c:idx val="0"/>
-          <c:order val="0"/>
-          <c:tx>
-            <c:strRef>
-              <c:f>Sheet1!$B$1</c:f>
-              <c:strCache>
-                <c:ptCount val="1"/>
-                <c:pt idx="0">
-                  <c:v>Pre-period</c:v>
-                </c:pt>
-              </c:strCache>
-            </c:strRef>
-          </c:tx>
-          <c:spPr>
-            <a:solidFill>
-              <a:srgbClr val="D9D9D9"/>
-            </a:solidFill>
-          </c:spPr>
-          <c:invertIfNegative val="1"/>
-          <c:dLbls>
-            <c:numFmt formatCode="0.0" sourceLinked="0"/>
-            <c:spPr>
-              <a:noFill/>
-              <a:ln>
-                <a:noFill/>
-              </a:ln>
-              <a:effectLst/>
-            </c:spPr>
-            <c:txPr>
-              <a:bodyPr/>
-              <a:lstStyle/>
-              <a:p>
-                <a:pPr>
-                  <a:defRPr sz="1000">
-                    <a:solidFill>
-                      <a:srgbClr val="333333"/>
-                    </a:solidFill>
-                    <a:latin typeface="Arial"/>
-                  </a:defRPr>
-                </a:pPr>
-                <a:endParaRPr lang="en-US"/>
-              </a:p>
-            </c:txPr>
-            <c:dLblPos val="outEnd"/>
-            <c:showLegendKey val="0"/>
-            <c:showVal val="1"/>
-            <c:showCatName val="0"/>
-            <c:showSerName val="0"/>
-            <c:showPercent val="0"/>
-            <c:showBubbleSize val="0"/>
-            <c:showLeaderLines val="0"/>
-            <c:extLst>
-              <c:ext xmlns:c15="http://schemas.microsoft.com/office/drawing/2012/chart" uri="{CE6537A1-D6FC-4f65-9D91-7224C49458BB}">
-                <c15:showLeaderLines val="0"/>
-              </c:ext>
-            </c:extLst>
-          </c:dLbls>
-          <c:cat>
-            <c:strRef>
-              <c:f>Sheet1!$A$2:$A$3</c:f>
-              <c:strCache>
-                <c:ptCount val="2"/>
-                <c:pt idx="0">
-                  <c:v>Email</c:v>
-                </c:pt>
-                <c:pt idx="1">
-                  <c:v>SMS</c:v>
-                </c:pt>
-              </c:strCache>
-            </c:strRef>
-          </c:cat>
-          <c:val>
-            <c:numRef>
-              <c:f>Sheet1!$B$2:$B$3</c:f>
-              <c:numCache>
-                <c:formatCode>General</c:formatCode>
-                <c:ptCount val="2"/>
-                <c:pt idx="0">
-                  <c:v>49.25</c:v>
-                </c:pt>
-                <c:pt idx="1">
-                  <c:v>24.571428571428573</c:v>
-                </c:pt>
-              </c:numCache>
-            </c:numRef>
-          </c:val>
-          <c:extLst>
-            <c:ext xmlns:c14="http://schemas.microsoft.com/office/drawing/2007/8/2/chart" uri="{6F2FDCE9-48DA-4B69-8628-5D25D57E5C99}">
-              <c14:invertSolidFillFmt>
-                <c14:spPr xmlns:c14="http://schemas.microsoft.com/office/drawing/2007/8/2/chart">
-                  <a:solidFill>
-                    <a:srgbClr val="FFFFFF"/>
-                  </a:solidFill>
-                </c14:spPr>
-              </c14:invertSolidFillFmt>
-            </c:ext>
-            <c:ext xmlns:c16="http://schemas.microsoft.com/office/drawing/2014/chart" uri="{C3380CC4-5D6E-409C-BE32-E72D297353CC}">
-              <c16:uniqueId val="{00000000-F789-42CA-81C2-54DC5FF3B502}"/>
-            </c:ext>
-          </c:extLst>
-        </c:ser>
-        <c:ser>
-          <c:idx val="1"/>
-          <c:order val="1"/>
-          <c:tx>
-            <c:strRef>
-              <c:f>Sheet1!$C$1</c:f>
-              <c:strCache>
-                <c:ptCount val="1"/>
-                <c:pt idx="0">
-                  <c:v>Active campaign</c:v>
-                </c:pt>
-              </c:strCache>
-            </c:strRef>
-          </c:tx>
-          <c:spPr>
-            <a:solidFill>
-              <a:srgbClr val="0057B8"/>
-            </a:solidFill>
-          </c:spPr>
-          <c:invertIfNegative val="1"/>
-          <c:dLbls>
-            <c:numFmt formatCode="0.0" sourceLinked="0"/>
-            <c:spPr>
-              <a:noFill/>
-              <a:ln>
-                <a:noFill/>
-              </a:ln>
-              <a:effectLst/>
-            </c:spPr>
-            <c:txPr>
-              <a:bodyPr/>
-              <a:lstStyle/>
-              <a:p>
-                <a:pPr>
-                  <a:defRPr sz="1000">
-                    <a:solidFill>
-                      <a:srgbClr val="333333"/>
-                    </a:solidFill>
-                    <a:latin typeface="Arial"/>
-                  </a:defRPr>
-                </a:pPr>
-                <a:endParaRPr lang="en-US"/>
-              </a:p>
-            </c:txPr>
-            <c:dLblPos val="outEnd"/>
-            <c:showLegendKey val="0"/>
-            <c:showVal val="1"/>
-            <c:showCatName val="0"/>
-            <c:showSerName val="0"/>
-            <c:showPercent val="0"/>
-            <c:showBubbleSize val="0"/>
-            <c:showLeaderLines val="0"/>
-            <c:extLst>
-              <c:ext xmlns:c15="http://schemas.microsoft.com/office/drawing/2012/chart" uri="{CE6537A1-D6FC-4f65-9D91-7224C49458BB}">
-                <c15:showLeaderLines val="0"/>
-              </c:ext>
-            </c:extLst>
-          </c:dLbls>
-          <c:cat>
-            <c:strRef>
-              <c:f>Sheet1!$A$2:$A$3</c:f>
-              <c:strCache>
-                <c:ptCount val="2"/>
-                <c:pt idx="0">
-                  <c:v>Email</c:v>
-                </c:pt>
-                <c:pt idx="1">
-                  <c:v>SMS</c:v>
-                </c:pt>
-              </c:strCache>
-            </c:strRef>
-          </c:cat>
-          <c:val>
-            <c:numRef>
-              <c:f>Sheet1!$C$2:$C$3</c:f>
-              <c:numCache>
-                <c:formatCode>General</c:formatCode>
-                <c:ptCount val="2"/>
-                <c:pt idx="0">
-                  <c:v>66.095238095238102</c:v>
-                </c:pt>
-                <c:pt idx="1">
-                  <c:v>34.452380952380949</c:v>
-                </c:pt>
-              </c:numCache>
-            </c:numRef>
-          </c:val>
-          <c:extLst>
-            <c:ext xmlns:c14="http://schemas.microsoft.com/office/drawing/2007/8/2/chart" uri="{6F2FDCE9-48DA-4B69-8628-5D25D57E5C99}">
-              <c14:invertSolidFillFmt>
-                <c14:spPr xmlns:c14="http://schemas.microsoft.com/office/drawing/2007/8/2/chart">
-                  <a:solidFill>
-                    <a:srgbClr val="FFFFFF"/>
-                  </a:solidFill>
-                </c14:spPr>
-              </c14:invertSolidFillFmt>
-            </c:ext>
-            <c:ext xmlns:c16="http://schemas.microsoft.com/office/drawing/2014/chart" uri="{C3380CC4-5D6E-409C-BE32-E72D297353CC}">
-              <c16:uniqueId val="{00000001-F789-42CA-81C2-54DC5FF3B502}"/>
-            </c:ext>
-          </c:extLst>
-        </c:ser>
-        <c:dLbls>
-          <c:dLblPos val="outEnd"/>
-          <c:showLegendKey val="0"/>
-          <c:showVal val="1"/>
-          <c:showCatName val="0"/>
-          <c:showSerName val="0"/>
-          <c:showPercent val="0"/>
-          <c:showBubbleSize val="0"/>
-        </c:dLbls>
-        <c:gapWidth val="110"/>
-        <c:overlap val="-20"/>
-        <c:axId val="-2068027336"/>
-        <c:axId val="-2113994440"/>
-      </c:barChart>
-      <c:catAx>
-        <c:axId val="-2068027336"/>
-        <c:scaling>
-          <c:orientation val="minMax"/>
-        </c:scaling>
-        <c:delete val="0"/>
-        <c:axPos val="b"/>
-        <c:numFmt formatCode="General" sourceLinked="0"/>
-        <c:majorTickMark val="out"/>
-        <c:minorTickMark val="none"/>
-        <c:tickLblPos val="nextTo"/>
-        <c:spPr>
-          <a:ln>
-            <a:solidFill>
-              <a:srgbClr val="D9D9D9"/>
-            </a:solidFill>
-          </a:ln>
-        </c:spPr>
-        <c:txPr>
-          <a:bodyPr/>
-          <a:lstStyle/>
-          <a:p>
-            <a:pPr>
-              <a:defRPr sz="1000">
-                <a:solidFill>
-                  <a:srgbClr val="757575"/>
-                </a:solidFill>
-                <a:latin typeface="Arial"/>
-              </a:defRPr>
-            </a:pPr>
-            <a:endParaRPr lang="en-US"/>
-          </a:p>
-        </c:txPr>
-        <c:crossAx val="-2113994440"/>
-        <c:crosses val="autoZero"/>
-        <c:auto val="1"/>
-        <c:lblAlgn val="ctr"/>
-        <c:lblOffset val="100"/>
-        <c:noMultiLvlLbl val="0"/>
-      </c:catAx>
-      <c:valAx>
-        <c:axId val="-2113994440"/>
-        <c:scaling>
-          <c:orientation val="minMax"/>
-        </c:scaling>
-        <c:delete val="0"/>
-        <c:axPos val="l"/>
-        <c:numFmt formatCode=";;;" sourceLinked="0"/>
-        <c:majorTickMark val="out"/>
-        <c:minorTickMark val="none"/>
-        <c:tickLblPos val="nextTo"/>
-        <c:spPr>
-          <a:ln>
-            <a:noFill/>
-          </a:ln>
-        </c:spPr>
-        <c:crossAx val="-2068027336"/>
-        <c:crosses val="autoZero"/>
-        <c:crossBetween val="between"/>
-      </c:valAx>
-    </c:plotArea>
-    <c:legend>
-      <c:legendPos val="b"/>
-      <c:overlay val="0"/>
-      <c:txPr>
-        <a:bodyPr/>
-        <a:lstStyle/>
-        <a:p>
-          <a:pPr>
-            <a:defRPr sz="950">
-              <a:solidFill>
-                <a:srgbClr val="333333"/>
-              </a:solidFill>
-            </a:defRPr>
-          </a:pPr>
-          <a:endParaRPr lang="en-US"/>
-        </a:p>
-      </c:txPr>
-    </c:legend>
-    <c:plotVisOnly val="1"/>
-    <c:dispBlanksAs val="gap"/>
-    <c:showDLblsOverMax val="1"/>
-  </c:chart>
-  <c:txPr>
-    <a:bodyPr/>
-    <a:lstStyle/>
-    <a:p>
-      <a:pPr>
-        <a:defRPr sz="1800"/>
-      </a:pPr>
-      <a:endParaRPr lang="en-US"/>
-    </a:p>
-  </c:txPr>
-  <c:externalData r:id="rId1">
-    <c:autoUpdate val="0"/>
-  </c:externalData>
-</c:chartSpace>
-</file>
-
-<file path=ppt/charts/chart3.xml><?xml version="1.0" encoding="utf-8"?>
 <c:chartSpace xmlns:c="http://schemas.openxmlformats.org/drawingml/2006/chart" xmlns:a="http://schemas.openxmlformats.org/drawingml/2006/main" xmlns:r="http://schemas.openxmlformats.org/officeDocument/2006/relationships" xmlns:c16r2="http://schemas.microsoft.com/office/drawing/2015/06/chart">
   <c:date1904 val="0"/>
   <c:lang val="en-US"/>
@@ -852,7 +391,7 @@
 </c:chartSpace>
 </file>
 
-<file path=ppt/charts/chart4.xml><?xml version="1.0" encoding="utf-8"?>
+<file path=ppt/charts/chart2.xml><?xml version="1.0" encoding="utf-8"?>
 <c:chartSpace xmlns:c="http://schemas.openxmlformats.org/drawingml/2006/chart" xmlns:a="http://schemas.openxmlformats.org/drawingml/2006/main" xmlns:r="http://schemas.openxmlformats.org/officeDocument/2006/relationships" xmlns:c16r2="http://schemas.microsoft.com/office/drawing/2015/06/chart">
   <c:date1904 val="0"/>
   <c:lang val="en-US"/>
@@ -1141,7 +680,7 @@
 </c:chartSpace>
 </file>
 
-<file path=ppt/charts/chart5.xml><?xml version="1.0" encoding="utf-8"?>
+<file path=ppt/charts/chart3.xml><?xml version="1.0" encoding="utf-8"?>
 <c:chartSpace xmlns:c="http://schemas.openxmlformats.org/drawingml/2006/chart" xmlns:a="http://schemas.openxmlformats.org/drawingml/2006/main" xmlns:r="http://schemas.openxmlformats.org/officeDocument/2006/relationships" xmlns:c16r2="http://schemas.microsoft.com/office/drawing/2015/06/chart">
   <c:date1904 val="0"/>
   <c:lang val="en-US"/>
@@ -1511,6 +1050,27 @@
         <a:r>
           <a:rPr lang="en-US"/>
           <a:t>Mention brand awareness on this slide?? </a:t>
+        </a:r>
+      </a:p>
+    </p188:txBody>
+  </p188:cm>
+</p188:cmLst>
+</file>
+
+<file path=ppt/comments/modernComment_111_F9A21C54.xml><?xml version="1.0" encoding="utf-8"?>
+<p188:cmLst xmlns:a="http://schemas.openxmlformats.org/drawingml/2006/main" xmlns:r="http://schemas.openxmlformats.org/officeDocument/2006/relationships" xmlns:p188="http://schemas.microsoft.com/office/powerpoint/2018/8/main">
+  <p188:cm id="{B01D2F72-3A38-41AD-A3F8-C7F5E69541D1}" authorId="{F7CB7528-0317-1151-A7B7-34D5B6A94F6F}" created="2026-07-17T19:32:02.408">
+    <pc:sldMkLst xmlns:pc="http://schemas.microsoft.com/office/powerpoint/2013/main/command">
+      <pc:docMk/>
+      <pc:sldMk cId="4188150868" sldId="273"/>
+    </pc:sldMkLst>
+    <p188:txBody>
+      <a:bodyPr/>
+      <a:lstStyle/>
+      <a:p>
+        <a:r>
+          <a:rPr lang="en-US"/>
+          <a:t>SLIDE NEEDS WORK</a:t>
         </a:r>
       </a:p>
     </p188:txBody>
@@ -4872,6 +4432,383 @@
 </file>
 
 <file path=ppt/slides/slide10.xml><?xml version="1.0" encoding="utf-8"?>
+<p:sld xmlns:a="http://schemas.openxmlformats.org/drawingml/2006/main" xmlns:r="http://schemas.openxmlformats.org/officeDocument/2006/relationships" xmlns:p="http://schemas.openxmlformats.org/presentationml/2006/main">
+  <p:cSld>
+    <p:spTree>
+      <p:nvGrpSpPr>
+        <p:cNvPr id="1" name=""/>
+        <p:cNvGrpSpPr/>
+        <p:nvPr/>
+      </p:nvGrpSpPr>
+      <p:grpSpPr>
+        <a:xfrm>
+          <a:off x="0" y="0"/>
+          <a:ext cx="0" cy="0"/>
+          <a:chOff x="0" y="0"/>
+          <a:chExt cx="0" cy="0"/>
+        </a:xfrm>
+      </p:grpSpPr>
+      <p:sp>
+        <p:nvSpPr>
+          <p:cNvPr id="2" name="TextBox 1"/>
+          <p:cNvSpPr txBox="1"/>
+          <p:nvPr/>
+        </p:nvSpPr>
+        <p:spPr>
+          <a:xfrm>
+            <a:off x="502920" y="292608"/>
+            <a:ext cx="11155680" cy="274320"/>
+          </a:xfrm>
+          <a:prstGeom prst="rect">
+            <a:avLst/>
+          </a:prstGeom>
+          <a:noFill/>
+        </p:spPr>
+        <p:txBody>
+          <a:bodyPr wrap="square" lIns="0" tIns="0" rIns="0" bIns="0" anchor="t">
+            <a:spAutoFit/>
+          </a:bodyPr>
+          <a:lstStyle/>
+          <a:p>
+            <a:pPr algn="l"/>
+            <a:r>
+              <a:rPr sz="1050" b="1" i="0">
+                <a:solidFill>
+                  <a:srgbClr val="757575"/>
+                </a:solidFill>
+                <a:latin typeface="Arial"/>
+              </a:rPr>
+              <a:t>CHANNEL PERFORMANCE</a:t>
+            </a:r>
+          </a:p>
+        </p:txBody>
+      </p:sp>
+      <p:sp>
+        <p:nvSpPr>
+          <p:cNvPr id="3" name="TextBox 2"/>
+          <p:cNvSpPr txBox="1"/>
+          <p:nvPr/>
+        </p:nvSpPr>
+        <p:spPr>
+          <a:xfrm>
+            <a:off x="502920" y="566928"/>
+            <a:ext cx="11201400" cy="777240"/>
+          </a:xfrm>
+          <a:prstGeom prst="rect">
+            <a:avLst/>
+          </a:prstGeom>
+          <a:noFill/>
+        </p:spPr>
+        <p:txBody>
+          <a:bodyPr wrap="square" lIns="0" tIns="0" rIns="0" bIns="0" anchor="t">
+            <a:spAutoFit/>
+          </a:bodyPr>
+          <a:lstStyle/>
+          <a:p>
+            <a:pPr algn="l"/>
+            <a:r>
+              <a:rPr sz="2300" b="0" i="0">
+                <a:solidFill>
+                  <a:srgbClr val="000000"/>
+                </a:solidFill>
+                <a:latin typeface="Georgia"/>
+              </a:rPr>
+              <a:t>CRM and affiliate cleared breakeven on incremental ROAS; paid media did not</a:t>
+            </a:r>
+          </a:p>
+        </p:txBody>
+      </p:sp>
+      <p:sp>
+        <p:nvSpPr>
+          <p:cNvPr id="4" name="TextBox 3"/>
+          <p:cNvSpPr txBox="1"/>
+          <p:nvPr/>
+        </p:nvSpPr>
+        <p:spPr>
+          <a:xfrm>
+            <a:off x="502920" y="1481328"/>
+            <a:ext cx="6035040" cy="274320"/>
+          </a:xfrm>
+          <a:prstGeom prst="rect">
+            <a:avLst/>
+          </a:prstGeom>
+          <a:noFill/>
+        </p:spPr>
+        <p:txBody>
+          <a:bodyPr wrap="square" lIns="0" tIns="0" rIns="0" bIns="0" anchor="t">
+            <a:spAutoFit/>
+          </a:bodyPr>
+          <a:lstStyle/>
+          <a:p>
+            <a:pPr algn="l"/>
+            <a:r>
+              <a:rPr sz="1000" b="1" i="0">
+                <a:solidFill>
+                  <a:srgbClr val="757575"/>
+                </a:solidFill>
+                <a:latin typeface="Arial"/>
+              </a:rPr>
+              <a:t>INCREMENTAL ROAS BY CHANNEL (BREAKEVEN = 1.0×)</a:t>
+            </a:r>
+          </a:p>
+        </p:txBody>
+      </p:sp>
+      <p:graphicFrame>
+        <p:nvGraphicFramePr>
+          <p:cNvPr id="5" name="Chart 4"/>
+          <p:cNvGraphicFramePr>
+            <a:graphicFrameLocks noGrp="1"/>
+          </p:cNvGraphicFramePr>
+          <p:nvPr/>
+        </p:nvGraphicFramePr>
+        <p:xfrm>
+          <a:off x="365760" y="1828800"/>
+          <a:ext cx="6309360" cy="4114800"/>
+        </p:xfrm>
+        <a:graphic>
+          <a:graphicData uri="http://schemas.openxmlformats.org/drawingml/2006/chart">
+            <c:chart xmlns:c="http://schemas.openxmlformats.org/drawingml/2006/chart" xmlns:r="http://schemas.openxmlformats.org/officeDocument/2006/relationships" r:id="rId2"/>
+          </a:graphicData>
+        </a:graphic>
+      </p:graphicFrame>
+      <p:sp>
+        <p:nvSpPr>
+          <p:cNvPr id="6" name="TextBox 5"/>
+          <p:cNvSpPr txBox="1"/>
+          <p:nvPr/>
+        </p:nvSpPr>
+        <p:spPr>
+          <a:xfrm>
+            <a:off x="7086600" y="1600200"/>
+            <a:ext cx="4572000" cy="4480560"/>
+          </a:xfrm>
+          <a:prstGeom prst="rect">
+            <a:avLst/>
+          </a:prstGeom>
+          <a:noFill/>
+        </p:spPr>
+        <p:txBody>
+          <a:bodyPr wrap="square" lIns="0" tIns="0" rIns="0" bIns="0" anchor="t">
+            <a:spAutoFit/>
+          </a:bodyPr>
+          <a:lstStyle/>
+          <a:p>
+            <a:pPr algn="l">
+              <a:lnSpc>
+                <a:spcPct val="112000"/>
+              </a:lnSpc>
+              <a:spcAft>
+                <a:spcPts val="1000"/>
+              </a:spcAft>
+            </a:pPr>
+            <a:r>
+              <a:rPr sz="1150" b="1" i="0">
+                <a:solidFill>
+                  <a:srgbClr val="333333"/>
+                </a:solidFill>
+                <a:latin typeface="Arial"/>
+              </a:rPr>
+              <a:t>•  CRM: </a:t>
+            </a:r>
+            <a:r>
+              <a:rPr sz="1150" b="0" i="0">
+                <a:solidFill>
+                  <a:srgbClr val="333333"/>
+                </a:solidFill>
+                <a:latin typeface="Arial"/>
+              </a:rPr>
+              <a:t>8% of spend, 44% of attributed revenue. Efficient activation of existing buyers — though without a holdout, high-intent audiences inflate its read.</a:t>
+            </a:r>
+          </a:p>
+          <a:p>
+            <a:pPr algn="l">
+              <a:lnSpc>
+                <a:spcPct val="112000"/>
+              </a:lnSpc>
+              <a:spcAft>
+                <a:spcPts val="1000"/>
+              </a:spcAft>
+            </a:pPr>
+            <a:r>
+              <a:rPr sz="1150" b="1" i="0">
+                <a:solidFill>
+                  <a:srgbClr val="333333"/>
+                </a:solidFill>
+                <a:latin typeface="Arial"/>
+              </a:rPr>
+              <a:t>•  Paid social: </a:t>
+            </a:r>
+            <a:r>
+              <a:rPr sz="1150" b="0" i="0">
+                <a:solidFill>
+                  <a:srgbClr val="333333"/>
+                </a:solidFill>
+                <a:latin typeface="Arial"/>
+              </a:rPr>
+              <a:t>59% of spend at 0.3× iROAS — but it acquired 629 of 1,499 new customers (42%) at $147 CAC vs $212 early value. It pays back as acquisition, not immediate revenue; judge it on CAC and LTV.</a:t>
+            </a:r>
+          </a:p>
+          <a:p>
+            <a:pPr algn="l">
+              <a:lnSpc>
+                <a:spcPct val="112000"/>
+              </a:lnSpc>
+              <a:spcAft>
+                <a:spcPts val="1000"/>
+              </a:spcAft>
+            </a:pPr>
+            <a:r>
+              <a:rPr sz="1150" b="1" i="0">
+                <a:solidFill>
+                  <a:srgbClr val="333333"/>
+                </a:solidFill>
+                <a:latin typeface="Arial"/>
+              </a:rPr>
+              <a:t>•  Paid search: </a:t>
+            </a:r>
+            <a:r>
+              <a:rPr sz="1150" b="0" i="0">
+                <a:solidFill>
+                  <a:srgbClr val="333333"/>
+                </a:solidFill>
+                <a:latin typeface="Arial"/>
+              </a:rPr>
+              <a:t>0.9× — strong early flight, efficiency fell as core sizes stocked out while spend kept running.</a:t>
+            </a:r>
+          </a:p>
+          <a:p>
+            <a:pPr algn="l">
+              <a:lnSpc>
+                <a:spcPct val="112000"/>
+              </a:lnSpc>
+              <a:spcAft>
+                <a:spcPts val="1000"/>
+              </a:spcAft>
+            </a:pPr>
+            <a:r>
+              <a:rPr sz="1150" b="1" i="0">
+                <a:solidFill>
+                  <a:srgbClr val="757575"/>
+                </a:solidFill>
+                <a:latin typeface="Arial"/>
+              </a:rPr>
+              <a:t>•  Method: </a:t>
+            </a:r>
+            <a:r>
+              <a:rPr sz="1150" b="0" i="0">
+                <a:solidFill>
+                  <a:srgbClr val="757575"/>
+                </a:solidFill>
+                <a:latin typeface="Arial"/>
+              </a:rPr>
+              <a:t>iROAS = attributed ROAS × 0.31 site-level incrementality factor, applied uniformly (no holdout or geo split this flight). Attributed ROAS: Email 23.2×, SMS 8.3×, Affiliate 4.2×, Search 3.0×, Social 1.0×.</a:t>
+            </a:r>
+          </a:p>
+        </p:txBody>
+      </p:sp>
+      <p:sp>
+        <p:nvSpPr>
+          <p:cNvPr id="7" name="TextBox 6"/>
+          <p:cNvSpPr txBox="1"/>
+          <p:nvPr/>
+        </p:nvSpPr>
+        <p:spPr>
+          <a:xfrm>
+            <a:off x="502920" y="6510528"/>
+            <a:ext cx="10515600" cy="274320"/>
+          </a:xfrm>
+          <a:prstGeom prst="rect">
+            <a:avLst/>
+          </a:prstGeom>
+          <a:noFill/>
+        </p:spPr>
+        <p:txBody>
+          <a:bodyPr wrap="square" lIns="0" tIns="0" rIns="0" bIns="0" anchor="t">
+            <a:spAutoFit/>
+          </a:bodyPr>
+          <a:lstStyle/>
+          <a:p>
+            <a:pPr algn="l"/>
+            <a:r>
+              <a:rPr sz="800" b="0" i="0">
+                <a:solidFill>
+                  <a:srgbClr val="757575"/>
+                </a:solidFill>
+                <a:latin typeface="Arial"/>
+              </a:rPr>
+              <a:t>Salomon NA eCommerce · Vestal Pro launch readout · Illustrative synthetic case data</a:t>
+            </a:r>
+          </a:p>
+        </p:txBody>
+      </p:sp>
+      <p:sp>
+        <p:nvSpPr>
+          <p:cNvPr id="8" name="TextBox 7"/>
+          <p:cNvSpPr txBox="1"/>
+          <p:nvPr/>
+        </p:nvSpPr>
+        <p:spPr>
+          <a:xfrm>
+            <a:off x="11292840" y="6510528"/>
+            <a:ext cx="411480" cy="274320"/>
+          </a:xfrm>
+          <a:prstGeom prst="rect">
+            <a:avLst/>
+          </a:prstGeom>
+          <a:noFill/>
+        </p:spPr>
+        <p:txBody>
+          <a:bodyPr wrap="square" lIns="0" tIns="0" rIns="0" bIns="0" anchor="t">
+            <a:spAutoFit/>
+          </a:bodyPr>
+          <a:lstStyle/>
+          <a:p>
+            <a:pPr algn="r"/>
+            <a:r>
+              <a:rPr sz="800" b="0" i="0">
+                <a:solidFill>
+                  <a:srgbClr val="757575"/>
+                </a:solidFill>
+                <a:latin typeface="Arial"/>
+              </a:rPr>
+              <a:t>10</a:t>
+            </a:r>
+          </a:p>
+        </p:txBody>
+      </p:sp>
+      <p:pic>
+        <p:nvPicPr>
+          <p:cNvPr id="9" name="Picture 8" descr="salomon_wordmark_black.png"/>
+          <p:cNvPicPr>
+            <a:picLocks noChangeAspect="1"/>
+          </p:cNvPicPr>
+          <p:nvPr/>
+        </p:nvPicPr>
+        <p:blipFill>
+          <a:blip r:embed="rId3"/>
+          <a:stretch>
+            <a:fillRect/>
+          </a:stretch>
+        </p:blipFill>
+        <p:spPr>
+          <a:xfrm>
+            <a:off x="10698480" y="292608"/>
+            <a:ext cx="960120" cy="110013"/>
+          </a:xfrm>
+          <a:prstGeom prst="rect">
+            <a:avLst/>
+          </a:prstGeom>
+        </p:spPr>
+      </p:pic>
+    </p:spTree>
+  </p:cSld>
+  <p:clrMapOvr>
+    <a:masterClrMapping/>
+  </p:clrMapOvr>
+</p:sld>
+</file>
+
+<file path=ppt/slides/slide11.xml><?xml version="1.0" encoding="utf-8"?>
 <p:sld xmlns:a="http://schemas.openxmlformats.org/drawingml/2006/main" xmlns:r="http://schemas.openxmlformats.org/officeDocument/2006/relationships" xmlns:p="http://schemas.openxmlformats.org/presentationml/2006/main">
   <p:cSld>
     <p:spTree>
@@ -6289,375 +6226,6 @@
 </p:sld>
 </file>
 
-<file path=ppt/slides/slide11.xml><?xml version="1.0" encoding="utf-8"?>
-<p:sld xmlns:a="http://schemas.openxmlformats.org/drawingml/2006/main" xmlns:r="http://schemas.openxmlformats.org/officeDocument/2006/relationships" xmlns:p="http://schemas.openxmlformats.org/presentationml/2006/main">
-  <p:cSld>
-    <p:spTree>
-      <p:nvGrpSpPr>
-        <p:cNvPr id="1" name=""/>
-        <p:cNvGrpSpPr/>
-        <p:nvPr/>
-      </p:nvGrpSpPr>
-      <p:grpSpPr>
-        <a:xfrm>
-          <a:off x="0" y="0"/>
-          <a:ext cx="0" cy="0"/>
-          <a:chOff x="0" y="0"/>
-          <a:chExt cx="0" cy="0"/>
-        </a:xfrm>
-      </p:grpSpPr>
-      <p:sp>
-        <p:nvSpPr>
-          <p:cNvPr id="2" name="TextBox 1"/>
-          <p:cNvSpPr txBox="1"/>
-          <p:nvPr/>
-        </p:nvSpPr>
-        <p:spPr>
-          <a:xfrm>
-            <a:off x="502920" y="292608"/>
-            <a:ext cx="11155680" cy="274320"/>
-          </a:xfrm>
-          <a:prstGeom prst="rect">
-            <a:avLst/>
-          </a:prstGeom>
-          <a:noFill/>
-        </p:spPr>
-        <p:txBody>
-          <a:bodyPr wrap="square" lIns="0" tIns="0" rIns="0" bIns="0" anchor="t">
-            <a:spAutoFit/>
-          </a:bodyPr>
-          <a:lstStyle/>
-          <a:p>
-            <a:pPr algn="l"/>
-            <a:r>
-              <a:rPr sz="1050" b="1" i="0">
-                <a:solidFill>
-                  <a:srgbClr val="757575"/>
-                </a:solidFill>
-                <a:latin typeface="Arial"/>
-              </a:rPr>
-              <a:t>INVENTORY</a:t>
-            </a:r>
-          </a:p>
-        </p:txBody>
-      </p:sp>
-      <p:sp>
-        <p:nvSpPr>
-          <p:cNvPr id="3" name="TextBox 2"/>
-          <p:cNvSpPr txBox="1"/>
-          <p:nvPr/>
-        </p:nvSpPr>
-        <p:spPr>
-          <a:xfrm>
-            <a:off x="502920" y="566928"/>
-            <a:ext cx="11201400" cy="777240"/>
-          </a:xfrm>
-          <a:prstGeom prst="rect">
-            <a:avLst/>
-          </a:prstGeom>
-          <a:noFill/>
-        </p:spPr>
-        <p:txBody>
-          <a:bodyPr wrap="square" lIns="0" tIns="0" rIns="0" bIns="0" anchor="t">
-            <a:spAutoFit/>
-          </a:bodyPr>
-          <a:lstStyle/>
-          <a:p>
-            <a:pPr algn="l"/>
-            <a:r>
-              <a:rPr sz="2300" b="0" i="0">
-                <a:solidFill>
-                  <a:srgbClr val="000000"/>
-                </a:solidFill>
-                <a:latin typeface="Georgia"/>
-              </a:rPr>
-              <a:t>Core sizes were 44% unavailable by week 6, costing an estimated $20K in demand</a:t>
-            </a:r>
-          </a:p>
-        </p:txBody>
-      </p:sp>
-      <p:sp>
-        <p:nvSpPr>
-          <p:cNvPr id="4" name="TextBox 3"/>
-          <p:cNvSpPr txBox="1"/>
-          <p:nvPr/>
-        </p:nvSpPr>
-        <p:spPr>
-          <a:xfrm>
-            <a:off x="502920" y="1481328"/>
-            <a:ext cx="6035040" cy="274320"/>
-          </a:xfrm>
-          <a:prstGeom prst="rect">
-            <a:avLst/>
-          </a:prstGeom>
-          <a:noFill/>
-        </p:spPr>
-        <p:txBody>
-          <a:bodyPr wrap="square" lIns="0" tIns="0" rIns="0" bIns="0" anchor="t">
-            <a:spAutoFit/>
-          </a:bodyPr>
-          <a:lstStyle/>
-          <a:p>
-            <a:pPr algn="l"/>
-            <a:r>
-              <a:rPr sz="1000" b="1" i="0">
-                <a:solidFill>
-                  <a:srgbClr val="757575"/>
-                </a:solidFill>
-                <a:latin typeface="Arial"/>
-              </a:rPr>
-              <a:t>VESTAL PRO AVAILABILITY BY CAMPAIGN WEEK</a:t>
-            </a:r>
-          </a:p>
-        </p:txBody>
-      </p:sp>
-      <p:graphicFrame>
-        <p:nvGraphicFramePr>
-          <p:cNvPr id="5" name="Chart 4"/>
-          <p:cNvGraphicFramePr>
-            <a:graphicFrameLocks noGrp="1"/>
-          </p:cNvGraphicFramePr>
-          <p:nvPr/>
-        </p:nvGraphicFramePr>
-        <p:xfrm>
-          <a:off x="365760" y="1828800"/>
-          <a:ext cx="6309360" cy="3977639"/>
-        </p:xfrm>
-        <a:graphic>
-          <a:graphicData uri="http://schemas.openxmlformats.org/drawingml/2006/chart">
-            <c:chart xmlns:c="http://schemas.openxmlformats.org/drawingml/2006/chart" xmlns:r="http://schemas.openxmlformats.org/officeDocument/2006/relationships" r:id="rId2"/>
-          </a:graphicData>
-        </a:graphic>
-      </p:graphicFrame>
-      <p:sp>
-        <p:nvSpPr>
-          <p:cNvPr id="6" name="TextBox 5"/>
-          <p:cNvSpPr txBox="1"/>
-          <p:nvPr/>
-        </p:nvSpPr>
-        <p:spPr>
-          <a:xfrm>
-            <a:off x="7086600" y="1600200"/>
-            <a:ext cx="4572000" cy="4480560"/>
-          </a:xfrm>
-          <a:prstGeom prst="rect">
-            <a:avLst/>
-          </a:prstGeom>
-          <a:noFill/>
-        </p:spPr>
-        <p:txBody>
-          <a:bodyPr wrap="square" lIns="0" tIns="0" rIns="0" bIns="0" anchor="t">
-            <a:spAutoFit/>
-          </a:bodyPr>
-          <a:lstStyle/>
-          <a:p>
-            <a:pPr algn="l">
-              <a:lnSpc>
-                <a:spcPct val="112000"/>
-              </a:lnSpc>
-              <a:spcAft>
-                <a:spcPts val="1000"/>
-              </a:spcAft>
-            </a:pPr>
-            <a:r>
-              <a:rPr sz="1150" b="1" i="0">
-                <a:solidFill>
-                  <a:srgbClr val="333333"/>
-                </a:solidFill>
-                <a:latin typeface="Arial"/>
-              </a:rPr>
-              <a:t>•  Depletion, not demand, ended the flight: </a:t>
-            </a:r>
-            <a:r>
-              <a:rPr sz="1150" b="0" i="0">
-                <a:solidFill>
-                  <a:srgbClr val="333333"/>
-                </a:solidFill>
-                <a:latin typeface="Arial"/>
-              </a:rPr>
-              <a:t>core sizes (M9–11, W7–9) fell below 90% in week 3 and hit 56% by week 6.</a:t>
-            </a:r>
-          </a:p>
-          <a:p>
-            <a:pPr algn="l">
-              <a:lnSpc>
-                <a:spcPct val="112000"/>
-              </a:lnSpc>
-              <a:spcAft>
-                <a:spcPts val="1000"/>
-              </a:spcAft>
-            </a:pPr>
-            <a:r>
-              <a:rPr sz="1150" b="0" i="0">
-                <a:solidFill>
-                  <a:srgbClr val="333333"/>
-                </a:solidFill>
-                <a:latin typeface="Arial"/>
-              </a:rPr>
-              <a:t>•  Vestal Pro sell-through conversion fell 35% (5.2% weeks 1–3 → 3.4% week 6) while paid media kept sending traffic.</a:t>
-            </a:r>
-          </a:p>
-          <a:p>
-            <a:pPr algn="l">
-              <a:lnSpc>
-                <a:spcPct val="112000"/>
-              </a:lnSpc>
-              <a:spcAft>
-                <a:spcPts val="1000"/>
-              </a:spcAft>
-            </a:pPr>
-            <a:r>
-              <a:rPr sz="1150" b="0" i="0">
-                <a:solidFill>
-                  <a:srgbClr val="333333"/>
-                </a:solidFill>
-                <a:latin typeface="Arial"/>
-              </a:rPr>
-              <a:t>•  Modeled unmet demand: ≈140 units, ≈$20.4K, from applying early-flight conversion to weeks 4–6 traffic.</a:t>
-            </a:r>
-          </a:p>
-          <a:p>
-            <a:pPr algn="l">
-              <a:lnSpc>
-                <a:spcPct val="112000"/>
-              </a:lnSpc>
-              <a:spcAft>
-                <a:spcPts val="1000"/>
-              </a:spcAft>
-            </a:pPr>
-            <a:r>
-              <a:rPr sz="1150" b="0" i="0">
-                <a:solidFill>
-                  <a:srgbClr val="333333"/>
-                </a:solidFill>
-                <a:latin typeface="Arial"/>
-              </a:rPr>
-              <a:t>•  Site conversion followed: 2.52% week 1 → 2.23% week 6, below the 2.33% pre-period average.</a:t>
-            </a:r>
-          </a:p>
-          <a:p>
-            <a:pPr algn="l">
-              <a:lnSpc>
-                <a:spcPct val="112000"/>
-              </a:lnSpc>
-              <a:spcAft>
-                <a:spcPts val="1000"/>
-              </a:spcAft>
-            </a:pPr>
-            <a:r>
-              <a:rPr sz="1150" b="0" i="0">
-                <a:solidFill>
-                  <a:srgbClr val="333333"/>
-                </a:solidFill>
-                <a:latin typeface="Arial"/>
-              </a:rPr>
-              <a:t>•  Speedcross picked up +14% units as shoppers substituted — a partial, lower-price offset.</a:t>
-            </a:r>
-          </a:p>
-        </p:txBody>
-      </p:sp>
-      <p:sp>
-        <p:nvSpPr>
-          <p:cNvPr id="7" name="TextBox 6"/>
-          <p:cNvSpPr txBox="1"/>
-          <p:nvPr/>
-        </p:nvSpPr>
-        <p:spPr>
-          <a:xfrm>
-            <a:off x="502920" y="6510528"/>
-            <a:ext cx="10515600" cy="274320"/>
-          </a:xfrm>
-          <a:prstGeom prst="rect">
-            <a:avLst/>
-          </a:prstGeom>
-          <a:noFill/>
-        </p:spPr>
-        <p:txBody>
-          <a:bodyPr wrap="square" lIns="0" tIns="0" rIns="0" bIns="0" anchor="t">
-            <a:spAutoFit/>
-          </a:bodyPr>
-          <a:lstStyle/>
-          <a:p>
-            <a:pPr algn="l"/>
-            <a:r>
-              <a:rPr sz="800" b="0" i="0">
-                <a:solidFill>
-                  <a:srgbClr val="757575"/>
-                </a:solidFill>
-                <a:latin typeface="Arial"/>
-              </a:rPr>
-              <a:t>Salomon NA eCommerce · Vestal Pro launch readout · Illustrative synthetic case data</a:t>
-            </a:r>
-          </a:p>
-        </p:txBody>
-      </p:sp>
-      <p:sp>
-        <p:nvSpPr>
-          <p:cNvPr id="8" name="TextBox 7"/>
-          <p:cNvSpPr txBox="1"/>
-          <p:nvPr/>
-        </p:nvSpPr>
-        <p:spPr>
-          <a:xfrm>
-            <a:off x="11292840" y="6510528"/>
-            <a:ext cx="411480" cy="274320"/>
-          </a:xfrm>
-          <a:prstGeom prst="rect">
-            <a:avLst/>
-          </a:prstGeom>
-          <a:noFill/>
-        </p:spPr>
-        <p:txBody>
-          <a:bodyPr wrap="square" lIns="0" tIns="0" rIns="0" bIns="0" anchor="t">
-            <a:spAutoFit/>
-          </a:bodyPr>
-          <a:lstStyle/>
-          <a:p>
-            <a:pPr algn="r"/>
-            <a:r>
-              <a:rPr sz="800" b="0" i="0">
-                <a:solidFill>
-                  <a:srgbClr val="757575"/>
-                </a:solidFill>
-                <a:latin typeface="Arial"/>
-              </a:rPr>
-              <a:t>12</a:t>
-            </a:r>
-          </a:p>
-        </p:txBody>
-      </p:sp>
-      <p:pic>
-        <p:nvPicPr>
-          <p:cNvPr id="9" name="Picture 8" descr="salomon_wordmark_black.png"/>
-          <p:cNvPicPr>
-            <a:picLocks noChangeAspect="1"/>
-          </p:cNvPicPr>
-          <p:nvPr/>
-        </p:nvPicPr>
-        <p:blipFill>
-          <a:blip r:embed="rId3"/>
-          <a:stretch>
-            <a:fillRect/>
-          </a:stretch>
-        </p:blipFill>
-        <p:spPr>
-          <a:xfrm>
-            <a:off x="10698480" y="292608"/>
-            <a:ext cx="960120" cy="110013"/>
-          </a:xfrm>
-          <a:prstGeom prst="rect">
-            <a:avLst/>
-          </a:prstGeom>
-        </p:spPr>
-      </p:pic>
-    </p:spTree>
-  </p:cSld>
-  <p:clrMapOvr>
-    <a:masterClrMapping/>
-  </p:clrMapOvr>
-</p:sld>
-</file>
-
 <file path=ppt/slides/slide12.xml><?xml version="1.0" encoding="utf-8"?>
 <p:sld xmlns:a="http://schemas.openxmlformats.org/drawingml/2006/main" xmlns:r="http://schemas.openxmlformats.org/officeDocument/2006/relationships" xmlns:p="http://schemas.openxmlformats.org/presentationml/2006/main">
   <p:cSld>
@@ -6677,6 +6245,375 @@
       </p:grpSpPr>
       <p:sp>
         <p:nvSpPr>
+          <p:cNvPr id="2" name="TextBox 1"/>
+          <p:cNvSpPr txBox="1"/>
+          <p:nvPr/>
+        </p:nvSpPr>
+        <p:spPr>
+          <a:xfrm>
+            <a:off x="502920" y="292608"/>
+            <a:ext cx="11155680" cy="274320"/>
+          </a:xfrm>
+          <a:prstGeom prst="rect">
+            <a:avLst/>
+          </a:prstGeom>
+          <a:noFill/>
+        </p:spPr>
+        <p:txBody>
+          <a:bodyPr wrap="square" lIns="0" tIns="0" rIns="0" bIns="0" anchor="t">
+            <a:spAutoFit/>
+          </a:bodyPr>
+          <a:lstStyle/>
+          <a:p>
+            <a:pPr algn="l"/>
+            <a:r>
+              <a:rPr sz="1050" b="1" i="0">
+                <a:solidFill>
+                  <a:srgbClr val="757575"/>
+                </a:solidFill>
+                <a:latin typeface="Arial"/>
+              </a:rPr>
+              <a:t>INVENTORY</a:t>
+            </a:r>
+          </a:p>
+        </p:txBody>
+      </p:sp>
+      <p:sp>
+        <p:nvSpPr>
+          <p:cNvPr id="3" name="TextBox 2"/>
+          <p:cNvSpPr txBox="1"/>
+          <p:nvPr/>
+        </p:nvSpPr>
+        <p:spPr>
+          <a:xfrm>
+            <a:off x="502920" y="566928"/>
+            <a:ext cx="11201400" cy="777240"/>
+          </a:xfrm>
+          <a:prstGeom prst="rect">
+            <a:avLst/>
+          </a:prstGeom>
+          <a:noFill/>
+        </p:spPr>
+        <p:txBody>
+          <a:bodyPr wrap="square" lIns="0" tIns="0" rIns="0" bIns="0" anchor="t">
+            <a:spAutoFit/>
+          </a:bodyPr>
+          <a:lstStyle/>
+          <a:p>
+            <a:pPr algn="l"/>
+            <a:r>
+              <a:rPr sz="2300" b="0" i="0">
+                <a:solidFill>
+                  <a:srgbClr val="000000"/>
+                </a:solidFill>
+                <a:latin typeface="Georgia"/>
+              </a:rPr>
+              <a:t>Core sizes were 44% unavailable by week 6, costing an estimated $20K in demand</a:t>
+            </a:r>
+          </a:p>
+        </p:txBody>
+      </p:sp>
+      <p:sp>
+        <p:nvSpPr>
+          <p:cNvPr id="4" name="TextBox 3"/>
+          <p:cNvSpPr txBox="1"/>
+          <p:nvPr/>
+        </p:nvSpPr>
+        <p:spPr>
+          <a:xfrm>
+            <a:off x="502920" y="1481328"/>
+            <a:ext cx="6035040" cy="274320"/>
+          </a:xfrm>
+          <a:prstGeom prst="rect">
+            <a:avLst/>
+          </a:prstGeom>
+          <a:noFill/>
+        </p:spPr>
+        <p:txBody>
+          <a:bodyPr wrap="square" lIns="0" tIns="0" rIns="0" bIns="0" anchor="t">
+            <a:spAutoFit/>
+          </a:bodyPr>
+          <a:lstStyle/>
+          <a:p>
+            <a:pPr algn="l"/>
+            <a:r>
+              <a:rPr sz="1000" b="1" i="0">
+                <a:solidFill>
+                  <a:srgbClr val="757575"/>
+                </a:solidFill>
+                <a:latin typeface="Arial"/>
+              </a:rPr>
+              <a:t>VESTAL PRO AVAILABILITY BY CAMPAIGN WEEK</a:t>
+            </a:r>
+          </a:p>
+        </p:txBody>
+      </p:sp>
+      <p:graphicFrame>
+        <p:nvGraphicFramePr>
+          <p:cNvPr id="5" name="Chart 4"/>
+          <p:cNvGraphicFramePr>
+            <a:graphicFrameLocks noGrp="1"/>
+          </p:cNvGraphicFramePr>
+          <p:nvPr/>
+        </p:nvGraphicFramePr>
+        <p:xfrm>
+          <a:off x="365760" y="1828800"/>
+          <a:ext cx="6309360" cy="3977639"/>
+        </p:xfrm>
+        <a:graphic>
+          <a:graphicData uri="http://schemas.openxmlformats.org/drawingml/2006/chart">
+            <c:chart xmlns:c="http://schemas.openxmlformats.org/drawingml/2006/chart" xmlns:r="http://schemas.openxmlformats.org/officeDocument/2006/relationships" r:id="rId2"/>
+          </a:graphicData>
+        </a:graphic>
+      </p:graphicFrame>
+      <p:sp>
+        <p:nvSpPr>
+          <p:cNvPr id="6" name="TextBox 5"/>
+          <p:cNvSpPr txBox="1"/>
+          <p:nvPr/>
+        </p:nvSpPr>
+        <p:spPr>
+          <a:xfrm>
+            <a:off x="7086600" y="1600200"/>
+            <a:ext cx="4572000" cy="4480560"/>
+          </a:xfrm>
+          <a:prstGeom prst="rect">
+            <a:avLst/>
+          </a:prstGeom>
+          <a:noFill/>
+        </p:spPr>
+        <p:txBody>
+          <a:bodyPr wrap="square" lIns="0" tIns="0" rIns="0" bIns="0" anchor="t">
+            <a:spAutoFit/>
+          </a:bodyPr>
+          <a:lstStyle/>
+          <a:p>
+            <a:pPr algn="l">
+              <a:lnSpc>
+                <a:spcPct val="112000"/>
+              </a:lnSpc>
+              <a:spcAft>
+                <a:spcPts val="1000"/>
+              </a:spcAft>
+            </a:pPr>
+            <a:r>
+              <a:rPr sz="1150" b="1" i="0">
+                <a:solidFill>
+                  <a:srgbClr val="333333"/>
+                </a:solidFill>
+                <a:latin typeface="Arial"/>
+              </a:rPr>
+              <a:t>•  Depletion, not demand, ended the flight: </a:t>
+            </a:r>
+            <a:r>
+              <a:rPr sz="1150" b="0" i="0">
+                <a:solidFill>
+                  <a:srgbClr val="333333"/>
+                </a:solidFill>
+                <a:latin typeface="Arial"/>
+              </a:rPr>
+              <a:t>core sizes (M9–11, W7–9) fell below 90% in week 3 and hit 56% by week 6.</a:t>
+            </a:r>
+          </a:p>
+          <a:p>
+            <a:pPr algn="l">
+              <a:lnSpc>
+                <a:spcPct val="112000"/>
+              </a:lnSpc>
+              <a:spcAft>
+                <a:spcPts val="1000"/>
+              </a:spcAft>
+            </a:pPr>
+            <a:r>
+              <a:rPr sz="1150" b="0" i="0">
+                <a:solidFill>
+                  <a:srgbClr val="333333"/>
+                </a:solidFill>
+                <a:latin typeface="Arial"/>
+              </a:rPr>
+              <a:t>•  Vestal Pro sell-through conversion fell 35% (5.2% weeks 1–3 → 3.4% week 6) while paid media kept sending traffic.</a:t>
+            </a:r>
+          </a:p>
+          <a:p>
+            <a:pPr algn="l">
+              <a:lnSpc>
+                <a:spcPct val="112000"/>
+              </a:lnSpc>
+              <a:spcAft>
+                <a:spcPts val="1000"/>
+              </a:spcAft>
+            </a:pPr>
+            <a:r>
+              <a:rPr sz="1150" b="0" i="0">
+                <a:solidFill>
+                  <a:srgbClr val="333333"/>
+                </a:solidFill>
+                <a:latin typeface="Arial"/>
+              </a:rPr>
+              <a:t>•  Modeled unmet demand: ≈140 units, ≈$20.4K, from applying early-flight conversion to weeks 4–6 traffic.</a:t>
+            </a:r>
+          </a:p>
+          <a:p>
+            <a:pPr algn="l">
+              <a:lnSpc>
+                <a:spcPct val="112000"/>
+              </a:lnSpc>
+              <a:spcAft>
+                <a:spcPts val="1000"/>
+              </a:spcAft>
+            </a:pPr>
+            <a:r>
+              <a:rPr sz="1150" b="0" i="0">
+                <a:solidFill>
+                  <a:srgbClr val="333333"/>
+                </a:solidFill>
+                <a:latin typeface="Arial"/>
+              </a:rPr>
+              <a:t>•  Site conversion followed: 2.52% week 1 → 2.23% week 6, below the 2.33% pre-period average.</a:t>
+            </a:r>
+          </a:p>
+          <a:p>
+            <a:pPr algn="l">
+              <a:lnSpc>
+                <a:spcPct val="112000"/>
+              </a:lnSpc>
+              <a:spcAft>
+                <a:spcPts val="1000"/>
+              </a:spcAft>
+            </a:pPr>
+            <a:r>
+              <a:rPr sz="1150" b="0" i="0">
+                <a:solidFill>
+                  <a:srgbClr val="333333"/>
+                </a:solidFill>
+                <a:latin typeface="Arial"/>
+              </a:rPr>
+              <a:t>•  Speedcross picked up +14% units as shoppers substituted — a partial, lower-price offset.</a:t>
+            </a:r>
+          </a:p>
+        </p:txBody>
+      </p:sp>
+      <p:sp>
+        <p:nvSpPr>
+          <p:cNvPr id="7" name="TextBox 6"/>
+          <p:cNvSpPr txBox="1"/>
+          <p:nvPr/>
+        </p:nvSpPr>
+        <p:spPr>
+          <a:xfrm>
+            <a:off x="502920" y="6510528"/>
+            <a:ext cx="10515600" cy="274320"/>
+          </a:xfrm>
+          <a:prstGeom prst="rect">
+            <a:avLst/>
+          </a:prstGeom>
+          <a:noFill/>
+        </p:spPr>
+        <p:txBody>
+          <a:bodyPr wrap="square" lIns="0" tIns="0" rIns="0" bIns="0" anchor="t">
+            <a:spAutoFit/>
+          </a:bodyPr>
+          <a:lstStyle/>
+          <a:p>
+            <a:pPr algn="l"/>
+            <a:r>
+              <a:rPr sz="800" b="0" i="0">
+                <a:solidFill>
+                  <a:srgbClr val="757575"/>
+                </a:solidFill>
+                <a:latin typeface="Arial"/>
+              </a:rPr>
+              <a:t>Salomon NA eCommerce · Vestal Pro launch readout · Illustrative synthetic case data</a:t>
+            </a:r>
+          </a:p>
+        </p:txBody>
+      </p:sp>
+      <p:sp>
+        <p:nvSpPr>
+          <p:cNvPr id="8" name="TextBox 7"/>
+          <p:cNvSpPr txBox="1"/>
+          <p:nvPr/>
+        </p:nvSpPr>
+        <p:spPr>
+          <a:xfrm>
+            <a:off x="11292840" y="6510528"/>
+            <a:ext cx="411480" cy="274320"/>
+          </a:xfrm>
+          <a:prstGeom prst="rect">
+            <a:avLst/>
+          </a:prstGeom>
+          <a:noFill/>
+        </p:spPr>
+        <p:txBody>
+          <a:bodyPr wrap="square" lIns="0" tIns="0" rIns="0" bIns="0" anchor="t">
+            <a:spAutoFit/>
+          </a:bodyPr>
+          <a:lstStyle/>
+          <a:p>
+            <a:pPr algn="r"/>
+            <a:r>
+              <a:rPr sz="800" b="0" i="0">
+                <a:solidFill>
+                  <a:srgbClr val="757575"/>
+                </a:solidFill>
+                <a:latin typeface="Arial"/>
+              </a:rPr>
+              <a:t>12</a:t>
+            </a:r>
+          </a:p>
+        </p:txBody>
+      </p:sp>
+      <p:pic>
+        <p:nvPicPr>
+          <p:cNvPr id="9" name="Picture 8" descr="salomon_wordmark_black.png"/>
+          <p:cNvPicPr>
+            <a:picLocks noChangeAspect="1"/>
+          </p:cNvPicPr>
+          <p:nvPr/>
+        </p:nvPicPr>
+        <p:blipFill>
+          <a:blip r:embed="rId3"/>
+          <a:stretch>
+            <a:fillRect/>
+          </a:stretch>
+        </p:blipFill>
+        <p:spPr>
+          <a:xfrm>
+            <a:off x="10698480" y="292608"/>
+            <a:ext cx="960120" cy="110013"/>
+          </a:xfrm>
+          <a:prstGeom prst="rect">
+            <a:avLst/>
+          </a:prstGeom>
+        </p:spPr>
+      </p:pic>
+    </p:spTree>
+  </p:cSld>
+  <p:clrMapOvr>
+    <a:masterClrMapping/>
+  </p:clrMapOvr>
+</p:sld>
+</file>
+
+<file path=ppt/slides/slide13.xml><?xml version="1.0" encoding="utf-8"?>
+<p:sld xmlns:a="http://schemas.openxmlformats.org/drawingml/2006/main" xmlns:r="http://schemas.openxmlformats.org/officeDocument/2006/relationships" xmlns:p="http://schemas.openxmlformats.org/presentationml/2006/main">
+  <p:cSld>
+    <p:spTree>
+      <p:nvGrpSpPr>
+        <p:cNvPr id="1" name=""/>
+        <p:cNvGrpSpPr/>
+        <p:nvPr/>
+      </p:nvGrpSpPr>
+      <p:grpSpPr>
+        <a:xfrm>
+          <a:off x="0" y="0"/>
+          <a:ext cx="0" cy="0"/>
+          <a:chOff x="0" y="0"/>
+          <a:chExt cx="0" cy="0"/>
+        </a:xfrm>
+      </p:grpSpPr>
+      <p:sp>
+        <p:nvSpPr>
           <p:cNvPr id="2" name="Rectangle 1"/>
           <p:cNvSpPr/>
           <p:nvPr/>
@@ -7355,7 +7292,267 @@
 </p:sld>
 </file>
 
-<file path=ppt/slides/slide13.xml><?xml version="1.0" encoding="utf-8"?>
+<file path=ppt/slides/slide14.xml><?xml version="1.0" encoding="utf-8"?>
+<p:sld xmlns:a="http://schemas.openxmlformats.org/drawingml/2006/main" xmlns:r="http://schemas.openxmlformats.org/officeDocument/2006/relationships" xmlns:p="http://schemas.openxmlformats.org/presentationml/2006/main">
+  <p:cSld>
+    <p:spTree>
+      <p:nvGrpSpPr>
+        <p:cNvPr id="1" name="">
+          <a:extLst>
+            <a:ext uri="{FF2B5EF4-FFF2-40B4-BE49-F238E27FC236}">
+              <a16:creationId xmlns:a16="http://schemas.microsoft.com/office/drawing/2014/main" id="{3A7BD774-5215-56D0-5E2D-5BEB935C20F4}"/>
+            </a:ext>
+          </a:extLst>
+        </p:cNvPr>
+        <p:cNvGrpSpPr/>
+        <p:nvPr/>
+      </p:nvGrpSpPr>
+      <p:grpSpPr>
+        <a:xfrm>
+          <a:off x="0" y="0"/>
+          <a:ext cx="0" cy="0"/>
+          <a:chOff x="0" y="0"/>
+          <a:chExt cx="0" cy="0"/>
+        </a:xfrm>
+      </p:grpSpPr>
+      <p:sp>
+        <p:nvSpPr>
+          <p:cNvPr id="2" name="Rectangle 1">
+            <a:extLst>
+              <a:ext uri="{FF2B5EF4-FFF2-40B4-BE49-F238E27FC236}">
+                <a16:creationId xmlns:a16="http://schemas.microsoft.com/office/drawing/2014/main" id="{2F2B0E74-D5E6-28E0-4424-F20FC2FD1565}"/>
+              </a:ext>
+            </a:extLst>
+          </p:cNvPr>
+          <p:cNvSpPr/>
+          <p:nvPr/>
+        </p:nvSpPr>
+        <p:spPr>
+          <a:xfrm>
+            <a:off x="0" y="0"/>
+            <a:ext cx="12191695" cy="6858000"/>
+          </a:xfrm>
+          <a:prstGeom prst="rect">
+            <a:avLst/>
+          </a:prstGeom>
+          <a:solidFill>
+            <a:srgbClr val="000000"/>
+          </a:solidFill>
+          <a:ln>
+            <a:noFill/>
+          </a:ln>
+          <a:effectLst/>
+        </p:spPr>
+        <p:style>
+          <a:lnRef idx="1">
+            <a:schemeClr val="accent1"/>
+          </a:lnRef>
+          <a:fillRef idx="3">
+            <a:schemeClr val="accent1"/>
+          </a:fillRef>
+          <a:effectRef idx="2">
+            <a:schemeClr val="accent1"/>
+          </a:effectRef>
+          <a:fontRef idx="minor">
+            <a:schemeClr val="lt1"/>
+          </a:fontRef>
+        </p:style>
+        <p:txBody>
+          <a:bodyPr rtlCol="0" anchor="ctr"/>
+          <a:lstStyle/>
+          <a:p>
+            <a:pPr algn="ctr"/>
+            <a:endParaRPr/>
+          </a:p>
+        </p:txBody>
+      </p:sp>
+      <p:sp>
+        <p:nvSpPr>
+          <p:cNvPr id="3" name="TextBox 2">
+            <a:extLst>
+              <a:ext uri="{FF2B5EF4-FFF2-40B4-BE49-F238E27FC236}">
+                <a16:creationId xmlns:a16="http://schemas.microsoft.com/office/drawing/2014/main" id="{02588DE6-B55D-C61B-F685-4F509F0716EE}"/>
+              </a:ext>
+            </a:extLst>
+          </p:cNvPr>
+          <p:cNvSpPr txBox="1"/>
+          <p:nvPr/>
+        </p:nvSpPr>
+        <p:spPr>
+          <a:xfrm>
+            <a:off x="822960" y="1965960"/>
+            <a:ext cx="10515600" cy="1354217"/>
+          </a:xfrm>
+          <a:prstGeom prst="rect">
+            <a:avLst/>
+          </a:prstGeom>
+          <a:noFill/>
+        </p:spPr>
+        <p:txBody>
+          <a:bodyPr wrap="square" lIns="0" tIns="0" rIns="0" bIns="0" anchor="t">
+            <a:spAutoFit/>
+          </a:bodyPr>
+          <a:lstStyle/>
+          <a:p>
+            <a:pPr algn="l"/>
+            <a:r>
+              <a:rPr lang="en-US" sz="4400" dirty="0">
+                <a:solidFill>
+                  <a:srgbClr val="FFFFFF"/>
+                </a:solidFill>
+                <a:latin typeface="Georgia"/>
+              </a:rPr>
+              <a:t>THANK YOU</a:t>
+            </a:r>
+          </a:p>
+          <a:p>
+            <a:pPr algn="l"/>
+            <a:r>
+              <a:rPr lang="en-US" sz="4400" b="0" i="0" dirty="0">
+                <a:solidFill>
+                  <a:srgbClr val="FFFFFF"/>
+                </a:solidFill>
+                <a:latin typeface="Georgia"/>
+              </a:rPr>
+              <a:t>MERCI</a:t>
+            </a:r>
+            <a:endParaRPr sz="4400" b="0" i="0" dirty="0">
+              <a:solidFill>
+                <a:srgbClr val="FFFFFF"/>
+              </a:solidFill>
+              <a:latin typeface="Georgia"/>
+            </a:endParaRPr>
+          </a:p>
+        </p:txBody>
+      </p:sp>
+      <p:sp>
+        <p:nvSpPr>
+          <p:cNvPr id="6" name="TextBox 5">
+            <a:extLst>
+              <a:ext uri="{FF2B5EF4-FFF2-40B4-BE49-F238E27FC236}">
+                <a16:creationId xmlns:a16="http://schemas.microsoft.com/office/drawing/2014/main" id="{AF312117-B385-77DE-78A5-DC270890AC11}"/>
+              </a:ext>
+            </a:extLst>
+          </p:cNvPr>
+          <p:cNvSpPr txBox="1"/>
+          <p:nvPr/>
+        </p:nvSpPr>
+        <p:spPr>
+          <a:xfrm>
+            <a:off x="822960" y="6080760"/>
+            <a:ext cx="10515600" cy="153888"/>
+          </a:xfrm>
+          <a:prstGeom prst="rect">
+            <a:avLst/>
+          </a:prstGeom>
+          <a:noFill/>
+        </p:spPr>
+        <p:txBody>
+          <a:bodyPr wrap="square" lIns="0" tIns="0" rIns="0" bIns="0" anchor="t">
+            <a:spAutoFit/>
+          </a:bodyPr>
+          <a:lstStyle/>
+          <a:p>
+            <a:pPr algn="l"/>
+            <a:r>
+              <a:rPr sz="1000" b="0" i="0" dirty="0">
+                <a:solidFill>
+                  <a:srgbClr val="757575"/>
+                </a:solidFill>
+                <a:latin typeface="Arial"/>
+              </a:rPr>
+              <a:t>Marketing Insights &amp; Analytics</a:t>
+            </a:r>
+          </a:p>
+        </p:txBody>
+      </p:sp>
+      <p:pic>
+        <p:nvPicPr>
+          <p:cNvPr id="7" name="Picture 6" descr="salomon_wordmark_white.png">
+            <a:extLst>
+              <a:ext uri="{FF2B5EF4-FFF2-40B4-BE49-F238E27FC236}">
+                <a16:creationId xmlns:a16="http://schemas.microsoft.com/office/drawing/2014/main" id="{4137F25F-3223-1AA1-5222-9B0CA75E764B}"/>
+              </a:ext>
+            </a:extLst>
+          </p:cNvPr>
+          <p:cNvPicPr>
+            <a:picLocks noChangeAspect="1"/>
+          </p:cNvPicPr>
+          <p:nvPr/>
+        </p:nvPicPr>
+        <p:blipFill>
+          <a:blip r:embed="rId2"/>
+          <a:stretch>
+            <a:fillRect/>
+          </a:stretch>
+        </p:blipFill>
+        <p:spPr>
+          <a:xfrm>
+            <a:off x="822960" y="900000"/>
+            <a:ext cx="2560320" cy="293370"/>
+          </a:xfrm>
+          <a:prstGeom prst="rect">
+            <a:avLst/>
+          </a:prstGeom>
+        </p:spPr>
+      </p:pic>
+      <p:pic>
+        <p:nvPicPr>
+          <p:cNvPr id="5" name="Picture 4" descr="The image shows a steep, rocky mountain side under a cloudy sky.&#10;&#10;AI-generated content may be incorrect.">
+            <a:extLst>
+              <a:ext uri="{FF2B5EF4-FFF2-40B4-BE49-F238E27FC236}">
+                <a16:creationId xmlns:a16="http://schemas.microsoft.com/office/drawing/2014/main" id="{5D256C6D-8464-4352-96C6-EE210AA6C53C}"/>
+              </a:ext>
+            </a:extLst>
+          </p:cNvPr>
+          <p:cNvPicPr>
+            <a:picLocks noChangeAspect="1"/>
+          </p:cNvPicPr>
+          <p:nvPr/>
+        </p:nvPicPr>
+        <p:blipFill>
+          <a:blip r:embed="rId3">
+            <a:alphaModFix amt="50000"/>
+            <a:extLst>
+              <a:ext uri="{BEBA8EAE-BF5A-486C-A8C5-ECC9F3942E4B}">
+                <a14:imgProps xmlns:a14="http://schemas.microsoft.com/office/drawing/2010/main">
+                  <a14:imgLayer r:embed="rId4">
+                    <a14:imgEffect>
+                      <a14:saturation sat="0"/>
+                    </a14:imgEffect>
+                  </a14:imgLayer>
+                </a14:imgProps>
+              </a:ext>
+            </a:extLst>
+          </a:blip>
+          <a:stretch>
+            <a:fillRect/>
+          </a:stretch>
+        </p:blipFill>
+        <p:spPr>
+          <a:xfrm>
+            <a:off x="-64851" y="0"/>
+            <a:ext cx="13452826" cy="7953983"/>
+          </a:xfrm>
+          <a:prstGeom prst="rect">
+            <a:avLst/>
+          </a:prstGeom>
+        </p:spPr>
+      </p:pic>
+    </p:spTree>
+    <p:extLst>
+      <p:ext uri="{BB962C8B-B14F-4D97-AF65-F5344CB8AC3E}">
+        <p14:creationId xmlns:p14="http://schemas.microsoft.com/office/powerpoint/2010/main" val="1247451091"/>
+      </p:ext>
+    </p:extLst>
+  </p:cSld>
+  <p:clrMapOvr>
+    <a:masterClrMapping/>
+  </p:clrMapOvr>
+</p:sld>
+</file>
+
+<file path=ppt/slides/slide15.xml><?xml version="1.0" encoding="utf-8"?>
 <p:sld xmlns:a="http://schemas.openxmlformats.org/drawingml/2006/main" xmlns:r="http://schemas.openxmlformats.org/officeDocument/2006/relationships" xmlns:p="http://schemas.openxmlformats.org/presentationml/2006/main">
   <p:cSld>
     <p:spTree>
@@ -7560,7 +7757,7 @@
 </p:sld>
 </file>
 
-<file path=ppt/slides/slide14.xml><?xml version="1.0" encoding="utf-8"?>
+<file path=ppt/slides/slide16.xml><?xml version="1.0" encoding="utf-8"?>
 <p:sld xmlns:a="http://schemas.openxmlformats.org/drawingml/2006/main" xmlns:r="http://schemas.openxmlformats.org/officeDocument/2006/relationships" xmlns:p="http://schemas.openxmlformats.org/presentationml/2006/main">
   <p:cSld>
     <p:spTree>
@@ -13224,7 +13421,7 @@
         <p:spPr>
           <a:xfrm>
             <a:off x="502920" y="566928"/>
-            <a:ext cx="11201400" cy="777240"/>
+            <a:ext cx="11201400" cy="353943"/>
           </a:xfrm>
           <a:prstGeom prst="rect">
             <a:avLst/>
@@ -13239,27 +13436,81 @@
           <a:p>
             <a:pPr algn="l"/>
             <a:r>
-              <a:rPr sz="2300" b="0" i="0">
+              <a:rPr sz="2300" b="0" i="0" dirty="0">
                 <a:solidFill>
                   <a:srgbClr val="000000"/>
                 </a:solidFill>
                 <a:latin typeface="Georgia"/>
               </a:rPr>
-              <a:t>44% of Vestal Pro buyers were new to Salomon, acquired at half their early value</a:t>
-            </a:r>
-          </a:p>
-        </p:txBody>
-      </p:sp>
-      <p:sp>
-        <p:nvSpPr>
-          <p:cNvPr id="4" name="TextBox 3"/>
+              <a:t>4</a:t>
+            </a:r>
+            <a:r>
+              <a:rPr lang="en-US" sz="2300" b="0" i="0" dirty="0">
+                <a:solidFill>
+                  <a:srgbClr val="000000"/>
+                </a:solidFill>
+                <a:latin typeface="Georgia"/>
+              </a:rPr>
+              <a:t>0</a:t>
+            </a:r>
+            <a:r>
+              <a:rPr sz="2300" b="0" i="0" dirty="0">
+                <a:solidFill>
+                  <a:srgbClr val="000000"/>
+                </a:solidFill>
+                <a:latin typeface="Georgia"/>
+              </a:rPr>
+              <a:t>% of Vestal Pro </a:t>
+            </a:r>
+            <a:r>
+              <a:rPr lang="en-US" sz="2300" b="0" i="0" dirty="0">
+                <a:solidFill>
+                  <a:srgbClr val="000000"/>
+                </a:solidFill>
+                <a:latin typeface="Georgia"/>
+              </a:rPr>
+              <a:t>buyers</a:t>
+            </a:r>
+            <a:r>
+              <a:rPr sz="2300" b="0" i="0" dirty="0">
+                <a:solidFill>
+                  <a:srgbClr val="000000"/>
+                </a:solidFill>
+                <a:latin typeface="Georgia"/>
+              </a:rPr>
+              <a:t> were new to Salomon</a:t>
+            </a:r>
+            <a:r>
+              <a:rPr lang="en-US" sz="2300" dirty="0">
+                <a:solidFill>
+                  <a:srgbClr val="000000"/>
+                </a:solidFill>
+                <a:latin typeface="Georgia"/>
+              </a:rPr>
+              <a:t>. A</a:t>
+            </a:r>
+            <a:r>
+              <a:rPr sz="2300" b="0" i="0" dirty="0">
+                <a:solidFill>
+                  <a:srgbClr val="000000"/>
+                </a:solidFill>
+                <a:latin typeface="Georgia"/>
+              </a:rPr>
+              <a:t>cquired at half early value</a:t>
+            </a:r>
+          </a:p>
+        </p:txBody>
+      </p:sp>
+      <p:sp>
+        <p:nvSpPr>
+          <p:cNvPr id="8" name="TextBox 7"/>
           <p:cNvSpPr txBox="1"/>
           <p:nvPr/>
         </p:nvSpPr>
         <p:spPr>
           <a:xfrm>
-            <a:off x="502920" y="1481328"/>
-            <a:ext cx="3383280" cy="274320"/>
+            <a:off x="4343400" y="1481328"/>
+            <a:ext cx="3474720" cy="153888"/>
           </a:xfrm>
           <a:prstGeom prst="rect">
             <a:avLst/>
@@ -13274,195 +13525,29 @@
           <a:p>
             <a:pPr algn="l"/>
             <a:r>
-              <a:rPr sz="1000" b="1" i="0">
+              <a:rPr sz="1000" b="1" i="0" dirty="0">
                 <a:solidFill>
                   <a:srgbClr val="757575"/>
                 </a:solidFill>
                 <a:latin typeface="Arial"/>
               </a:rPr>
-              <a:t>VESTAL PRO BUYER MIX (N = 1,335)</a:t>
-            </a:r>
-          </a:p>
-        </p:txBody>
-      </p:sp>
-      <p:graphicFrame>
-        <p:nvGraphicFramePr>
-          <p:cNvPr id="5" name="Chart 4"/>
-          <p:cNvGraphicFramePr>
-            <a:graphicFrameLocks noGrp="1"/>
-          </p:cNvGraphicFramePr>
-          <p:nvPr/>
-        </p:nvGraphicFramePr>
-        <p:xfrm>
-          <a:off x="502920" y="1828800"/>
-          <a:ext cx="3383280" cy="3383280"/>
-        </p:xfrm>
-        <a:graphic>
-          <a:graphicData uri="http://schemas.openxmlformats.org/drawingml/2006/chart">
-            <c:chart xmlns:c="http://schemas.openxmlformats.org/drawingml/2006/chart" xmlns:r="http://schemas.openxmlformats.org/officeDocument/2006/relationships" r:id="rId2"/>
-          </a:graphicData>
-        </a:graphic>
-      </p:graphicFrame>
-      <p:sp>
-        <p:nvSpPr>
-          <p:cNvPr id="6" name="TextBox 5"/>
-          <p:cNvSpPr txBox="1"/>
-          <p:nvPr/>
-        </p:nvSpPr>
-        <p:spPr>
-          <a:xfrm>
-            <a:off x="502920" y="3246120"/>
-            <a:ext cx="3383280" cy="640080"/>
-          </a:xfrm>
-          <a:prstGeom prst="rect">
-            <a:avLst/>
-          </a:prstGeom>
-          <a:noFill/>
-        </p:spPr>
-        <p:txBody>
-          <a:bodyPr wrap="square" lIns="0" tIns="0" rIns="0" bIns="0" anchor="t">
-            <a:spAutoFit/>
-          </a:bodyPr>
-          <a:lstStyle/>
-          <a:p>
-            <a:pPr algn="ctr">
-              <a:lnSpc>
-                <a:spcPct val="95000"/>
-              </a:lnSpc>
-            </a:pPr>
-            <a:r>
-              <a:rPr sz="2600" b="1" i="0">
-                <a:solidFill>
-                  <a:srgbClr val="000000"/>
-                </a:solidFill>
-                <a:latin typeface="Arial"/>
-              </a:rPr>
-              <a:t>44%</a:t>
-            </a:r>
-          </a:p>
-          <a:p>
-            <a:pPr algn="ctr">
-              <a:lnSpc>
-                <a:spcPct val="95000"/>
-              </a:lnSpc>
-            </a:pPr>
-            <a:r>
-              <a:rPr sz="1200" b="0" i="0">
+              <a:t>ACQUISITION</a:t>
+            </a:r>
+            <a:r>
+              <a:rPr lang="en-US" sz="1000" b="1" i="0" dirty="0">
                 <a:solidFill>
                   <a:srgbClr val="757575"/>
                 </a:solidFill>
                 <a:latin typeface="Arial"/>
               </a:rPr>
-              <a:t>new</a:t>
-            </a:r>
-          </a:p>
-        </p:txBody>
-      </p:sp>
-      <p:sp>
-        <p:nvSpPr>
-          <p:cNvPr id="7" name="TextBox 6"/>
-          <p:cNvSpPr txBox="1"/>
-          <p:nvPr/>
-        </p:nvSpPr>
-        <p:spPr>
-          <a:xfrm>
-            <a:off x="502920" y="5303520"/>
-            <a:ext cx="3383280" cy="548640"/>
-          </a:xfrm>
-          <a:prstGeom prst="rect">
-            <a:avLst/>
-          </a:prstGeom>
-          <a:noFill/>
-        </p:spPr>
-        <p:txBody>
-          <a:bodyPr wrap="square" lIns="0" tIns="0" rIns="0" bIns="0" anchor="t">
-            <a:spAutoFit/>
-          </a:bodyPr>
-          <a:lstStyle/>
-          <a:p>
-            <a:pPr algn="ctr">
-              <a:spcAft>
-                <a:spcPts val="300"/>
-              </a:spcAft>
-            </a:pPr>
-            <a:r>
-              <a:rPr sz="1100" b="1" i="0">
-                <a:solidFill>
-                  <a:srgbClr val="0057B8"/>
-                </a:solidFill>
-                <a:latin typeface="Arial"/>
-              </a:rPr>
-              <a:t>New 590 · </a:t>
-            </a:r>
-            <a:r>
-              <a:rPr sz="1100" b="1" i="0">
-                <a:solidFill>
-                  <a:srgbClr val="757575"/>
-                </a:solidFill>
-                <a:latin typeface="Arial"/>
-              </a:rPr>
-              <a:t>Existing 745</a:t>
-            </a:r>
-          </a:p>
-          <a:p>
-            <a:pPr algn="ctr">
-              <a:spcAft>
-                <a:spcPts val="300"/>
-              </a:spcAft>
-            </a:pPr>
-            <a:r>
-              <a:rPr sz="1050" b="0" i="0">
-                <a:solidFill>
-                  <a:srgbClr val="757575"/>
-                </a:solidFill>
-                <a:latin typeface="Arial"/>
-              </a:rPr>
-              <a:t>Success criterion ≥ 25% · </a:t>
-            </a:r>
-            <a:r>
-              <a:rPr sz="1050" b="1" i="0">
-                <a:solidFill>
-                  <a:srgbClr val="1F7A4D"/>
-                </a:solidFill>
-                <a:latin typeface="Arial"/>
-              </a:rPr>
-              <a:t>PASS</a:t>
-            </a:r>
-          </a:p>
-        </p:txBody>
-      </p:sp>
-      <p:sp>
-        <p:nvSpPr>
-          <p:cNvPr id="8" name="TextBox 7"/>
-          <p:cNvSpPr txBox="1"/>
-          <p:nvPr/>
-        </p:nvSpPr>
-        <p:spPr>
-          <a:xfrm>
-            <a:off x="4343400" y="1481328"/>
-            <a:ext cx="3474720" cy="274320"/>
-          </a:xfrm>
-          <a:prstGeom prst="rect">
-            <a:avLst/>
-          </a:prstGeom>
-          <a:noFill/>
-        </p:spPr>
-        <p:txBody>
-          <a:bodyPr wrap="square" lIns="0" tIns="0" rIns="0" bIns="0" anchor="t">
-            <a:spAutoFit/>
-          </a:bodyPr>
-          <a:lstStyle/>
-          <a:p>
-            <a:pPr algn="l"/>
-            <a:r>
-              <a:rPr sz="1000" b="1" i="0">
-                <a:solidFill>
-                  <a:srgbClr val="757575"/>
-                </a:solidFill>
-                <a:latin typeface="Arial"/>
-              </a:rPr>
-              <a:t>ACQUISITION ECONOMICS</a:t>
-            </a:r>
+              <a:t> METRICS</a:t>
+            </a:r>
+            <a:endParaRPr sz="1000" b="1" i="0" dirty="0">
+              <a:solidFill>
+                <a:srgbClr val="757575"/>
+              </a:solidFill>
+              <a:latin typeface="Arial"/>
+            </a:endParaRPr>
           </a:p>
         </p:txBody>
       </p:sp>
@@ -13475,7 +13560,7 @@
         <p:spPr>
           <a:xfrm>
             <a:off x="4343400" y="1847088"/>
-            <a:ext cx="3474720" cy="914400"/>
+            <a:ext cx="3474720" cy="510396"/>
           </a:xfrm>
           <a:prstGeom prst="rect">
             <a:avLst/>
@@ -13497,16 +13582,34 @@
               </a:spcAft>
             </a:pPr>
             <a:r>
-              <a:rPr sz="2100" b="1" i="0">
+              <a:rPr sz="2100" b="1" i="0" dirty="0">
                 <a:solidFill>
                   <a:srgbClr val="333333"/>
                 </a:solidFill>
                 <a:latin typeface="Arial"/>
               </a:rPr>
-              <a:t>$104   </a:t>
-            </a:r>
-            <a:r>
-              <a:rPr sz="1200" b="1" i="0">
+              <a:t>$10</a:t>
+            </a:r>
+            <a:r>
+              <a:rPr lang="en-US" sz="2100" b="1" i="0" dirty="0">
+                <a:solidFill>
+                  <a:srgbClr val="333333"/>
+                </a:solidFill>
+                <a:latin typeface="Arial"/>
+              </a:rPr>
+              <a:t>2</a:t>
+            </a:r>
+            <a:r>
+              <a:rPr sz="2100" b="1" i="0" dirty="0">
+                <a:solidFill>
+                  <a:srgbClr val="333333"/>
+                </a:solidFill>
+                <a:latin typeface="Arial"/>
+              </a:rPr>
+              <a:t>   </a:t>
+            </a:r>
+            <a:r>
+              <a:rPr sz="1200" b="1" i="0" dirty="0">
                 <a:solidFill>
                   <a:srgbClr val="333333"/>
                 </a:solidFill>
@@ -13525,13 +13628,31 @@
               </a:spcAft>
             </a:pPr>
             <a:r>
-              <a:rPr sz="1050" b="0" i="0">
+              <a:rPr sz="1050" b="0" i="0" dirty="0">
                 <a:solidFill>
                   <a:srgbClr val="757575"/>
                 </a:solidFill>
                 <a:latin typeface="Arial"/>
               </a:rPr>
-              <a:t>$155.8K spend ÷ 1,499 new customers</a:t>
+              <a:t>$155.8K spend ÷ </a:t>
+            </a:r>
+            <a:r>
+              <a:rPr lang="en-US" sz="1050" b="0" i="0" dirty="0">
+                <a:solidFill>
+                  <a:srgbClr val="757575"/>
+                </a:solidFill>
+                <a:latin typeface="Arial"/>
+              </a:rPr>
+              <a:t>730 </a:t>
+            </a:r>
+            <a:r>
+              <a:rPr sz="1050" b="0" i="0" dirty="0">
+                <a:solidFill>
+                  <a:srgbClr val="757575"/>
+                </a:solidFill>
+                <a:latin typeface="Arial"/>
+              </a:rPr>
+              <a:t>new customers</a:t>
             </a:r>
           </a:p>
         </p:txBody>
@@ -13545,7 +13666,7 @@
         <p:spPr>
           <a:xfrm>
             <a:off x="4343400" y="2834640"/>
-            <a:ext cx="3474720" cy="914400"/>
+            <a:ext cx="3474720" cy="510396"/>
           </a:xfrm>
           <a:prstGeom prst="rect">
             <a:avLst/>
@@ -13567,16 +13688,34 @@
               </a:spcAft>
             </a:pPr>
             <a:r>
-              <a:rPr sz="2100" b="1" i="0">
+              <a:rPr sz="2100" b="1" i="0" dirty="0">
                 <a:solidFill>
                   <a:srgbClr val="333333"/>
                 </a:solidFill>
                 <a:latin typeface="Arial"/>
               </a:rPr>
-              <a:t>$130   </a:t>
-            </a:r>
-            <a:r>
-              <a:rPr sz="1200" b="1" i="0">
+              <a:t>$1</a:t>
+            </a:r>
+            <a:r>
+              <a:rPr lang="en-US" sz="2100" b="1" i="0" dirty="0">
+                <a:solidFill>
+                  <a:srgbClr val="333333"/>
+                </a:solidFill>
+                <a:latin typeface="Arial"/>
+              </a:rPr>
+              <a:t>29</a:t>
+            </a:r>
+            <a:r>
+              <a:rPr sz="2100" b="1" i="0" dirty="0">
+                <a:solidFill>
+                  <a:srgbClr val="333333"/>
+                </a:solidFill>
+                <a:latin typeface="Arial"/>
+              </a:rPr>
+              <a:t>   </a:t>
+            </a:r>
+            <a:r>
+              <a:rPr sz="1200" b="1" i="0" dirty="0">
                 <a:solidFill>
                   <a:srgbClr val="333333"/>
                 </a:solidFill>
@@ -13595,7 +13734,7 @@
               </a:spcAft>
             </a:pPr>
             <a:r>
-              <a:rPr sz="1050" b="0" i="0">
+              <a:rPr sz="1050" b="0" i="0" dirty="0">
                 <a:solidFill>
                   <a:srgbClr val="757575"/>
                 </a:solidFill>
@@ -13615,7 +13754,7 @@
         <p:spPr>
           <a:xfrm>
             <a:off x="4343400" y="3822191"/>
-            <a:ext cx="3474720" cy="914400"/>
+            <a:ext cx="3474720" cy="510396"/>
           </a:xfrm>
           <a:prstGeom prst="rect">
             <a:avLst/>
@@ -13637,16 +13776,34 @@
               </a:spcAft>
             </a:pPr>
             <a:r>
-              <a:rPr sz="2100" b="1" i="0">
+              <a:rPr sz="2100" b="1" i="0" dirty="0">
                 <a:solidFill>
                   <a:srgbClr val="0057B8"/>
                 </a:solidFill>
                 <a:latin typeface="Arial"/>
               </a:rPr>
-              <a:t>$212   </a:t>
-            </a:r>
-            <a:r>
-              <a:rPr sz="1200" b="1" i="0">
+              <a:t>$</a:t>
+            </a:r>
+            <a:r>
+              <a:rPr lang="en-US" sz="2100" b="1" i="0" dirty="0">
+                <a:solidFill>
+                  <a:srgbClr val="0057B8"/>
+                </a:solidFill>
+                <a:latin typeface="Arial"/>
+              </a:rPr>
+              <a:t>188</a:t>
+            </a:r>
+            <a:r>
+              <a:rPr sz="2100" b="1" i="0" dirty="0">
+                <a:solidFill>
+                  <a:srgbClr val="0057B8"/>
+                </a:solidFill>
+                <a:latin typeface="Arial"/>
+              </a:rPr>
+              <a:t>   </a:t>
+            </a:r>
+            <a:r>
+              <a:rPr sz="1200" b="1" i="0" dirty="0">
                 <a:solidFill>
                   <a:srgbClr val="333333"/>
                 </a:solidFill>
@@ -13665,13 +13822,49 @@
               </a:spcAft>
             </a:pPr>
             <a:r>
-              <a:rPr sz="1050" b="0" i="0">
+              <a:rPr sz="1050" b="0" i="0" dirty="0">
                 <a:solidFill>
                   <a:srgbClr val="757575"/>
                 </a:solidFill>
                 <a:latin typeface="Arial"/>
               </a:rPr>
-              <a:t>revenue through May 10 · 2.0× CAC</a:t>
+              <a:t>revenue through </a:t>
+            </a:r>
+            <a:r>
+              <a:rPr lang="en-US" sz="1050" b="0" i="0" dirty="0">
+                <a:solidFill>
+                  <a:srgbClr val="757575"/>
+                </a:solidFill>
+                <a:latin typeface="Arial"/>
+              </a:rPr>
+              <a:t>June 20</a:t>
+            </a:r>
+            <a:r>
+              <a:rPr sz="1050" b="0" i="0" dirty="0">
+                <a:solidFill>
+                  <a:srgbClr val="757575"/>
+                </a:solidFill>
+                <a:latin typeface="Arial"/>
+              </a:rPr>
+              <a:t> · </a:t>
+            </a:r>
+            <a:r>
+              <a:rPr lang="en-US" sz="1050" b="0" i="0" dirty="0">
+                <a:solidFill>
+                  <a:srgbClr val="757575"/>
+                </a:solidFill>
+                <a:latin typeface="Arial"/>
+              </a:rPr>
+              <a:t>1.8</a:t>
+            </a:r>
+            <a:r>
+              <a:rPr sz="1050" b="0" i="0" dirty="0">
+                <a:solidFill>
+                  <a:srgbClr val="757575"/>
+                </a:solidFill>
+                <a:latin typeface="Arial"/>
+              </a:rPr>
+              <a:t>× CAC</a:t>
             </a:r>
           </a:p>
         </p:txBody>
@@ -13685,7 +13878,7 @@
         <p:spPr>
           <a:xfrm>
             <a:off x="4343400" y="4809744"/>
-            <a:ext cx="3474720" cy="914400"/>
+            <a:ext cx="3474720" cy="510396"/>
           </a:xfrm>
           <a:prstGeom prst="rect">
             <a:avLst/>
@@ -13707,16 +13900,25 @@
               </a:spcAft>
             </a:pPr>
             <a:r>
-              <a:rPr sz="2100" b="1" i="0">
+              <a:rPr lang="en-US" sz="2100" b="1" dirty="0">
                 <a:solidFill>
                   <a:srgbClr val="333333"/>
                 </a:solidFill>
                 <a:latin typeface="Arial"/>
               </a:rPr>
-              <a:t>27%   </a:t>
-            </a:r>
-            <a:r>
-              <a:rPr sz="1200" b="1" i="0">
+              <a:t>28.1</a:t>
+            </a:r>
+            <a:r>
+              <a:rPr sz="2100" b="1" i="0" dirty="0">
+                <a:solidFill>
+                  <a:srgbClr val="333333"/>
+                </a:solidFill>
+                <a:latin typeface="Arial"/>
+              </a:rPr>
+              <a:t>%   </a:t>
+            </a:r>
+            <a:r>
+              <a:rPr sz="1200" b="1" i="0" dirty="0">
                 <a:solidFill>
                   <a:srgbClr val="333333"/>
                 </a:solidFill>
@@ -13735,27 +13937,42 @@
               </a:spcAft>
             </a:pPr>
             <a:r>
-              <a:rPr sz="1050" b="0" i="0">
+              <a:rPr sz="1050" b="0" i="0" dirty="0">
                 <a:solidFill>
                   <a:srgbClr val="757575"/>
                 </a:solidFill>
                 <a:latin typeface="Arial"/>
               </a:rPr>
-              <a:t>repurchased within 4 weeks of flight end</a:t>
-            </a:r>
-          </a:p>
-        </p:txBody>
-      </p:sp>
-      <p:sp>
-        <p:nvSpPr>
-          <p:cNvPr id="13" name="TextBox 12"/>
+              <a:t>repurchased within 4 weeks of </a:t>
+            </a:r>
+            <a:r>
+              <a:rPr lang="en-US" sz="1050" b="0" i="0" dirty="0">
+                <a:solidFill>
+                  <a:srgbClr val="757575"/>
+                </a:solidFill>
+                <a:latin typeface="Arial"/>
+              </a:rPr>
+              <a:t>initial purchase</a:t>
+            </a:r>
+            <a:endParaRPr sz="1050" b="0" i="0" dirty="0">
+              <a:solidFill>
+                <a:srgbClr val="757575"/>
+              </a:solidFill>
+              <a:latin typeface="Arial"/>
+            </a:endParaRPr>
+          </a:p>
+        </p:txBody>
+      </p:sp>
+      <p:sp>
+        <p:nvSpPr>
+          <p:cNvPr id="16" name="TextBox 15"/>
           <p:cNvSpPr txBox="1"/>
           <p:nvPr/>
         </p:nvSpPr>
         <p:spPr>
           <a:xfrm>
-            <a:off x="4343400" y="5760720"/>
-            <a:ext cx="3474720" cy="457200"/>
+            <a:off x="8183879" y="5074920"/>
+            <a:ext cx="3520440" cy="749308"/>
           </a:xfrm>
           <a:prstGeom prst="rect">
             <a:avLst/>
@@ -13768,97 +13985,36 @@
           </a:bodyPr>
           <a:lstStyle/>
           <a:p>
-            <a:pPr algn="l">
+            <a:pPr>
               <a:lnSpc>
-                <a:spcPct val="105000"/>
+                <a:spcPct val="108000"/>
               </a:lnSpc>
+              <a:spcAft>
+                <a:spcPts val="500"/>
+              </a:spcAft>
             </a:pPr>
             <a:r>
-              <a:rPr sz="1000" b="0" i="1">
-                <a:solidFill>
-                  <a:srgbClr val="757575"/>
-                </a:solidFill>
-                <a:latin typeface="Arial"/>
-              </a:rPr>
-              <a:t>Full LTV needs cohort history beyond this window; early value already covers CAC twice over.</a:t>
-            </a:r>
-          </a:p>
-        </p:txBody>
-      </p:sp>
-      <p:sp>
-        <p:nvSpPr>
-          <p:cNvPr id="14" name="TextBox 13"/>
-          <p:cNvSpPr txBox="1"/>
-          <p:nvPr/>
-        </p:nvSpPr>
-        <p:spPr>
-          <a:xfrm>
-            <a:off x="8183879" y="1481328"/>
-            <a:ext cx="3520440" cy="274320"/>
-          </a:xfrm>
-          <a:prstGeom prst="rect">
-            <a:avLst/>
-          </a:prstGeom>
-          <a:noFill/>
-        </p:spPr>
-        <p:txBody>
-          <a:bodyPr wrap="square" lIns="0" tIns="0" rIns="0" bIns="0" anchor="t">
-            <a:spAutoFit/>
-          </a:bodyPr>
-          <a:lstStyle/>
-          <a:p>
-            <a:pPr algn="l"/>
-            <a:r>
-              <a:rPr sz="1000" b="1" i="0">
-                <a:solidFill>
-                  <a:srgbClr val="757575"/>
-                </a:solidFill>
-                <a:latin typeface="Arial"/>
-              </a:rPr>
-              <a:t>DATABASE ADDS PER DAY</a:t>
-            </a:r>
-          </a:p>
-        </p:txBody>
-      </p:sp>
-      <p:graphicFrame>
-        <p:nvGraphicFramePr>
-          <p:cNvPr id="15" name="Chart 14"/>
-          <p:cNvGraphicFramePr>
-            <a:graphicFrameLocks noGrp="1"/>
-          </p:cNvGraphicFramePr>
-          <p:nvPr/>
-        </p:nvGraphicFramePr>
-        <p:xfrm>
-          <a:off x="8046719" y="1828800"/>
-          <a:ext cx="3657600" cy="3108960"/>
-        </p:xfrm>
-        <a:graphic>
-          <a:graphicData uri="http://schemas.openxmlformats.org/drawingml/2006/chart">
-            <c:chart xmlns:c="http://schemas.openxmlformats.org/drawingml/2006/chart" xmlns:r="http://schemas.openxmlformats.org/officeDocument/2006/relationships" r:id="rId3"/>
-          </a:graphicData>
-        </a:graphic>
-      </p:graphicFrame>
-      <p:sp>
-        <p:nvSpPr>
-          <p:cNvPr id="16" name="TextBox 15"/>
-          <p:cNvSpPr txBox="1"/>
-          <p:nvPr/>
-        </p:nvSpPr>
-        <p:spPr>
-          <a:xfrm>
-            <a:off x="8183879" y="5074920"/>
-            <a:ext cx="3520440" cy="1188720"/>
-          </a:xfrm>
-          <a:prstGeom prst="rect">
-            <a:avLst/>
-          </a:prstGeom>
-          <a:noFill/>
-        </p:spPr>
-        <p:txBody>
-          <a:bodyPr wrap="square" lIns="0" tIns="0" rIns="0" bIns="0" anchor="t">
-            <a:spAutoFit/>
-          </a:bodyPr>
-          <a:lstStyle/>
+              <a:rPr lang="en-US" sz="1050" dirty="0">
+                <a:solidFill>
+                  <a:schemeClr val="tx2">
+                    <a:lumMod val="50000"/>
+                    <a:lumOff val="50000"/>
+                  </a:schemeClr>
+                </a:solidFill>
+                <a:latin typeface="Arial"/>
+              </a:rPr>
+              <a:t>1,361 email and 678 SMS adds during the 20-day campaign.</a:t>
+            </a:r>
+            <a:endParaRPr sz="1050" b="0" i="0" dirty="0">
+              <a:solidFill>
+                <a:schemeClr val="tx2">
+                  <a:lumMod val="50000"/>
+                  <a:lumOff val="50000"/>
+                </a:schemeClr>
+              </a:solidFill>
+              <a:latin typeface="Arial"/>
+            </a:endParaRPr>
+          </a:p>
           <a:p>
             <a:pPr algn="l">
               <a:lnSpc>
@@ -13869,33 +14025,26 @@
               </a:spcAft>
             </a:pPr>
             <a:r>
-              <a:rPr sz="1050" b="0" i="0">
-                <a:solidFill>
-                  <a:srgbClr val="333333"/>
-                </a:solidFill>
-                <a:latin typeface="Arial"/>
-              </a:rPr>
-              <a:t>Email +34% · SMS +40% vs pre-period run-rate → 2,776 email and 1,447 SMS adds in six weeks.</a:t>
-            </a:r>
-          </a:p>
-          <a:p>
-            <a:pPr algn="l">
-              <a:lnSpc>
-                <a:spcPct val="108000"/>
-              </a:lnSpc>
-              <a:spcAft>
-                <a:spcPts val="500"/>
-              </a:spcAft>
-            </a:pPr>
-            <a:r>
-              <a:rPr sz="1050" b="0" i="0">
-                <a:solidFill>
-                  <a:srgbClr val="333333"/>
-                </a:solidFill>
-                <a:latin typeface="Arial"/>
-              </a:rPr>
-              <a:t>New Vestal Pro buyers opt in at 77% email / 47% SMS vs a 56% / 28% site average.</a:t>
-            </a:r>
+              <a:rPr lang="en-US" sz="1050" dirty="0">
+                <a:solidFill>
+                  <a:schemeClr val="tx2">
+                    <a:lumMod val="50000"/>
+                    <a:lumOff val="50000"/>
+                  </a:schemeClr>
+                </a:solidFill>
+                <a:latin typeface="Arial"/>
+              </a:rPr>
+              <a:t>New Vestal Pro buyers opt in at 72% email / 40% SMS, vs 51% / 24% for existing buyers.</a:t>
+            </a:r>
+            <a:endParaRPr sz="1050" b="0" i="0" dirty="0">
+              <a:solidFill>
+                <a:schemeClr val="tx2">
+                  <a:lumMod val="50000"/>
+                  <a:lumOff val="50000"/>
+                </a:schemeClr>
+              </a:solidFill>
+              <a:latin typeface="Arial"/>
+            </a:endParaRPr>
           </a:p>
         </p:txBody>
       </p:sp>
@@ -13908,7 +14057,7 @@
         <p:spPr>
           <a:xfrm>
             <a:off x="502920" y="6510528"/>
-            <a:ext cx="10515600" cy="274320"/>
+            <a:ext cx="10515600" cy="123111"/>
           </a:xfrm>
           <a:prstGeom prst="rect">
             <a:avLst/>
@@ -13923,13 +14072,13 @@
           <a:p>
             <a:pPr algn="l"/>
             <a:r>
-              <a:rPr sz="800" b="0" i="0">
+              <a:rPr sz="800" b="0" i="0" dirty="0">
                 <a:solidFill>
                   <a:srgbClr val="757575"/>
                 </a:solidFill>
                 <a:latin typeface="Arial"/>
               </a:rPr>
-              <a:t>Salomon NA eCommerce · Vestal Pro launch readout · Illustrative synthetic case data · No numeric CAC or database targets were set pre-launch — set them next flight</a:t>
+              <a:t>Salomon NA eCommerce · Vestal Pro launch readout</a:t>
             </a:r>
           </a:p>
         </p:txBody>
@@ -13972,6 +14121,66 @@
       <p:pic>
         <p:nvPicPr>
           <p:cNvPr id="19" name="Picture 18" descr="salomon_wordmark_black.png"/>
+          <p:cNvPicPr>
+            <a:picLocks noChangeAspect="1"/>
+          </p:cNvPicPr>
+          <p:nvPr/>
+        </p:nvPicPr>
+        <p:blipFill>
+          <a:blip r:embed="rId2"/>
+          <a:stretch>
+            <a:fillRect/>
+          </a:stretch>
+        </p:blipFill>
+        <p:spPr>
+          <a:xfrm>
+            <a:off x="10698480" y="292608"/>
+            <a:ext cx="960120" cy="110013"/>
+          </a:xfrm>
+          <a:prstGeom prst="rect">
+            <a:avLst/>
+          </a:prstGeom>
+        </p:spPr>
+      </p:pic>
+      <p:pic>
+        <p:nvPicPr>
+          <p:cNvPr id="21" name="Picture 20" descr="The image displays a pie chart indicating that 25% of Vestal Pro buyers choose to pass, with new Salomon products being more popular at 268 and existing products at 399.&#10;&#10;AI-generated content may be incorrect.">
+            <a:extLst>
+              <a:ext uri="{FF2B5EF4-FFF2-40B4-BE49-F238E27FC236}">
+                <a16:creationId xmlns:a16="http://schemas.microsoft.com/office/drawing/2014/main" id="{EDD06685-1F8D-CD67-638F-B32B434A1A09}"/>
+              </a:ext>
+            </a:extLst>
+          </p:cNvPr>
+          <p:cNvPicPr>
+            <a:picLocks noChangeAspect="1"/>
+          </p:cNvPicPr>
+          <p:nvPr/>
+        </p:nvPicPr>
+        <p:blipFill>
+          <a:blip r:embed="rId3"/>
+          <a:stretch>
+            <a:fillRect/>
+          </a:stretch>
+        </p:blipFill>
+        <p:spPr>
+          <a:xfrm>
+            <a:off x="-1" y="1408656"/>
+            <a:ext cx="4313947" cy="3805518"/>
+          </a:xfrm>
+          <a:prstGeom prst="rect">
+            <a:avLst/>
+          </a:prstGeom>
+        </p:spPr>
+      </p:pic>
+      <p:pic>
+        <p:nvPicPr>
+          <p:cNvPr id="23" name="Picture 22" descr="The diagram illustrates an increasing trend in daily database additions, with percentages rising from +35% to +37% and a significant increase in email activity, contrasted with a smaller growth in SMS engagement.&#10;&#10;AI-generated content may be incorrect.">
+            <a:extLst>
+              <a:ext uri="{FF2B5EF4-FFF2-40B4-BE49-F238E27FC236}">
+                <a16:creationId xmlns:a16="http://schemas.microsoft.com/office/drawing/2014/main" id="{8A7433B0-14CE-40AB-7678-59C5DDFC7F44}"/>
+              </a:ext>
+            </a:extLst>
+          </p:cNvPr>
           <p:cNvPicPr>
             <a:picLocks noChangeAspect="1"/>
           </p:cNvPicPr>
@@ -13985,8 +14194,8 @@
         </p:blipFill>
         <p:spPr>
           <a:xfrm>
-            <a:off x="10698480" y="292608"/>
-            <a:ext cx="960120" cy="110013"/>
+            <a:off x="7384277" y="1481327"/>
+            <a:ext cx="4530844" cy="3497245"/>
           </a:xfrm>
           <a:prstGeom prst="rect">
             <a:avLst/>
@@ -14006,7 +14215,13 @@
   <p:cSld>
     <p:spTree>
       <p:nvGrpSpPr>
-        <p:cNvPr id="1" name=""/>
+        <p:cNvPr id="1" name="">
+          <a:extLst>
+            <a:ext uri="{FF2B5EF4-FFF2-40B4-BE49-F238E27FC236}">
+              <a16:creationId xmlns:a16="http://schemas.microsoft.com/office/drawing/2014/main" id="{8729F1A2-49D4-AE4A-1D0A-23C7A225436B}"/>
+            </a:ext>
+          </a:extLst>
+        </p:cNvPr>
         <p:cNvGrpSpPr/>
         <p:nvPr/>
       </p:nvGrpSpPr>
@@ -14020,14 +14235,20 @@
       </p:grpSpPr>
       <p:sp>
         <p:nvSpPr>
-          <p:cNvPr id="2" name="TextBox 1"/>
+          <p:cNvPr id="2" name="TextBox 1">
+            <a:extLst>
+              <a:ext uri="{FF2B5EF4-FFF2-40B4-BE49-F238E27FC236}">
+                <a16:creationId xmlns:a16="http://schemas.microsoft.com/office/drawing/2014/main" id="{D1AF255B-BC9F-3F24-461F-7B00C6BE6B54}"/>
+              </a:ext>
+            </a:extLst>
+          </p:cNvPr>
           <p:cNvSpPr txBox="1"/>
           <p:nvPr/>
         </p:nvSpPr>
         <p:spPr>
           <a:xfrm>
             <a:off x="502920" y="292608"/>
-            <a:ext cx="11155680" cy="274320"/>
+            <a:ext cx="11155680" cy="161583"/>
           </a:xfrm>
           <a:prstGeom prst="rect">
             <a:avLst/>
@@ -14042,27 +14263,48 @@
           <a:p>
             <a:pPr algn="l"/>
             <a:r>
-              <a:rPr sz="1050" b="1" i="0">
+              <a:rPr sz="1050" b="1" i="0" dirty="0">
                 <a:solidFill>
                   <a:srgbClr val="757575"/>
                 </a:solidFill>
                 <a:latin typeface="Arial"/>
               </a:rPr>
-              <a:t>HALO EFFECT</a:t>
-            </a:r>
-          </a:p>
-        </p:txBody>
-      </p:sp>
-      <p:sp>
-        <p:nvSpPr>
-          <p:cNvPr id="3" name="TextBox 2"/>
+              <a:t>CUSTOMER ACQUISITION</a:t>
+            </a:r>
+            <a:r>
+              <a:rPr lang="en-US" sz="1050" b="1" i="0" dirty="0">
+                <a:solidFill>
+                  <a:srgbClr val="757575"/>
+                </a:solidFill>
+                <a:latin typeface="Arial"/>
+              </a:rPr>
+              <a:t> AND LTV</a:t>
+            </a:r>
+            <a:endParaRPr sz="1050" b="1" i="0" dirty="0">
+              <a:solidFill>
+                <a:srgbClr val="757575"/>
+              </a:solidFill>
+              <a:latin typeface="Arial"/>
+            </a:endParaRPr>
+          </a:p>
+        </p:txBody>
+      </p:sp>
+      <p:sp>
+        <p:nvSpPr>
+          <p:cNvPr id="3" name="TextBox 2">
+            <a:extLst>
+              <a:ext uri="{FF2B5EF4-FFF2-40B4-BE49-F238E27FC236}">
+                <a16:creationId xmlns:a16="http://schemas.microsoft.com/office/drawing/2014/main" id="{D53D5D81-D5F6-4AAE-1E2A-8080FB2F4082}"/>
+              </a:ext>
+            </a:extLst>
+          </p:cNvPr>
           <p:cNvSpPr txBox="1"/>
           <p:nvPr/>
         </p:nvSpPr>
         <p:spPr>
           <a:xfrm>
             <a:off x="502920" y="566928"/>
-            <a:ext cx="11201400" cy="777240"/>
+            <a:ext cx="11201400" cy="353943"/>
           </a:xfrm>
           <a:prstGeom prst="rect">
             <a:avLst/>
@@ -14077,27 +14319,39 @@
           <a:p>
             <a:pPr algn="l"/>
             <a:r>
-              <a:rPr sz="2300" b="0" i="0">
+              <a:rPr lang="en-US" sz="2300" b="0" i="0" dirty="0">
                 <a:solidFill>
                   <a:srgbClr val="000000"/>
                 </a:solidFill>
                 <a:latin typeface="Georgia"/>
               </a:rPr>
-              <a:t>Adjacent categories lifted +9%, but as standalone purchases, not bigger baskets</a:t>
-            </a:r>
-          </a:p>
-        </p:txBody>
-      </p:sp>
-      <p:sp>
-        <p:nvSpPr>
-          <p:cNvPr id="4" name="TextBox 3"/>
+              <a:t>Projected 24-month value of ~$387 per new customer; 3.8× acquisition cost</a:t>
+            </a:r>
+            <a:endParaRPr sz="2300" b="0" i="0" dirty="0">
+              <a:solidFill>
+                <a:srgbClr val="000000"/>
+              </a:solidFill>
+              <a:latin typeface="Georgia"/>
+            </a:endParaRPr>
+          </a:p>
+        </p:txBody>
+      </p:sp>
+      <p:sp>
+        <p:nvSpPr>
+          <p:cNvPr id="17" name="TextBox 16">
+            <a:extLst>
+              <a:ext uri="{FF2B5EF4-FFF2-40B4-BE49-F238E27FC236}">
+                <a16:creationId xmlns:a16="http://schemas.microsoft.com/office/drawing/2014/main" id="{3A7D67C6-323C-82EF-4AC6-94AA08868144}"/>
+              </a:ext>
+            </a:extLst>
+          </p:cNvPr>
           <p:cNvSpPr txBox="1"/>
           <p:nvPr/>
         </p:nvSpPr>
         <p:spPr>
           <a:xfrm>
-            <a:off x="502920" y="1481328"/>
-            <a:ext cx="6035040" cy="274320"/>
+            <a:off x="502920" y="6510528"/>
+            <a:ext cx="10515600" cy="123111"/>
           </a:xfrm>
           <a:prstGeom prst="rect">
             <a:avLst/>
@@ -14112,45 +14366,33 @@
           <a:p>
             <a:pPr algn="l"/>
             <a:r>
-              <a:rPr sz="1000" b="1" i="0">
+              <a:rPr sz="800" b="0" i="0" dirty="0">
                 <a:solidFill>
                   <a:srgbClr val="757575"/>
                 </a:solidFill>
                 <a:latin typeface="Arial"/>
               </a:rPr>
-              <a:t>ADJACENT-CATEGORY REVENUE VS EXPECTED BASELINE, ACTIVE FLIGHT</a:t>
-            </a:r>
-          </a:p>
-        </p:txBody>
-      </p:sp>
-      <p:graphicFrame>
-        <p:nvGraphicFramePr>
-          <p:cNvPr id="5" name="Chart 4"/>
-          <p:cNvGraphicFramePr>
-            <a:graphicFrameLocks noGrp="1"/>
-          </p:cNvGraphicFramePr>
-          <p:nvPr/>
-        </p:nvGraphicFramePr>
-        <p:xfrm>
-          <a:off x="365760" y="1828800"/>
-          <a:ext cx="6309360" cy="4023360"/>
-        </p:xfrm>
-        <a:graphic>
-          <a:graphicData uri="http://schemas.openxmlformats.org/drawingml/2006/chart">
-            <c:chart xmlns:c="http://schemas.openxmlformats.org/drawingml/2006/chart" xmlns:r="http://schemas.openxmlformats.org/officeDocument/2006/relationships" r:id="rId2"/>
-          </a:graphicData>
-        </a:graphic>
-      </p:graphicFrame>
-      <p:sp>
-        <p:nvSpPr>
-          <p:cNvPr id="6" name="TextBox 5"/>
+              <a:t>Salomon NA eCommerce · Vestal Pro launch readout</a:t>
+            </a:r>
+          </a:p>
+        </p:txBody>
+      </p:sp>
+      <p:sp>
+        <p:nvSpPr>
+          <p:cNvPr id="18" name="TextBox 17">
+            <a:extLst>
+              <a:ext uri="{FF2B5EF4-FFF2-40B4-BE49-F238E27FC236}">
+                <a16:creationId xmlns:a16="http://schemas.microsoft.com/office/drawing/2014/main" id="{063D1226-9BE7-41CB-399A-C53415DF9AB7}"/>
+              </a:ext>
+            </a:extLst>
+          </p:cNvPr>
           <p:cNvSpPr txBox="1"/>
           <p:nvPr/>
         </p:nvSpPr>
         <p:spPr>
           <a:xfrm>
-            <a:off x="640080" y="5806440"/>
-            <a:ext cx="5852160" cy="320040"/>
+            <a:off x="11292840" y="6510528"/>
+            <a:ext cx="411480" cy="274320"/>
           </a:xfrm>
           <a:prstGeom prst="rect">
             <a:avLst/>
@@ -14163,269 +14405,28 @@
           </a:bodyPr>
           <a:lstStyle/>
           <a:p>
-            <a:pPr algn="l"/>
-            <a:r>
-              <a:rPr sz="1000" b="0" i="0">
+            <a:pPr algn="r"/>
+            <a:r>
+              <a:rPr sz="800" b="0" i="0">
                 <a:solidFill>
                   <a:srgbClr val="757575"/>
                 </a:solidFill>
                 <a:latin typeface="Arial"/>
               </a:rPr>
-              <a:t>Success criterion ≥ +5%: </a:t>
-            </a:r>
-            <a:r>
-              <a:rPr sz="1000" b="1" i="0">
-                <a:solidFill>
-                  <a:srgbClr val="1F7A4D"/>
-                </a:solidFill>
-                <a:latin typeface="Arial"/>
-              </a:rPr>
-              <a:t>PASS</a:t>
-            </a:r>
-            <a:r>
-              <a:rPr sz="1000" b="0" i="0">
-                <a:solidFill>
-                  <a:srgbClr val="757575"/>
-                </a:solidFill>
-                <a:latin typeface="Arial"/>
-              </a:rPr>
-              <a:t>  (+9.2%, 95% CI +3.0% to +15.4% · +$7.9K)</a:t>
-            </a:r>
-          </a:p>
-        </p:txBody>
-      </p:sp>
-      <p:sp>
-        <p:nvSpPr>
-          <p:cNvPr id="7" name="TextBox 6"/>
-          <p:cNvSpPr txBox="1"/>
-          <p:nvPr/>
-        </p:nvSpPr>
-        <p:spPr>
-          <a:xfrm>
-            <a:off x="7086600" y="1481328"/>
-            <a:ext cx="4572000" cy="274320"/>
-          </a:xfrm>
-          <a:prstGeom prst="rect">
-            <a:avLst/>
-          </a:prstGeom>
-          <a:noFill/>
-        </p:spPr>
-        <p:txBody>
-          <a:bodyPr wrap="square" lIns="0" tIns="0" rIns="0" bIns="0" anchor="t">
-            <a:spAutoFit/>
-          </a:bodyPr>
-          <a:lstStyle/>
-          <a:p>
-            <a:pPr algn="l"/>
-            <a:r>
-              <a:rPr sz="1000" b="1" i="0">
-                <a:solidFill>
-                  <a:srgbClr val="757575"/>
-                </a:solidFill>
-                <a:latin typeface="Arial"/>
-              </a:rPr>
-              <a:t>ATTACH RATE TO VESTAL PRO ORDERS</a:t>
-            </a:r>
-          </a:p>
-        </p:txBody>
-      </p:sp>
-      <p:sp>
-        <p:nvSpPr>
-          <p:cNvPr id="8" name="TextBox 7"/>
-          <p:cNvSpPr txBox="1"/>
-          <p:nvPr/>
-        </p:nvSpPr>
-        <p:spPr>
-          <a:xfrm>
-            <a:off x="7086600" y="1828800"/>
-            <a:ext cx="4572000" cy="868680"/>
-          </a:xfrm>
-          <a:prstGeom prst="rect">
-            <a:avLst/>
-          </a:prstGeom>
-          <a:noFill/>
-        </p:spPr>
-        <p:txBody>
-          <a:bodyPr wrap="square" lIns="0" tIns="0" rIns="0" bIns="0" anchor="t">
-            <a:spAutoFit/>
-          </a:bodyPr>
-          <a:lstStyle/>
-          <a:p>
-            <a:pPr algn="l"/>
-            <a:r>
-              <a:rPr sz="3400" b="1" i="0">
-                <a:solidFill>
-                  <a:srgbClr val="333333"/>
-                </a:solidFill>
-                <a:latin typeface="Arial"/>
-              </a:rPr>
-              <a:t>17.8%</a:t>
-            </a:r>
-            <a:r>
-              <a:rPr sz="1300" b="0" i="0">
-                <a:solidFill>
-                  <a:srgbClr val="757575"/>
-                </a:solidFill>
-                <a:latin typeface="Arial"/>
-              </a:rPr>
-              <a:t>   flat vs 18.0% pre-period</a:t>
-            </a:r>
-          </a:p>
-        </p:txBody>
-      </p:sp>
-      <p:sp>
-        <p:nvSpPr>
-          <p:cNvPr id="9" name="TextBox 8"/>
-          <p:cNvSpPr txBox="1"/>
-          <p:nvPr/>
-        </p:nvSpPr>
-        <p:spPr>
-          <a:xfrm>
-            <a:off x="7086600" y="2834640"/>
-            <a:ext cx="4572000" cy="3200400"/>
-          </a:xfrm>
-          <a:prstGeom prst="rect">
-            <a:avLst/>
-          </a:prstGeom>
-          <a:noFill/>
-        </p:spPr>
-        <p:txBody>
-          <a:bodyPr wrap="square" lIns="0" tIns="0" rIns="0" bIns="0" anchor="t">
-            <a:spAutoFit/>
-          </a:bodyPr>
-          <a:lstStyle/>
-          <a:p>
-            <a:pPr algn="l">
-              <a:lnSpc>
-                <a:spcPct val="112000"/>
-              </a:lnSpc>
-              <a:spcAft>
-                <a:spcPts val="800"/>
-              </a:spcAft>
-            </a:pPr>
-            <a:r>
-              <a:rPr sz="1150" b="0" i="0">
-                <a:solidFill>
-                  <a:srgbClr val="333333"/>
-                </a:solidFill>
-                <a:latin typeface="Arial"/>
-              </a:rPr>
-              <a:t>•  The halo arrived as standalone adjacent purchases driven by campaign traffic and awareness — not as bigger Vestal Pro baskets.</a:t>
-            </a:r>
-          </a:p>
-          <a:p>
-            <a:pPr algn="l">
-              <a:lnSpc>
-                <a:spcPct val="112000"/>
-              </a:lnSpc>
-              <a:spcAft>
-                <a:spcPts val="800"/>
-              </a:spcAft>
-            </a:pPr>
-            <a:r>
-              <a:rPr sz="1150" b="0" i="0">
-                <a:solidFill>
-                  <a:srgbClr val="333333"/>
-                </a:solidFill>
-                <a:latin typeface="Arial"/>
-              </a:rPr>
-              <a:t>•  Accessories led (+16.9%); apparel followed (+5.4%). Other footwear orders attached at the same 18% rate.</a:t>
-            </a:r>
-          </a:p>
-          <a:p>
-            <a:pPr algn="l">
-              <a:lnSpc>
-                <a:spcPct val="112000"/>
-              </a:lnSpc>
-              <a:spcAft>
-                <a:spcPts val="800"/>
-              </a:spcAft>
-            </a:pPr>
-            <a:r>
-              <a:rPr sz="1150" b="0" i="0">
-                <a:solidFill>
-                  <a:srgbClr val="333333"/>
-                </a:solidFill>
-                <a:latin typeface="Arial"/>
-              </a:rPr>
-              <a:t>•  Opportunity: PDP bundles (socks, gaiters, hydration) and CRM cross-sell journeys to convert awareness halo into basket halo.</a:t>
-            </a:r>
-          </a:p>
-        </p:txBody>
-      </p:sp>
-      <p:sp>
-        <p:nvSpPr>
-          <p:cNvPr id="10" name="TextBox 9"/>
-          <p:cNvSpPr txBox="1"/>
-          <p:nvPr/>
-        </p:nvSpPr>
-        <p:spPr>
-          <a:xfrm>
-            <a:off x="502920" y="6510528"/>
-            <a:ext cx="10515600" cy="274320"/>
-          </a:xfrm>
-          <a:prstGeom prst="rect">
-            <a:avLst/>
-          </a:prstGeom>
-          <a:noFill/>
-        </p:spPr>
-        <p:txBody>
-          <a:bodyPr wrap="square" lIns="0" tIns="0" rIns="0" bIns="0" anchor="t">
-            <a:spAutoFit/>
-          </a:bodyPr>
-          <a:lstStyle/>
-          <a:p>
-            <a:pPr algn="l"/>
-            <a:r>
-              <a:rPr sz="800" b="0" i="0">
-                <a:solidFill>
-                  <a:srgbClr val="757575"/>
-                </a:solidFill>
-                <a:latin typeface="Arial"/>
-              </a:rPr>
-              <a:t>Salomon NA eCommerce · Vestal Pro launch readout · Illustrative synthetic case data · Baseline: pre-period trend + weekly seasonality per category</a:t>
-            </a:r>
-          </a:p>
-        </p:txBody>
-      </p:sp>
-      <p:sp>
-        <p:nvSpPr>
-          <p:cNvPr id="11" name="TextBox 10"/>
-          <p:cNvSpPr txBox="1"/>
-          <p:nvPr/>
-        </p:nvSpPr>
-        <p:spPr>
-          <a:xfrm>
-            <a:off x="11292840" y="6510528"/>
-            <a:ext cx="411480" cy="274320"/>
-          </a:xfrm>
-          <a:prstGeom prst="rect">
-            <a:avLst/>
-          </a:prstGeom>
-          <a:noFill/>
-        </p:spPr>
-        <p:txBody>
-          <a:bodyPr wrap="square" lIns="0" tIns="0" rIns="0" bIns="0" anchor="t">
-            <a:spAutoFit/>
-          </a:bodyPr>
-          <a:lstStyle/>
-          <a:p>
-            <a:pPr algn="r"/>
-            <a:r>
-              <a:rPr sz="800" b="0" i="0">
-                <a:solidFill>
-                  <a:srgbClr val="757575"/>
-                </a:solidFill>
-                <a:latin typeface="Arial"/>
-              </a:rPr>
-              <a:t>9</a:t>
+              <a:t>7</a:t>
             </a:r>
           </a:p>
         </p:txBody>
       </p:sp>
       <p:pic>
         <p:nvPicPr>
-          <p:cNvPr id="12" name="Picture 11" descr="salomon_wordmark_black.png"/>
+          <p:cNvPr id="19" name="Picture 18" descr="salomon_wordmark_black.png">
+            <a:extLst>
+              <a:ext uri="{FF2B5EF4-FFF2-40B4-BE49-F238E27FC236}">
+                <a16:creationId xmlns:a16="http://schemas.microsoft.com/office/drawing/2014/main" id="{C54FDC2E-F88A-4793-C382-698F26484CEB}"/>
+              </a:ext>
+            </a:extLst>
+          </p:cNvPr>
           <p:cNvPicPr>
             <a:picLocks noChangeAspect="1"/>
           </p:cNvPicPr>
@@ -14447,11 +14448,376 @@
           </a:prstGeom>
         </p:spPr>
       </p:pic>
+      <p:pic>
+        <p:nvPicPr>
+          <p:cNvPr id="5" name="Picture 4" descr="The diagram illustrates the projected and actual customer lifetime values, including the first order, blended customer acquisition cost (CAC), and the cumulative value per customer over time.&#10;&#10;AI-generated content may be incorrect.">
+            <a:extLst>
+              <a:ext uri="{FF2B5EF4-FFF2-40B4-BE49-F238E27FC236}">
+                <a16:creationId xmlns:a16="http://schemas.microsoft.com/office/drawing/2014/main" id="{4BADB25B-6C91-F75F-9BCD-A697A8C85905}"/>
+              </a:ext>
+            </a:extLst>
+          </p:cNvPr>
+          <p:cNvPicPr>
+            <a:picLocks noChangeAspect="1"/>
+          </p:cNvPicPr>
+          <p:nvPr/>
+        </p:nvPicPr>
+        <p:blipFill>
+          <a:blip r:embed="rId4"/>
+          <a:stretch>
+            <a:fillRect/>
+          </a:stretch>
+        </p:blipFill>
+        <p:spPr>
+          <a:xfrm>
+            <a:off x="502919" y="1834765"/>
+            <a:ext cx="6484213" cy="4023537"/>
+          </a:xfrm>
+          <a:prstGeom prst="rect">
+            <a:avLst/>
+          </a:prstGeom>
+        </p:spPr>
+      </p:pic>
+      <p:cxnSp>
+        <p:nvCxnSpPr>
+          <p:cNvPr id="7" name="Straight Arrow Connector 6">
+            <a:extLst>
+              <a:ext uri="{FF2B5EF4-FFF2-40B4-BE49-F238E27FC236}">
+                <a16:creationId xmlns:a16="http://schemas.microsoft.com/office/drawing/2014/main" id="{B79F3486-0308-AEA3-B6CD-45160B32CA97}"/>
+              </a:ext>
+            </a:extLst>
+          </p:cNvPr>
+          <p:cNvCxnSpPr/>
+          <p:nvPr/>
+        </p:nvCxnSpPr>
+        <p:spPr>
+          <a:xfrm>
+            <a:off x="5877289" y="2135926"/>
+            <a:ext cx="0" cy="425789"/>
+          </a:xfrm>
+          <a:prstGeom prst="straightConnector1">
+            <a:avLst/>
+          </a:prstGeom>
+          <a:ln>
+            <a:solidFill>
+              <a:schemeClr val="tx2">
+                <a:lumMod val="50000"/>
+                <a:lumOff val="50000"/>
+              </a:schemeClr>
+            </a:solidFill>
+            <a:tailEnd type="triangle"/>
+          </a:ln>
+        </p:spPr>
+        <p:style>
+          <a:lnRef idx="2">
+            <a:schemeClr val="dk1"/>
+          </a:lnRef>
+          <a:fillRef idx="0">
+            <a:schemeClr val="dk1"/>
+          </a:fillRef>
+          <a:effectRef idx="1">
+            <a:schemeClr val="dk1"/>
+          </a:effectRef>
+          <a:fontRef idx="minor">
+            <a:schemeClr val="tx1"/>
+          </a:fontRef>
+        </p:style>
+      </p:cxnSp>
+      <p:sp>
+        <p:nvSpPr>
+          <p:cNvPr id="13" name="TextBox 12">
+            <a:extLst>
+              <a:ext uri="{FF2B5EF4-FFF2-40B4-BE49-F238E27FC236}">
+                <a16:creationId xmlns:a16="http://schemas.microsoft.com/office/drawing/2014/main" id="{9AED6645-9556-3AB4-7674-3147830657AB}"/>
+              </a:ext>
+            </a:extLst>
+          </p:cNvPr>
+          <p:cNvSpPr txBox="1"/>
+          <p:nvPr/>
+        </p:nvSpPr>
+        <p:spPr>
+          <a:xfrm>
+            <a:off x="5065149" y="1916665"/>
+            <a:ext cx="1779937" cy="261610"/>
+          </a:xfrm>
+          <a:prstGeom prst="rect">
+            <a:avLst/>
+          </a:prstGeom>
+          <a:noFill/>
+        </p:spPr>
+        <p:txBody>
+          <a:bodyPr wrap="square" rtlCol="0">
+            <a:spAutoFit/>
+          </a:bodyPr>
+          <a:lstStyle/>
+          <a:p>
+            <a:r>
+              <a:rPr lang="en-US" sz="1100" dirty="0">
+                <a:solidFill>
+                  <a:schemeClr val="tx2">
+                    <a:lumMod val="50000"/>
+                    <a:lumOff val="50000"/>
+                  </a:schemeClr>
+                </a:solidFill>
+                <a:latin typeface="Arial" panose="020B0604020202020204" pitchFamily="34" charset="0"/>
+                <a:cs typeface="Arial" panose="020B0604020202020204" pitchFamily="34" charset="0"/>
+              </a:rPr>
+              <a:t>Prior CLV cohort analysis</a:t>
+            </a:r>
+          </a:p>
+        </p:txBody>
+      </p:sp>
+      <p:sp>
+        <p:nvSpPr>
+          <p:cNvPr id="20" name="TextBox 19">
+            <a:extLst>
+              <a:ext uri="{FF2B5EF4-FFF2-40B4-BE49-F238E27FC236}">
+                <a16:creationId xmlns:a16="http://schemas.microsoft.com/office/drawing/2014/main" id="{2BAA0C35-1420-E2C8-050C-10BB01FA0712}"/>
+              </a:ext>
+            </a:extLst>
+          </p:cNvPr>
+          <p:cNvSpPr txBox="1"/>
+          <p:nvPr/>
+        </p:nvSpPr>
+        <p:spPr>
+          <a:xfrm>
+            <a:off x="7817805" y="1915228"/>
+            <a:ext cx="3589511" cy="2292038"/>
+          </a:xfrm>
+          <a:prstGeom prst="rect">
+            <a:avLst/>
+          </a:prstGeom>
+          <a:noFill/>
+        </p:spPr>
+        <p:txBody>
+          <a:bodyPr wrap="square" lIns="0" tIns="0" rIns="0" bIns="0" anchor="t">
+            <a:spAutoFit/>
+          </a:bodyPr>
+          <a:lstStyle/>
+          <a:p>
+            <a:pPr algn="ctr">
+              <a:lnSpc>
+                <a:spcPct val="112000"/>
+              </a:lnSpc>
+              <a:spcAft>
+                <a:spcPts val="900"/>
+              </a:spcAft>
+            </a:pPr>
+            <a:r>
+              <a:rPr lang="en-US" sz="1200" b="1" dirty="0">
+                <a:solidFill>
+                  <a:schemeClr val="tx2">
+                    <a:lumMod val="50000"/>
+                    <a:lumOff val="50000"/>
+                  </a:schemeClr>
+                </a:solidFill>
+                <a:latin typeface="Arial"/>
+              </a:rPr>
+              <a:t>LIFETIME VALUE</a:t>
+            </a:r>
+            <a:r>
+              <a:rPr lang="en-US" sz="1200" b="1" i="0" dirty="0">
+                <a:solidFill>
+                  <a:schemeClr val="tx2">
+                    <a:lumMod val="50000"/>
+                    <a:lumOff val="50000"/>
+                  </a:schemeClr>
+                </a:solidFill>
+                <a:latin typeface="Arial"/>
+              </a:rPr>
+              <a:t> BREAKDOWN</a:t>
+            </a:r>
+            <a:endParaRPr lang="en-US" sz="1200" b="1" dirty="0">
+              <a:solidFill>
+                <a:schemeClr val="tx2">
+                  <a:lumMod val="50000"/>
+                  <a:lumOff val="50000"/>
+                </a:schemeClr>
+              </a:solidFill>
+              <a:latin typeface="Arial"/>
+            </a:endParaRPr>
+          </a:p>
+          <a:p>
+            <a:pPr>
+              <a:spcAft>
+                <a:spcPts val="600"/>
+              </a:spcAft>
+            </a:pPr>
+            <a:r>
+              <a:rPr lang="en-US" sz="1200" dirty="0">
+                <a:solidFill>
+                  <a:schemeClr val="tx2">
+                    <a:lumMod val="75000"/>
+                    <a:lumOff val="25000"/>
+                  </a:schemeClr>
+                </a:solidFill>
+                <a:latin typeface="Arial"/>
+              </a:rPr>
+              <a:t>•  </a:t>
+            </a:r>
+            <a:r>
+              <a:rPr lang="en-US" sz="1200" b="1" dirty="0">
+                <a:solidFill>
+                  <a:schemeClr val="tx2">
+                    <a:lumMod val="75000"/>
+                    <a:lumOff val="25000"/>
+                  </a:schemeClr>
+                </a:solidFill>
+                <a:latin typeface="Arial"/>
+              </a:rPr>
+              <a:t>LTV Forecast of $387/customer </a:t>
+            </a:r>
+            <a:r>
+              <a:rPr lang="en-US" sz="1200" dirty="0">
+                <a:solidFill>
+                  <a:schemeClr val="tx2">
+                    <a:lumMod val="75000"/>
+                    <a:lumOff val="25000"/>
+                  </a:schemeClr>
+                </a:solidFill>
+                <a:latin typeface="Arial"/>
+              </a:rPr>
+              <a:t>at 24 months (3.8x CAC) based on prior CLV cohort analysis.</a:t>
+            </a:r>
+          </a:p>
+          <a:p>
+            <a:pPr>
+              <a:spcAft>
+                <a:spcPts val="600"/>
+              </a:spcAft>
+            </a:pPr>
+            <a:endParaRPr lang="en-US" sz="1200" dirty="0">
+              <a:solidFill>
+                <a:schemeClr val="tx2">
+                  <a:lumMod val="75000"/>
+                  <a:lumOff val="25000"/>
+                </a:schemeClr>
+              </a:solidFill>
+              <a:latin typeface="Arial"/>
+            </a:endParaRPr>
+          </a:p>
+          <a:p>
+            <a:pPr>
+              <a:spcAft>
+                <a:spcPts val="600"/>
+              </a:spcAft>
+            </a:pPr>
+            <a:r>
+              <a:rPr lang="en-US" sz="1200" dirty="0">
+                <a:solidFill>
+                  <a:schemeClr val="tx2">
+                    <a:lumMod val="75000"/>
+                    <a:lumOff val="25000"/>
+                  </a:schemeClr>
+                </a:solidFill>
+                <a:latin typeface="Arial"/>
+              </a:rPr>
+              <a:t>• </a:t>
+            </a:r>
+            <a:r>
+              <a:rPr lang="en-US" sz="1200" b="1" dirty="0">
+                <a:solidFill>
+                  <a:schemeClr val="tx2">
+                    <a:lumMod val="75000"/>
+                    <a:lumOff val="25000"/>
+                  </a:schemeClr>
+                </a:solidFill>
+                <a:latin typeface="Arial"/>
+              </a:rPr>
+              <a:t>Value is front-loaded: </a:t>
+            </a:r>
+            <a:r>
+              <a:rPr lang="en-US" sz="1200" dirty="0">
+                <a:solidFill>
+                  <a:schemeClr val="tx2">
+                    <a:lumMod val="75000"/>
+                    <a:lumOff val="25000"/>
+                  </a:schemeClr>
+                </a:solidFill>
+                <a:latin typeface="Arial"/>
+              </a:rPr>
+              <a:t>We will see most of the LTV within the first 12 months (Roughly 86% accrues within the first year).</a:t>
+            </a:r>
+          </a:p>
+          <a:p>
+            <a:pPr>
+              <a:spcAft>
+                <a:spcPts val="600"/>
+              </a:spcAft>
+            </a:pPr>
+            <a:endParaRPr lang="en-US" sz="1200" dirty="0">
+              <a:solidFill>
+                <a:schemeClr val="tx2">
+                  <a:lumMod val="75000"/>
+                  <a:lumOff val="25000"/>
+                </a:schemeClr>
+              </a:solidFill>
+              <a:latin typeface="Arial"/>
+            </a:endParaRPr>
+          </a:p>
+          <a:p>
+            <a:pPr>
+              <a:spcAft>
+                <a:spcPts val="600"/>
+              </a:spcAft>
+            </a:pPr>
+            <a:r>
+              <a:rPr lang="en-US" sz="1200" dirty="0">
+                <a:solidFill>
+                  <a:schemeClr val="tx2">
+                    <a:lumMod val="75000"/>
+                    <a:lumOff val="25000"/>
+                  </a:schemeClr>
+                </a:solidFill>
+                <a:latin typeface="Arial"/>
+              </a:rPr>
+              <a:t>• Currently </a:t>
+            </a:r>
+            <a:r>
+              <a:rPr lang="en-US" sz="1200" b="1" dirty="0">
+                <a:solidFill>
+                  <a:schemeClr val="tx2">
+                    <a:lumMod val="75000"/>
+                    <a:lumOff val="25000"/>
+                  </a:schemeClr>
+                </a:solidFill>
+                <a:latin typeface="Arial"/>
+              </a:rPr>
+              <a:t>outperforming </a:t>
+            </a:r>
+            <a:r>
+              <a:rPr lang="en-US" sz="1200" dirty="0">
+                <a:solidFill>
+                  <a:schemeClr val="tx2">
+                    <a:lumMod val="75000"/>
+                    <a:lumOff val="25000"/>
+                  </a:schemeClr>
+                </a:solidFill>
+                <a:latin typeface="Arial"/>
+              </a:rPr>
+              <a:t>LTV forecast at $188 after 4 weeks (1.8x CAC)</a:t>
+            </a:r>
+            <a:endParaRPr lang="en-US" sz="1200" dirty="0">
+              <a:latin typeface="Arial"/>
+            </a:endParaRPr>
+          </a:p>
+        </p:txBody>
+      </p:sp>
     </p:spTree>
+    <p:extLst>
+      <p:ext uri="{BB962C8B-B14F-4D97-AF65-F5344CB8AC3E}">
+        <p14:creationId xmlns:p14="http://schemas.microsoft.com/office/powerpoint/2010/main" val="4188150868"/>
+      </p:ext>
+    </p:extLst>
   </p:cSld>
   <p:clrMapOvr>
     <a:masterClrMapping/>
   </p:clrMapOvr>
+  <p:extLst>
+    <p:ext uri="{6950BFC3-D8DA-4A85-94F7-54DA5524770B}">
+      <p188:commentRel xmlns:p188="http://schemas.microsoft.com/office/powerpoint/2018/8/main" r:id="rId2"/>
+    </p:ext>
+  </p:extLst>
 </p:sld>
 </file>
 
@@ -14502,7 +14868,7 @@
                 </a:solidFill>
                 <a:latin typeface="Arial"/>
               </a:rPr>
-              <a:t>CHANNEL PERFORMANCE</a:t>
+              <a:t>HALO EFFECT</a:t>
             </a:r>
           </a:p>
         </p:txBody>
@@ -14516,7 +14882,7 @@
         <p:spPr>
           <a:xfrm>
             <a:off x="502920" y="566928"/>
-            <a:ext cx="11201400" cy="777240"/>
+            <a:ext cx="11201400" cy="353943"/>
           </a:xfrm>
           <a:prstGeom prst="rect">
             <a:avLst/>
@@ -14531,14 +14897,29 @@
           <a:p>
             <a:pPr algn="l"/>
             <a:r>
-              <a:rPr sz="2300" b="0" i="0">
+              <a:rPr sz="2300" b="0" i="0" dirty="0">
                 <a:solidFill>
                   <a:srgbClr val="000000"/>
                 </a:solidFill>
                 <a:latin typeface="Georgia"/>
               </a:rPr>
-              <a:t>CRM and affiliate cleared breakeven on incremental ROAS; paid media did not</a:t>
-            </a:r>
+              <a:t>Adjacent categories lifted +9%, but as standalone purchases, </a:t>
+            </a:r>
+            <a:r>
+              <a:rPr lang="en-US" sz="2300" b="0" i="0" dirty="0">
+                <a:solidFill>
+                  <a:srgbClr val="000000"/>
+                </a:solidFill>
+                <a:latin typeface="Georgia"/>
+              </a:rPr>
+              <a:t>bigger carts.</a:t>
+            </a:r>
+            <a:endParaRPr sz="2300" b="0" i="0" dirty="0">
+              <a:solidFill>
+                <a:srgbClr val="000000"/>
+              </a:solidFill>
+              <a:latin typeface="Georgia"/>
+            </a:endParaRPr>
           </a:p>
         </p:txBody>
       </p:sp>
@@ -14566,13 +14947,13 @@
           <a:p>
             <a:pPr algn="l"/>
             <a:r>
-              <a:rPr sz="1000" b="1" i="0">
+              <a:rPr sz="1000" b="1" i="0" dirty="0">
                 <a:solidFill>
                   <a:srgbClr val="757575"/>
                 </a:solidFill>
                 <a:latin typeface="Arial"/>
               </a:rPr>
-              <a:t>INCREMENTAL ROAS BY CHANNEL (BREAKEVEN = 1.0×)</a:t>
+              <a:t>ADJACENT-CATEGORY REVENUE VS EXPECTED BASELINE, ACTIVE FLIGHT</a:t>
             </a:r>
           </a:p>
         </p:txBody>
@@ -14587,7 +14968,7 @@
         </p:nvGraphicFramePr>
         <p:xfrm>
           <a:off x="365760" y="1828800"/>
-          <a:ext cx="6309360" cy="4114800"/>
+          <a:ext cx="6309360" cy="4023360"/>
         </p:xfrm>
         <a:graphic>
           <a:graphicData uri="http://schemas.openxmlformats.org/drawingml/2006/chart">
@@ -14603,8 +14984,155 @@
         </p:nvSpPr>
         <p:spPr>
           <a:xfrm>
-            <a:off x="7086600" y="1600200"/>
-            <a:ext cx="4572000" cy="4480560"/>
+            <a:off x="640080" y="5806440"/>
+            <a:ext cx="5852160" cy="320040"/>
+          </a:xfrm>
+          <a:prstGeom prst="rect">
+            <a:avLst/>
+          </a:prstGeom>
+          <a:noFill/>
+        </p:spPr>
+        <p:txBody>
+          <a:bodyPr wrap="square" lIns="0" tIns="0" rIns="0" bIns="0" anchor="t">
+            <a:spAutoFit/>
+          </a:bodyPr>
+          <a:lstStyle/>
+          <a:p>
+            <a:pPr algn="l"/>
+            <a:r>
+              <a:rPr sz="1000" b="0" i="0">
+                <a:solidFill>
+                  <a:srgbClr val="757575"/>
+                </a:solidFill>
+                <a:latin typeface="Arial"/>
+              </a:rPr>
+              <a:t>Success criterion ≥ +5%: </a:t>
+            </a:r>
+            <a:r>
+              <a:rPr sz="1000" b="1" i="0">
+                <a:solidFill>
+                  <a:srgbClr val="1F7A4D"/>
+                </a:solidFill>
+                <a:latin typeface="Arial"/>
+              </a:rPr>
+              <a:t>PASS</a:t>
+            </a:r>
+            <a:r>
+              <a:rPr sz="1000" b="0" i="0">
+                <a:solidFill>
+                  <a:srgbClr val="757575"/>
+                </a:solidFill>
+                <a:latin typeface="Arial"/>
+              </a:rPr>
+              <a:t>  (+9.2%, 95% CI +3.0% to +15.4% · +$7.9K)</a:t>
+            </a:r>
+          </a:p>
+        </p:txBody>
+      </p:sp>
+      <p:sp>
+        <p:nvSpPr>
+          <p:cNvPr id="7" name="TextBox 6"/>
+          <p:cNvSpPr txBox="1"/>
+          <p:nvPr/>
+        </p:nvSpPr>
+        <p:spPr>
+          <a:xfrm>
+            <a:off x="7086600" y="1481328"/>
+            <a:ext cx="4572000" cy="274320"/>
+          </a:xfrm>
+          <a:prstGeom prst="rect">
+            <a:avLst/>
+          </a:prstGeom>
+          <a:noFill/>
+        </p:spPr>
+        <p:txBody>
+          <a:bodyPr wrap="square" lIns="0" tIns="0" rIns="0" bIns="0" anchor="t">
+            <a:spAutoFit/>
+          </a:bodyPr>
+          <a:lstStyle/>
+          <a:p>
+            <a:pPr algn="l"/>
+            <a:r>
+              <a:rPr sz="1000" b="1" i="0">
+                <a:solidFill>
+                  <a:srgbClr val="757575"/>
+                </a:solidFill>
+                <a:latin typeface="Arial"/>
+              </a:rPr>
+              <a:t>ATTACH RATE TO VESTAL PRO ORDERS</a:t>
+            </a:r>
+          </a:p>
+        </p:txBody>
+      </p:sp>
+      <p:sp>
+        <p:nvSpPr>
+          <p:cNvPr id="8" name="TextBox 7"/>
+          <p:cNvSpPr txBox="1"/>
+          <p:nvPr/>
+        </p:nvSpPr>
+        <p:spPr>
+          <a:xfrm>
+            <a:off x="7086600" y="1828800"/>
+            <a:ext cx="4572000" cy="523220"/>
+          </a:xfrm>
+          <a:prstGeom prst="rect">
+            <a:avLst/>
+          </a:prstGeom>
+          <a:noFill/>
+        </p:spPr>
+        <p:txBody>
+          <a:bodyPr wrap="square" lIns="0" tIns="0" rIns="0" bIns="0" anchor="t">
+            <a:spAutoFit/>
+          </a:bodyPr>
+          <a:lstStyle/>
+          <a:p>
+            <a:pPr algn="l"/>
+            <a:r>
+              <a:rPr sz="3400" b="1" i="0" dirty="0">
+                <a:solidFill>
+                  <a:srgbClr val="333333"/>
+                </a:solidFill>
+                <a:latin typeface="Arial"/>
+              </a:rPr>
+              <a:t>17.8%</a:t>
+            </a:r>
+            <a:r>
+              <a:rPr sz="1300" b="0" i="0" dirty="0">
+                <a:solidFill>
+                  <a:srgbClr val="757575"/>
+                </a:solidFill>
+                <a:latin typeface="Arial"/>
+              </a:rPr>
+              <a:t>   flat vs 18.0% </a:t>
+            </a:r>
+            <a:r>
+              <a:rPr lang="en-US" sz="1300" b="0" i="0" dirty="0">
+                <a:solidFill>
+                  <a:srgbClr val="757575"/>
+                </a:solidFill>
+                <a:latin typeface="Arial"/>
+              </a:rPr>
+              <a:t>historical average</a:t>
+            </a:r>
+            <a:endParaRPr sz="1300" b="0" i="0" dirty="0">
+              <a:solidFill>
+                <a:srgbClr val="757575"/>
+              </a:solidFill>
+              <a:latin typeface="Arial"/>
+            </a:endParaRPr>
+          </a:p>
+        </p:txBody>
+      </p:sp>
+      <p:sp>
+        <p:nvSpPr>
+          <p:cNvPr id="9" name="TextBox 8"/>
+          <p:cNvSpPr txBox="1"/>
+          <p:nvPr/>
+        </p:nvSpPr>
+        <p:spPr>
+          <a:xfrm>
+            <a:off x="7086600" y="2834640"/>
+            <a:ext cx="4572000" cy="1378391"/>
           </a:xfrm>
           <a:prstGeom prst="rect">
             <a:avLst/>
@@ -14622,27 +15150,114 @@
                 <a:spcPct val="112000"/>
               </a:lnSpc>
               <a:spcAft>
-                <a:spcPts val="1000"/>
+                <a:spcPts val="800"/>
               </a:spcAft>
             </a:pPr>
             <a:r>
-              <a:rPr sz="1150" b="1" i="0">
+              <a:rPr sz="1150" b="0" i="0" dirty="0">
                 <a:solidFill>
                   <a:srgbClr val="333333"/>
                 </a:solidFill>
                 <a:latin typeface="Arial"/>
               </a:rPr>
-              <a:t>•  CRM: </a:t>
-            </a:r>
-            <a:r>
-              <a:rPr sz="1150" b="0" i="0">
+              <a:t>•  </a:t>
+            </a:r>
+            <a:r>
+              <a:rPr lang="en-US" sz="1150" b="0" i="0" dirty="0">
                 <a:solidFill>
                   <a:srgbClr val="333333"/>
                 </a:solidFill>
                 <a:latin typeface="Arial"/>
               </a:rPr>
-              <a:t>8% of spend, 44% of attributed revenue. Efficient activation of existing buyers — though without a holdout, high-intent audiences inflate its read.</a:t>
-            </a:r>
+              <a:t>Halo effect </a:t>
+            </a:r>
+            <a:r>
+              <a:rPr lang="en-US" sz="1150" dirty="0">
+                <a:solidFill>
+                  <a:srgbClr val="333333"/>
+                </a:solidFill>
+                <a:latin typeface="Arial"/>
+              </a:rPr>
+              <a:t>realized through increased </a:t>
+            </a:r>
+            <a:r>
+              <a:rPr lang="en-US" sz="1150" b="1" dirty="0">
+                <a:solidFill>
+                  <a:srgbClr val="333333"/>
+                </a:solidFill>
+                <a:latin typeface="Arial"/>
+              </a:rPr>
+              <a:t>standalone accessory purchases</a:t>
+            </a:r>
+            <a:r>
+              <a:rPr lang="en-US" sz="1150" dirty="0">
+                <a:solidFill>
+                  <a:srgbClr val="333333"/>
+                </a:solidFill>
+                <a:latin typeface="Arial"/>
+              </a:rPr>
+              <a:t>, driven by </a:t>
+            </a:r>
+            <a:r>
+              <a:rPr sz="1150" b="0" i="0" dirty="0">
+                <a:solidFill>
+                  <a:srgbClr val="333333"/>
+                </a:solidFill>
+                <a:latin typeface="Arial"/>
+              </a:rPr>
+              <a:t>campaign </a:t>
+            </a:r>
+            <a:r>
+              <a:rPr sz="1150" b="1" i="0" dirty="0">
+                <a:solidFill>
+                  <a:srgbClr val="333333"/>
+                </a:solidFill>
+                <a:latin typeface="Arial"/>
+              </a:rPr>
+              <a:t>traffic </a:t>
+            </a:r>
+            <a:r>
+              <a:rPr sz="1150" b="0" i="0" dirty="0">
+                <a:solidFill>
+                  <a:srgbClr val="333333"/>
+                </a:solidFill>
+                <a:latin typeface="Arial"/>
+              </a:rPr>
+              <a:t>and </a:t>
+            </a:r>
+            <a:r>
+              <a:rPr lang="en-US" sz="1150" b="0" i="0" dirty="0">
+                <a:solidFill>
+                  <a:srgbClr val="333333"/>
+                </a:solidFill>
+                <a:latin typeface="Arial"/>
+              </a:rPr>
+              <a:t>brand </a:t>
+            </a:r>
+            <a:r>
+              <a:rPr sz="1150" b="1" i="0" dirty="0">
+                <a:solidFill>
+                  <a:srgbClr val="333333"/>
+                </a:solidFill>
+                <a:latin typeface="Arial"/>
+              </a:rPr>
+              <a:t>awareness</a:t>
+            </a:r>
+            <a:r>
+              <a:rPr lang="en-US" sz="1150" b="0" i="0" dirty="0">
+                <a:solidFill>
+                  <a:srgbClr val="333333"/>
+                </a:solidFill>
+                <a:latin typeface="Arial"/>
+              </a:rPr>
+              <a:t>.</a:t>
+            </a:r>
+            <a:endParaRPr sz="1150" b="0" i="0" dirty="0">
+              <a:solidFill>
+                <a:srgbClr val="333333"/>
+              </a:solidFill>
+              <a:latin typeface="Arial"/>
+            </a:endParaRPr>
           </a:p>
           <a:p>
             <a:pPr algn="l">
@@ -14650,26 +15265,17 @@
                 <a:spcPct val="112000"/>
               </a:lnSpc>
               <a:spcAft>
-                <a:spcPts val="1000"/>
+                <a:spcPts val="800"/>
               </a:spcAft>
             </a:pPr>
             <a:r>
-              <a:rPr sz="1150" b="1" i="0">
+              <a:rPr sz="1150" b="0" i="0" dirty="0">
                 <a:solidFill>
                   <a:srgbClr val="333333"/>
                 </a:solidFill>
                 <a:latin typeface="Arial"/>
               </a:rPr>
-              <a:t>•  Paid social: </a:t>
-            </a:r>
-            <a:r>
-              <a:rPr sz="1150" b="0" i="0">
-                <a:solidFill>
-                  <a:srgbClr val="333333"/>
-                </a:solidFill>
-                <a:latin typeface="Arial"/>
-              </a:rPr>
-              <a:t>59% of spend at 0.3× iROAS — but it acquired 629 of 1,499 new customers (42%) at $147 CAC vs $212 early value. It pays back as acquisition, not immediate revenue; judge it on CAC and LTV.</a:t>
+              <a:t>•  Accessories led (+16.9%); apparel followed (+5.4%). Other footwear orders attached at the same 18% rate.</a:t>
             </a:r>
           </a:p>
           <a:p>
@@ -14678,61 +15284,75 @@
                 <a:spcPct val="112000"/>
               </a:lnSpc>
               <a:spcAft>
-                <a:spcPts val="1000"/>
+                <a:spcPts val="800"/>
               </a:spcAft>
             </a:pPr>
             <a:r>
-              <a:rPr sz="1150" b="1" i="0">
+              <a:rPr sz="1150" b="0" i="0" dirty="0">
                 <a:solidFill>
                   <a:srgbClr val="333333"/>
                 </a:solidFill>
                 <a:latin typeface="Arial"/>
               </a:rPr>
-              <a:t>•  Paid search: </a:t>
-            </a:r>
-            <a:r>
-              <a:rPr sz="1150" b="0" i="0">
+              <a:t>•  </a:t>
+            </a:r>
+            <a:r>
+              <a:rPr sz="1150" b="1" i="0" dirty="0">
                 <a:solidFill>
                   <a:srgbClr val="333333"/>
                 </a:solidFill>
                 <a:latin typeface="Arial"/>
               </a:rPr>
-              <a:t>0.9× — strong early flight, efficiency fell as core sizes stocked out while spend kept running.</a:t>
-            </a:r>
-          </a:p>
-          <a:p>
-            <a:pPr algn="l">
-              <a:lnSpc>
-                <a:spcPct val="112000"/>
-              </a:lnSpc>
-              <a:spcAft>
-                <a:spcPts val="1000"/>
-              </a:spcAft>
-            </a:pPr>
-            <a:r>
-              <a:rPr sz="1150" b="1" i="0">
-                <a:solidFill>
-                  <a:srgbClr val="757575"/>
-                </a:solidFill>
-                <a:latin typeface="Arial"/>
-              </a:rPr>
-              <a:t>•  Method: </a:t>
-            </a:r>
-            <a:r>
-              <a:rPr sz="1150" b="0" i="0">
-                <a:solidFill>
-                  <a:srgbClr val="757575"/>
-                </a:solidFill>
-                <a:latin typeface="Arial"/>
-              </a:rPr>
-              <a:t>iROAS = attributed ROAS × 0.31 site-level incrementality factor, applied uniformly (no holdout or geo split this flight). Attributed ROAS: Email 23.2×, SMS 8.3×, Affiliate 4.2×, Search 3.0×, Social 1.0×.</a:t>
-            </a:r>
-          </a:p>
-        </p:txBody>
-      </p:sp>
-      <p:sp>
-        <p:nvSpPr>
-          <p:cNvPr id="7" name="TextBox 6"/>
+              <a:t>Opportunity</a:t>
+            </a:r>
+            <a:r>
+              <a:rPr sz="1150" b="0" i="0" dirty="0">
+                <a:solidFill>
+                  <a:srgbClr val="333333"/>
+                </a:solidFill>
+                <a:latin typeface="Arial"/>
+              </a:rPr>
+              <a:t>: PDP bundles (socks, gaiters, hydration) and </a:t>
+            </a:r>
+            <a:r>
+              <a:rPr lang="en-US" sz="1150" b="0" i="0" dirty="0">
+                <a:solidFill>
+                  <a:srgbClr val="333333"/>
+                </a:solidFill>
+                <a:latin typeface="Arial"/>
+              </a:rPr>
+              <a:t>enhanced item-item recommendation</a:t>
+            </a:r>
+            <a:r>
+              <a:rPr lang="en-US" sz="1150" dirty="0">
+                <a:solidFill>
+                  <a:srgbClr val="333333"/>
+                </a:solidFill>
+                <a:latin typeface="Arial"/>
+              </a:rPr>
+              <a:t> systems </a:t>
+            </a:r>
+            <a:r>
+              <a:rPr lang="en-US" sz="1150" b="0" i="0">
+                <a:solidFill>
+                  <a:srgbClr val="333333"/>
+                </a:solidFill>
+                <a:latin typeface="Arial"/>
+              </a:rPr>
+              <a:t>to push bigger baskets.</a:t>
+            </a:r>
+            <a:endParaRPr sz="1150" b="0" i="0" dirty="0">
+              <a:solidFill>
+                <a:srgbClr val="333333"/>
+              </a:solidFill>
+              <a:latin typeface="Arial"/>
+            </a:endParaRPr>
+          </a:p>
+        </p:txBody>
+      </p:sp>
+      <p:sp>
+        <p:nvSpPr>
+          <p:cNvPr id="10" name="TextBox 9"/>
           <p:cNvSpPr txBox="1"/>
           <p:nvPr/>
         </p:nvSpPr>
@@ -14760,14 +15380,14 @@
                 </a:solidFill>
                 <a:latin typeface="Arial"/>
               </a:rPr>
-              <a:t>Salomon NA eCommerce · Vestal Pro launch readout · Illustrative synthetic case data</a:t>
-            </a:r>
-          </a:p>
-        </p:txBody>
-      </p:sp>
-      <p:sp>
-        <p:nvSpPr>
-          <p:cNvPr id="8" name="TextBox 7"/>
+              <a:t>Salomon NA eCommerce · Vestal Pro launch readout · Illustrative synthetic case data · Baseline: pre-period trend + weekly seasonality per category</a:t>
+            </a:r>
+          </a:p>
+        </p:txBody>
+      </p:sp>
+      <p:sp>
+        <p:nvSpPr>
+          <p:cNvPr id="11" name="TextBox 10"/>
           <p:cNvSpPr txBox="1"/>
           <p:nvPr/>
         </p:nvSpPr>
@@ -14795,14 +15415,14 @@
                 </a:solidFill>
                 <a:latin typeface="Arial"/>
               </a:rPr>
-              <a:t>10</a:t>
+              <a:t>9</a:t>
             </a:r>
           </a:p>
         </p:txBody>
       </p:sp>
       <p:pic>
         <p:nvPicPr>
-          <p:cNvPr id="9" name="Picture 8" descr="salomon_wordmark_black.png"/>
+          <p:cNvPr id="12" name="Picture 11" descr="salomon_wordmark_black.png"/>
           <p:cNvPicPr>
             <a:picLocks noChangeAspect="1"/>
           </p:cNvPicPr>

</xml_diff>

<commit_message>
Add deck-style adjacent-category halo chart
Add a deck-formatted adjacent-category lift chart to the halo section of
notebooks/campaign_analysis.ipynb: Trail Apparel +17.4%, Trail Accessories
+26.5%, All adjacent +20.3% (95% CI +13.6% to +27.0%, +$8.2K), with the
>= +5% pass criterion called out. Apparel/accessories in blue, combined in
black, matching the readout deck. Export plots/12 and update the deck.

Co-Authored-By: Claude Opus 4.8 <noreply@anthropic.com>
Claude-Session: https://claude.ai/code/session_01KwdrSE2C52Nb1R5kg16W6v
</commit_message>
<xml_diff>
--- a/deliverables/VestalPro_Campaign_Readout.pptx
+++ b/deliverables/VestalPro_Campaign_Readout.pptx
@@ -15132,7 +15132,7 @@
         <p:spPr>
           <a:xfrm>
             <a:off x="7086600" y="2834640"/>
-            <a:ext cx="4572000" cy="1378391"/>
+            <a:ext cx="4572000" cy="1576585"/>
           </a:xfrm>
           <a:prstGeom prst="rect">
             <a:avLst/>
@@ -15312,7 +15312,7 @@
                 </a:solidFill>
                 <a:latin typeface="Arial"/>
               </a:rPr>
-              <a:t>: PDP bundles (socks, gaiters, hydration) and </a:t>
+              <a:t>: PDP bundles (socks, </a:t>
             </a:r>
             <a:r>
               <a:rPr lang="en-US" sz="1150" b="0" i="0" dirty="0">
@@ -15321,6 +15321,24 @@
                 </a:solidFill>
                 <a:latin typeface="Arial"/>
               </a:rPr>
+              <a:t>jerseys</a:t>
+            </a:r>
+            <a:r>
+              <a:rPr sz="1150" b="0" i="0" dirty="0">
+                <a:solidFill>
+                  <a:srgbClr val="333333"/>
+                </a:solidFill>
+                <a:latin typeface="Arial"/>
+              </a:rPr>
+              <a:t>, hydration) and </a:t>
+            </a:r>
+            <a:r>
+              <a:rPr lang="en-US" sz="1150" b="0" i="0" dirty="0">
+                <a:solidFill>
+                  <a:srgbClr val="333333"/>
+                </a:solidFill>
+                <a:latin typeface="Arial"/>
+              </a:rPr>
               <a:t>enhanced item-item recommendation</a:t>
             </a:r>
             <a:r>
@@ -15333,13 +15351,13 @@
               <a:t> systems </a:t>
             </a:r>
             <a:r>
-              <a:rPr lang="en-US" sz="1150" b="0" i="0">
+              <a:rPr lang="en-US" sz="1150" b="0" i="0" dirty="0">
                 <a:solidFill>
                   <a:srgbClr val="333333"/>
                 </a:solidFill>
                 <a:latin typeface="Arial"/>
               </a:rPr>
-              <a:t>to push bigger baskets.</a:t>
+              <a:t>to support ancillary products.</a:t>
             </a:r>
             <a:endParaRPr sz="1150" b="0" i="0" dirty="0">
               <a:solidFill>
@@ -15359,7 +15377,7 @@
         <p:spPr>
           <a:xfrm>
             <a:off x="502920" y="6510528"/>
-            <a:ext cx="10515600" cy="274320"/>
+            <a:ext cx="10515600" cy="123111"/>
           </a:xfrm>
           <a:prstGeom prst="rect">
             <a:avLst/>
@@ -15374,13 +15392,13 @@
           <a:p>
             <a:pPr algn="l"/>
             <a:r>
-              <a:rPr sz="800" b="0" i="0">
+              <a:rPr sz="800" b="0" i="0" dirty="0">
                 <a:solidFill>
                   <a:srgbClr val="757575"/>
                 </a:solidFill>
                 <a:latin typeface="Arial"/>
               </a:rPr>
-              <a:t>Salomon NA eCommerce · Vestal Pro launch readout · Illustrative synthetic case data · Baseline: pre-period trend + weekly seasonality per category</a:t>
+              <a:t>Salomon NA eCommerce · Vestal Pro launch readout · Baseline: pre-period trend + weekly seasonality per category</a:t>
             </a:r>
           </a:p>
         </p:txBody>

</xml_diff>

<commit_message>
Update readout deck slides
Revise the readout deck: corrected acquisition/LTV, halo, channel,
brand-awareness, and inventory slides, and the rebuilt five-point
recommendations slide including cannibalization.

Co-Authored-By: Claude Opus 4.8 <noreply@anthropic.com>
Claude-Session: https://claude.ai/code/session_01KwdrSE2C52Nb1R5kg16W6v
</commit_message>
<xml_diff>
--- a/deliverables/VestalPro_Campaign_Readout.pptx
+++ b/deliverables/VestalPro_Campaign_Readout.pptx
@@ -5,7 +5,7 @@
     <p:sldMasterId id="2147483648" r:id="rId1"/>
   </p:sldMasterIdLst>
   <p:notesMasterIdLst>
-    <p:notesMasterId r:id="rId18"/>
+    <p:notesMasterId r:id="rId17"/>
   </p:notesMasterIdLst>
   <p:sldIdLst>
     <p:sldId id="256" r:id="rId2"/>
@@ -23,7 +23,6 @@
     <p:sldId id="268" r:id="rId14"/>
     <p:sldId id="272" r:id="rId15"/>
     <p:sldId id="269" r:id="rId16"/>
-    <p:sldId id="266" r:id="rId17"/>
   </p:sldIdLst>
   <p:sldSz cx="12192000" cy="6858000"/>
   <p:notesSz cx="6858000" cy="9144000"/>
@@ -168,6 +167,27 @@
 </p188:cmLst>
 </file>
 
+<file path=ppt/comments/modernComment_102_0.xml><?xml version="1.0" encoding="utf-8"?>
+<p188:cmLst xmlns:a="http://schemas.openxmlformats.org/drawingml/2006/main" xmlns:r="http://schemas.openxmlformats.org/officeDocument/2006/relationships" xmlns:p188="http://schemas.microsoft.com/office/powerpoint/2018/8/main">
+  <p188:cm id="{2532E033-8FC5-4A17-8ABC-1855FDCC5737}" authorId="{F7CB7528-0317-1151-A7B7-34D5B6A94F6F}" created="2026-07-18T22:30:59.564">
+    <pc:sldMkLst xmlns:pc="http://schemas.microsoft.com/office/powerpoint/2013/main/command">
+      <pc:docMk/>
+      <pc:sldMk cId="0" sldId="258"/>
+    </pc:sldMkLst>
+    <p188:txBody>
+      <a:bodyPr/>
+      <a:lstStyle/>
+      <a:p>
+        <a:r>
+          <a:rPr lang="en-US"/>
+          <a:t>Maybe too many words on this slide??</a:t>
+        </a:r>
+      </a:p>
+    </p188:txBody>
+  </p188:cm>
+</p188:cmLst>
+</file>
+
 <file path=ppt/comments/modernComment_111_F9A21C54.xml><?xml version="1.0" encoding="utf-8"?>
 <p188:cmLst xmlns:a="http://schemas.openxmlformats.org/drawingml/2006/main" xmlns:r="http://schemas.openxmlformats.org/officeDocument/2006/relationships" xmlns:p188="http://schemas.microsoft.com/office/powerpoint/2018/8/main">
   <p188:cm id="{B01D2F72-3A38-41AD-A3F8-C7F5E69541D1}" authorId="{F7CB7528-0317-1151-A7B7-34D5B6A94F6F}" created="2026-07-17T19:32:02.408">
@@ -616,6 +636,93 @@
     <p:extLst>
       <p:ext uri="{BB962C8B-B14F-4D97-AF65-F5344CB8AC3E}">
         <p14:creationId xmlns:p14="http://schemas.microsoft.com/office/powerpoint/2010/main" val="3239551481"/>
+      </p:ext>
+    </p:extLst>
+  </p:cSld>
+  <p:clrMapOvr>
+    <a:masterClrMapping/>
+  </p:clrMapOvr>
+</p:notes>
+</file>
+
+<file path=ppt/notesSlides/notesSlide2.xml><?xml version="1.0" encoding="utf-8"?>
+<p:notes xmlns:a="http://schemas.openxmlformats.org/drawingml/2006/main" xmlns:r="http://schemas.openxmlformats.org/officeDocument/2006/relationships" xmlns:p="http://schemas.openxmlformats.org/presentationml/2006/main">
+  <p:cSld>
+    <p:spTree>
+      <p:nvGrpSpPr>
+        <p:cNvPr id="1" name=""/>
+        <p:cNvGrpSpPr/>
+        <p:nvPr/>
+      </p:nvGrpSpPr>
+      <p:grpSpPr>
+        <a:xfrm>
+          <a:off x="0" y="0"/>
+          <a:ext cx="0" cy="0"/>
+          <a:chOff x="0" y="0"/>
+          <a:chExt cx="0" cy="0"/>
+        </a:xfrm>
+      </p:grpSpPr>
+      <p:sp>
+        <p:nvSpPr>
+          <p:cNvPr id="2" name="Slide Image Placeholder 1"/>
+          <p:cNvSpPr>
+            <a:spLocks noGrp="1" noRot="1" noChangeAspect="1"/>
+          </p:cNvSpPr>
+          <p:nvPr>
+            <p:ph type="sldImg"/>
+          </p:nvPr>
+        </p:nvSpPr>
+        <p:spPr/>
+      </p:sp>
+      <p:sp>
+        <p:nvSpPr>
+          <p:cNvPr id="3" name="Notes Placeholder 2"/>
+          <p:cNvSpPr>
+            <a:spLocks noGrp="1"/>
+          </p:cNvSpPr>
+          <p:nvPr>
+            <p:ph type="body" idx="1"/>
+          </p:nvPr>
+        </p:nvSpPr>
+        <p:spPr/>
+        <p:txBody>
+          <a:bodyPr/>
+          <a:lstStyle/>
+          <a:p>
+            <a:r>
+              <a:rPr lang="en-US" dirty="0"/>
+              <a:t>Weeks run from the June 1 launch; weeks 4–7 are post-campaign (Jun 21–Jul 19). Core-size availability = share of core sizes (M9–11, W7–9) in stock, daily average. PDP conversion = Vestal Pro units ÷ PDP views, 7-day average. Unmet demand = campaign-period conversion (4.6%) applied to weeks 4–7 PDP traffic, less actual units, at the $145 average selling price. Illustrative synthetic case data.</a:t>
+            </a:r>
+          </a:p>
+        </p:txBody>
+      </p:sp>
+      <p:sp>
+        <p:nvSpPr>
+          <p:cNvPr id="4" name="Slide Number Placeholder 3"/>
+          <p:cNvSpPr>
+            <a:spLocks noGrp="1"/>
+          </p:cNvSpPr>
+          <p:nvPr>
+            <p:ph type="sldNum" sz="quarter" idx="5"/>
+          </p:nvPr>
+        </p:nvSpPr>
+        <p:spPr/>
+        <p:txBody>
+          <a:bodyPr/>
+          <a:lstStyle/>
+          <a:p>
+            <a:fld id="{52C4B57B-4552-441A-AA75-72A3C605ADE9}" type="slidenum">
+              <a:rPr lang="en-US" smtClean="0"/>
+              <a:t>12</a:t>
+            </a:fld>
+            <a:endParaRPr lang="en-US"/>
+          </a:p>
+        </p:txBody>
+      </p:sp>
+    </p:spTree>
+    <p:extLst>
+      <p:ext uri="{BB962C8B-B14F-4D97-AF65-F5344CB8AC3E}">
+        <p14:creationId xmlns:p14="http://schemas.microsoft.com/office/powerpoint/2010/main" val="274521647"/>
       </p:ext>
     </p:extLst>
   </p:cSld>
@@ -5716,7 +5823,7 @@
           <p:nvPr/>
         </p:nvPicPr>
         <p:blipFill>
-          <a:blip r:embed="rId2"/>
+          <a:blip r:embed="rId3"/>
           <a:stretch>
             <a:fillRect/>
           </a:stretch>
@@ -5789,7 +5896,7 @@
         </p:nvSpPr>
         <p:spPr>
           <a:xfrm>
-            <a:off x="502920" y="566928"/>
+            <a:off x="502920" y="562478"/>
             <a:ext cx="11201400" cy="353943"/>
           </a:xfrm>
           <a:prstGeom prst="rect">
@@ -5830,8 +5937,8 @@
         </p:nvSpPr>
         <p:spPr>
           <a:xfrm>
-            <a:off x="7084194" y="1600774"/>
-            <a:ext cx="4572000" cy="3528210"/>
+            <a:off x="7011566" y="2241529"/>
+            <a:ext cx="4692754" cy="3138103"/>
           </a:xfrm>
           <a:prstGeom prst="rect">
             <a:avLst/>
@@ -5868,7 +5975,7 @@
                 </a:solidFill>
                 <a:latin typeface="Arial"/>
               </a:rPr>
-              <a:t>Inventory constraints (not demand)</a:t>
+              <a:t>Inventory (not demand)</a:t>
             </a:r>
             <a:r>
               <a:rPr lang="en-US" sz="1150" i="0" dirty="0">
@@ -5877,7 +5984,7 @@
                 </a:solidFill>
                 <a:latin typeface="Arial"/>
               </a:rPr>
-              <a:t> resulted in less demand capture. </a:t>
+              <a:t> constrained the campaign and demand capture. </a:t>
             </a:r>
             <a:r>
               <a:rPr lang="en-US" sz="1150" dirty="0">
@@ -5886,7 +5993,7 @@
                 </a:solidFill>
                 <a:latin typeface="Arial"/>
               </a:rPr>
-              <a:t>Core sizes fell below 90% threshold by week 3 of the campaign. </a:t>
+              <a:t>Core sizes fell below 90% threshold by week 3.</a:t>
             </a:r>
           </a:p>
           <a:p>
@@ -5905,14 +6012,27 @@
                 </a:solidFill>
                 <a:latin typeface="Arial"/>
               </a:rPr>
-              <a:t>• Unmet Demand: </a:t>
-            </a:r>
-            <a:endParaRPr lang="en-US" sz="1150" i="0" dirty="0">
-              <a:solidFill>
-                <a:srgbClr val="333333"/>
-              </a:solidFill>
-              <a:latin typeface="Arial"/>
-            </a:endParaRPr>
+              <a:t>• Conversion rate </a:t>
+            </a:r>
+            <a:r>
+              <a:rPr lang="en-US" sz="1150" dirty="0">
+                <a:solidFill>
+                  <a:srgbClr val="333333"/>
+                </a:solidFill>
+                <a:latin typeface="Arial"/>
+              </a:rPr>
+              <a:t>depression depressed from 4.6% </a:t>
+            </a:r>
+            <a:r>
+              <a:rPr lang="en-US" sz="1150" dirty="0">
+                <a:solidFill>
+                  <a:srgbClr val="333333"/>
+                </a:solidFill>
+                <a:latin typeface="Arial"/>
+                <a:sym typeface="Wingdings" panose="05000000000000000000" pitchFamily="2" charset="2"/>
+              </a:rPr>
+              <a:t> 3% due to inventory constraints. </a:t>
+            </a:r>
           </a:p>
           <a:p>
             <a:pPr>
@@ -5930,7 +6050,7 @@
                 </a:solidFill>
                 <a:latin typeface="Arial"/>
               </a:rPr>
-              <a:t>• Opportunity: </a:t>
+              <a:t>• Unmet Demand: </a:t>
             </a:r>
             <a:r>
               <a:rPr lang="en-US" sz="1150" dirty="0">
@@ -5939,17 +6059,11 @@
                 </a:solidFill>
                 <a:latin typeface="Arial"/>
               </a:rPr>
-              <a:t>Increase WOS purchasing plan on core sizes to create inventory buffer. </a:t>
-            </a:r>
-            <a:endParaRPr lang="en-US" sz="1150" i="0" dirty="0">
-              <a:solidFill>
-                <a:srgbClr val="333333"/>
-              </a:solidFill>
-              <a:latin typeface="Arial"/>
-            </a:endParaRPr>
-          </a:p>
-          <a:p>
-            <a:pPr algn="l">
+              <a:t>112 units // ~16.2K value, modeled through conversion drop from baseline.</a:t>
+            </a:r>
+          </a:p>
+          <a:p>
+            <a:pPr>
               <a:lnSpc>
                 <a:spcPct val="112000"/>
               </a:lnSpc>
@@ -5958,17 +6072,32 @@
               </a:spcAft>
             </a:pPr>
             <a:r>
-              <a:rPr sz="1150" b="0" i="0" dirty="0">
-                <a:solidFill>
-                  <a:srgbClr val="333333"/>
-                </a:solidFill>
-                <a:latin typeface="Arial"/>
-              </a:rPr>
-              <a:t>•  Vestal Pro sell-through conversion fell 35% (5.2% weeks 1–3 → 3.4% week 6) while paid media kept sending traffic.</a:t>
-            </a:r>
-          </a:p>
-          <a:p>
-            <a:pPr algn="l">
+              <a:rPr lang="en-US" sz="1150" b="1" dirty="0">
+                <a:solidFill>
+                  <a:srgbClr val="333333"/>
+                </a:solidFill>
+                <a:latin typeface="Arial"/>
+              </a:rPr>
+              <a:t>• No substitution offset </a:t>
+            </a:r>
+            <a:r>
+              <a:rPr lang="en-US" sz="1150" dirty="0">
+                <a:solidFill>
+                  <a:srgbClr val="333333"/>
+                </a:solidFill>
+                <a:latin typeface="Arial"/>
+              </a:rPr>
+              <a:t>counteracted lost Vestral Pro sales. Adjacent shoe categories held flat.</a:t>
+            </a:r>
+            <a:endParaRPr lang="en-US" sz="1150" i="0" dirty="0">
+              <a:solidFill>
+                <a:srgbClr val="333333"/>
+              </a:solidFill>
+              <a:latin typeface="Arial"/>
+            </a:endParaRPr>
+          </a:p>
+          <a:p>
+            <a:pPr>
               <a:lnSpc>
                 <a:spcPct val="112000"/>
               </a:lnSpc>
@@ -5977,17 +6106,40 @@
               </a:spcAft>
             </a:pPr>
             <a:r>
-              <a:rPr sz="1150" b="0" i="0" dirty="0">
-                <a:solidFill>
-                  <a:srgbClr val="333333"/>
-                </a:solidFill>
-                <a:latin typeface="Arial"/>
-              </a:rPr>
-              <a:t>•  Modeled unmet demand: ≈140 units, ≈$20.4K, from applying early-flight conversion to weeks 4–6 traffic.</a:t>
-            </a:r>
-          </a:p>
-          <a:p>
-            <a:pPr algn="l">
+              <a:rPr lang="en-US" sz="1150" b="1" dirty="0">
+                <a:solidFill>
+                  <a:srgbClr val="333333"/>
+                </a:solidFill>
+                <a:latin typeface="Arial"/>
+              </a:rPr>
+              <a:t>• Opportunity:</a:t>
+            </a:r>
+          </a:p>
+          <a:p>
+            <a:r>
+              <a:rPr lang="en-US" sz="1150" dirty="0">
+                <a:solidFill>
+                  <a:srgbClr val="333333"/>
+                </a:solidFill>
+                <a:latin typeface="Arial"/>
+              </a:rPr>
+              <a:t>    • Increase WOS purchasing plan on core sizes to create sales buffer.</a:t>
+            </a:r>
+          </a:p>
+          <a:p>
+            <a:r>
+              <a:rPr lang="en-US" sz="1150" dirty="0">
+                <a:solidFill>
+                  <a:srgbClr val="333333"/>
+                </a:solidFill>
+                <a:latin typeface="Arial"/>
+              </a:rPr>
+              <a:t>    • Tie inventory indicators to purchasing and paid media actions including replenishment triggers and paid spend throttling. </a:t>
+            </a:r>
+            <a:endParaRPr lang="en-US" sz="1200" dirty="0"/>
+          </a:p>
+          <a:p>
+            <a:pPr>
               <a:lnSpc>
                 <a:spcPct val="112000"/>
               </a:lnSpc>
@@ -5995,52 +6147,12 @@
                 <a:spcPts val="1000"/>
               </a:spcAft>
             </a:pPr>
-            <a:r>
-              <a:rPr sz="1150" b="0" i="0" dirty="0">
-                <a:solidFill>
-                  <a:srgbClr val="333333"/>
-                </a:solidFill>
-                <a:latin typeface="Arial"/>
-              </a:rPr>
-              <a:t>•  Site conversion followed: 2.52% week 1 → 2.23% week 6, below the 2.33% pre-period average.</a:t>
-            </a:r>
-          </a:p>
-          <a:p>
-            <a:pPr algn="l">
-              <a:lnSpc>
-                <a:spcPct val="112000"/>
-              </a:lnSpc>
-              <a:spcAft>
-                <a:spcPts val="1000"/>
-              </a:spcAft>
-            </a:pPr>
-            <a:r>
-              <a:rPr sz="1150" b="0" i="0" dirty="0">
-                <a:solidFill>
-                  <a:srgbClr val="333333"/>
-                </a:solidFill>
-                <a:latin typeface="Arial"/>
-              </a:rPr>
-              <a:t>•  </a:t>
-            </a:r>
-            <a:r>
-              <a:rPr sz="1150" b="0" i="0" dirty="0" err="1">
-                <a:solidFill>
-                  <a:srgbClr val="333333"/>
-                </a:solidFill>
-                <a:latin typeface="Arial"/>
-              </a:rPr>
-              <a:t>Speedcross</a:t>
-            </a:r>
-            <a:r>
-              <a:rPr sz="1150" b="0" i="0" dirty="0">
-                <a:solidFill>
-                  <a:srgbClr val="333333"/>
-                </a:solidFill>
-                <a:latin typeface="Arial"/>
-              </a:rPr>
-              <a:t> picked up +14% units as shoppers substituted — a partial, lower-price offset.</a:t>
-            </a:r>
+            <a:endParaRPr sz="1150" b="0" i="0" dirty="0">
+              <a:solidFill>
+                <a:srgbClr val="333333"/>
+              </a:solidFill>
+              <a:latin typeface="Arial"/>
+            </a:endParaRPr>
           </a:p>
         </p:txBody>
       </p:sp>
@@ -6123,7 +6235,7 @@
           <p:nvPr/>
         </p:nvPicPr>
         <p:blipFill>
-          <a:blip r:embed="rId3"/>
+          <a:blip r:embed="rId4"/>
           <a:stretch>
             <a:fillRect/>
           </a:stretch>
@@ -6340,6 +6452,153 @@
                 </a:solidFill>
               </a:rPr>
               <a:t>June 1  Campaign Start</a:t>
+            </a:r>
+          </a:p>
+        </p:txBody>
+      </p:sp>
+      <p:sp>
+        <p:nvSpPr>
+          <p:cNvPr id="27" name="TextBox 26">
+            <a:extLst>
+              <a:ext uri="{FF2B5EF4-FFF2-40B4-BE49-F238E27FC236}">
+                <a16:creationId xmlns:a16="http://schemas.microsoft.com/office/drawing/2014/main" id="{533385BE-5ABE-2284-3C03-5F02C31A420F}"/>
+              </a:ext>
+            </a:extLst>
+          </p:cNvPr>
+          <p:cNvSpPr txBox="1"/>
+          <p:nvPr/>
+        </p:nvSpPr>
+        <p:spPr>
+          <a:xfrm>
+            <a:off x="6908093" y="1828845"/>
+            <a:ext cx="2324995" cy="276999"/>
+          </a:xfrm>
+          <a:prstGeom prst="rect">
+            <a:avLst/>
+          </a:prstGeom>
+          <a:noFill/>
+        </p:spPr>
+        <p:txBody>
+          <a:bodyPr wrap="none" rtlCol="0">
+            <a:spAutoFit/>
+          </a:bodyPr>
+          <a:lstStyle/>
+          <a:p>
+            <a:r>
+              <a:rPr lang="en-US" sz="1200" b="1" dirty="0">
+                <a:solidFill>
+                  <a:schemeClr val="tx2">
+                    <a:lumMod val="50000"/>
+                    <a:lumOff val="50000"/>
+                  </a:schemeClr>
+                </a:solidFill>
+                <a:latin typeface="Arial" panose="020B0604020202020204" pitchFamily="34" charset="0"/>
+                <a:cs typeface="Arial" panose="020B0604020202020204" pitchFamily="34" charset="0"/>
+              </a:rPr>
+              <a:t>DEMAND OUTLIVED SUPPLY</a:t>
+            </a:r>
+          </a:p>
+        </p:txBody>
+      </p:sp>
+      <p:cxnSp>
+        <p:nvCxnSpPr>
+          <p:cNvPr id="36" name="Straight Arrow Connector 35">
+            <a:extLst>
+              <a:ext uri="{FF2B5EF4-FFF2-40B4-BE49-F238E27FC236}">
+                <a16:creationId xmlns:a16="http://schemas.microsoft.com/office/drawing/2014/main" id="{0E54AC80-F1C8-395A-031B-55B86C63EB0E}"/>
+              </a:ext>
+            </a:extLst>
+          </p:cNvPr>
+          <p:cNvCxnSpPr>
+            <a:cxnSpLocks/>
+          </p:cNvCxnSpPr>
+          <p:nvPr/>
+        </p:nvCxnSpPr>
+        <p:spPr>
+          <a:xfrm flipH="1">
+            <a:off x="2958912" y="1882171"/>
+            <a:ext cx="722945" cy="399580"/>
+          </a:xfrm>
+          <a:prstGeom prst="straightConnector1">
+            <a:avLst/>
+          </a:prstGeom>
+          <a:ln>
+            <a:solidFill>
+              <a:schemeClr val="tx2">
+                <a:lumMod val="50000"/>
+                <a:lumOff val="50000"/>
+              </a:schemeClr>
+            </a:solidFill>
+            <a:tailEnd type="triangle"/>
+          </a:ln>
+        </p:spPr>
+        <p:style>
+          <a:lnRef idx="2">
+            <a:schemeClr val="accent1"/>
+          </a:lnRef>
+          <a:fillRef idx="0">
+            <a:schemeClr val="accent1"/>
+          </a:fillRef>
+          <a:effectRef idx="1">
+            <a:schemeClr val="accent1"/>
+          </a:effectRef>
+          <a:fontRef idx="minor">
+            <a:schemeClr val="tx1"/>
+          </a:fontRef>
+        </p:style>
+      </p:cxnSp>
+      <p:sp>
+        <p:nvSpPr>
+          <p:cNvPr id="35" name="TextBox 34">
+            <a:extLst>
+              <a:ext uri="{FF2B5EF4-FFF2-40B4-BE49-F238E27FC236}">
+                <a16:creationId xmlns:a16="http://schemas.microsoft.com/office/drawing/2014/main" id="{0418E6C6-1DF5-6D65-7AF1-E25B0CA107E5}"/>
+              </a:ext>
+            </a:extLst>
+          </p:cNvPr>
+          <p:cNvSpPr txBox="1"/>
+          <p:nvPr/>
+        </p:nvSpPr>
+        <p:spPr>
+          <a:xfrm>
+            <a:off x="3621535" y="1611291"/>
+            <a:ext cx="1136954" cy="338554"/>
+          </a:xfrm>
+          <a:prstGeom prst="rect">
+            <a:avLst/>
+          </a:prstGeom>
+        </p:spPr>
+        <p:style>
+          <a:lnRef idx="1">
+            <a:schemeClr val="dk1"/>
+          </a:lnRef>
+          <a:fillRef idx="2">
+            <a:schemeClr val="dk1"/>
+          </a:fillRef>
+          <a:effectRef idx="1">
+            <a:schemeClr val="dk1"/>
+          </a:effectRef>
+          <a:fontRef idx="minor">
+            <a:schemeClr val="dk1"/>
+          </a:fontRef>
+        </p:style>
+        <p:txBody>
+          <a:bodyPr wrap="square" rtlCol="0">
+            <a:spAutoFit/>
+          </a:bodyPr>
+          <a:lstStyle/>
+          <a:p>
+            <a:pPr algn="ctr"/>
+            <a:r>
+              <a:rPr lang="en-US" sz="800" dirty="0">
+                <a:solidFill>
+                  <a:schemeClr val="tx2">
+                    <a:lumMod val="50000"/>
+                    <a:lumOff val="50000"/>
+                  </a:schemeClr>
+                </a:solidFill>
+              </a:rPr>
+              <a:t>Traffic follows paid media divestment</a:t>
             </a:r>
           </a:p>
         </p:txBody>
@@ -6378,7 +6637,7 @@
         <p:spPr>
           <a:xfrm>
             <a:off x="0" y="-6016"/>
-            <a:ext cx="12191695" cy="6858000"/>
+            <a:ext cx="12191695" cy="6864016"/>
           </a:xfrm>
           <a:prstGeom prst="rect">
             <a:avLst/>
@@ -6533,7 +6792,7 @@
         </p:nvSpPr>
         <p:spPr>
           <a:xfrm>
-            <a:off x="1417320" y="1618488"/>
+            <a:off x="1405288" y="1618488"/>
             <a:ext cx="9966960" cy="384657"/>
           </a:xfrm>
           <a:prstGeom prst="rect">
@@ -6559,25 +6818,16 @@
                 </a:solidFill>
                 <a:latin typeface="Arial"/>
               </a:rPr>
-              <a:t>Buy deeper on core sizes.  </a:t>
-            </a:r>
-            <a:r>
-              <a:rPr sz="1150" b="0" i="0" dirty="0">
+              <a:t>Buy deeper on core sizes</a:t>
+            </a:r>
+            <a:r>
+              <a:rPr lang="en-US" sz="1150" dirty="0">
                 <a:solidFill>
                   <a:srgbClr val="BFD5ED"/>
                 </a:solidFill>
                 <a:latin typeface="Arial"/>
               </a:rPr>
-              <a:t>Week-3 depletion of M9–11 / W7–9 cost ≈140 units (≈$20K) and dragged site conversion below baseline by week 6.</a:t>
-            </a:r>
-            <a:r>
-              <a:rPr lang="en-US" sz="1150" b="0" i="0" dirty="0">
-                <a:solidFill>
-                  <a:srgbClr val="BFD5ED"/>
-                </a:solidFill>
-                <a:latin typeface="Arial"/>
-              </a:rPr>
-              <a:t> Increasing WOS purchasing plan on core sizes will support additional demand. </a:t>
+              <a:t> and replenish behind the launch. Core-size availability broke 90% in week 2 and bottomed near 43%, costing ≈112 units (≈$16.2K). Increase the WOS purchasing plan on core sizes and trigger replenishment order when ATS breaks threshold.</a:t>
             </a:r>
             <a:endParaRPr sz="1150" b="0" i="0" dirty="0">
               <a:solidFill>
@@ -6632,7 +6882,7 @@
         <p:spPr>
           <a:xfrm>
             <a:off x="1417320" y="2404872"/>
-            <a:ext cx="9966960" cy="749808"/>
+            <a:ext cx="9966960" cy="384657"/>
           </a:xfrm>
           <a:prstGeom prst="rect">
             <a:avLst/>
@@ -6651,41 +6901,29 @@
               </a:lnSpc>
             </a:pPr>
             <a:r>
-              <a:rPr sz="1250" b="1" i="0" dirty="0">
+              <a:rPr lang="en-US" sz="1250" b="1" i="0" dirty="0">
                 <a:solidFill>
                   <a:srgbClr val="FFFFFF"/>
                 </a:solidFill>
                 <a:latin typeface="Arial"/>
               </a:rPr>
-              <a:t>Tie paid media to inventory signals.  </a:t>
-            </a:r>
-            <a:r>
-              <a:rPr sz="1150" b="0" i="0" dirty="0">
+              <a:t>Gate and rebalance paid media.</a:t>
+            </a:r>
+            <a:r>
+              <a:rPr lang="en-US" sz="1150" dirty="0">
                 <a:solidFill>
                   <a:srgbClr val="BFD5ED"/>
                 </a:solidFill>
                 <a:latin typeface="Arial"/>
               </a:rPr>
-              <a:t>Throttle prospecting when core-size availability drops below 80%. Paid social ran 59% of budget at 0.3× </a:t>
-            </a:r>
-            <a:r>
-              <a:rPr sz="1150" b="0" i="0" dirty="0" err="1">
-                <a:solidFill>
-                  <a:srgbClr val="BFD5ED"/>
-                </a:solidFill>
-                <a:latin typeface="Arial"/>
-              </a:rPr>
-              <a:t>iROAS</a:t>
-            </a:r>
-            <a:r>
-              <a:rPr sz="1150" b="0" i="0" dirty="0">
-                <a:solidFill>
-                  <a:srgbClr val="BFD5ED"/>
-                </a:solidFill>
-                <a:latin typeface="Arial"/>
-              </a:rPr>
-              <a:t> into a constrained assortment; reallocate mid-flight to CRM and search.</a:t>
-            </a:r>
+              <a:t> Tie spend to inventory signals. Throttle when core availability breaks 90% rather than pushing traffic into a broken size curve. 41% of new customers at $151 CAC vs $188 early value; set the CAC target pre-launch and add a day-90 LTV readout.</a:t>
+            </a:r>
+            <a:endParaRPr sz="1150" b="0" i="0" dirty="0">
+              <a:solidFill>
+                <a:srgbClr val="BFD5ED"/>
+              </a:solidFill>
+              <a:latin typeface="Arial"/>
+            </a:endParaRPr>
           </a:p>
         </p:txBody>
       </p:sp>
@@ -6733,7 +6971,7 @@
         <p:spPr>
           <a:xfrm>
             <a:off x="1417320" y="3191256"/>
-            <a:ext cx="9966960" cy="749808"/>
+            <a:ext cx="9966960" cy="384657"/>
           </a:xfrm>
           <a:prstGeom prst="rect">
             <a:avLst/>
@@ -6758,17 +6996,23 @@
                 </a:solidFill>
                 <a:latin typeface="Arial"/>
               </a:rPr>
-              <a:t>Judge paid social on acquisition economics, not last-click revenue.  </a:t>
-            </a:r>
-            <a:r>
-              <a:rPr sz="1150" b="0" i="0" dirty="0">
+              <a:t>Judge paid social on acquisition economics, not last-click revenue. </a:t>
+            </a:r>
+            <a:r>
+              <a:rPr lang="en-US" sz="1150" dirty="0">
                 <a:solidFill>
                   <a:srgbClr val="BFD5ED"/>
                 </a:solidFill>
                 <a:latin typeface="Arial"/>
               </a:rPr>
-              <a:t>It delivered 42% of new customers at $147 CAC against $212 early customer value. Set a CAC target pre-launch and add a day-90 LTV readout.</a:t>
-            </a:r>
+              <a:t>41% of new customers at $151 CAC vs $188 early value; set the CAC target pre-launch and add a day-90 LTV forecast.</a:t>
+            </a:r>
+            <a:endParaRPr sz="1150" b="0" i="0" dirty="0">
+              <a:solidFill>
+                <a:srgbClr val="BFD5ED"/>
+              </a:solidFill>
+              <a:latin typeface="Arial"/>
+            </a:endParaRPr>
           </a:p>
         </p:txBody>
       </p:sp>
@@ -6844,14 +7088,14 @@
       </p:sp>
       <p:sp>
         <p:nvSpPr>
-          <p:cNvPr id="14" name="TextBox 13"/>
+          <p:cNvPr id="16" name="TextBox 15"/>
           <p:cNvSpPr txBox="1"/>
           <p:nvPr/>
         </p:nvSpPr>
         <p:spPr>
           <a:xfrm>
-            <a:off x="1417320" y="3959352"/>
-            <a:ext cx="9966960" cy="749808"/>
+            <a:off x="1417320" y="4713009"/>
+            <a:ext cx="9966960" cy="384657"/>
           </a:xfrm>
           <a:prstGeom prst="rect">
             <a:avLst/>
@@ -6864,42 +7108,48 @@
           </a:bodyPr>
           <a:lstStyle/>
           <a:p>
-            <a:pPr algn="l">
+            <a:pPr>
               <a:lnSpc>
                 <a:spcPct val="108000"/>
               </a:lnSpc>
             </a:pPr>
             <a:r>
-              <a:rPr sz="1250" b="1" i="0" dirty="0">
+              <a:rPr lang="en-US" sz="1250" b="1" dirty="0">
                 <a:solidFill>
                   <a:srgbClr val="FFFFFF"/>
                 </a:solidFill>
                 <a:latin typeface="Arial"/>
               </a:rPr>
-              <a:t>Convert the halo into baskets.  </a:t>
-            </a:r>
-            <a:r>
-              <a:rPr sz="1150" b="0" i="0" dirty="0">
+              <a:t>Support additional halo effects. </a:t>
+            </a:r>
+            <a:r>
+              <a:rPr lang="en-US" sz="1150" dirty="0">
                 <a:solidFill>
                   <a:srgbClr val="BFD5ED"/>
                 </a:solidFill>
                 <a:latin typeface="Arial"/>
               </a:rPr>
-              <a:t>Adjacent demand lifted +9% but attach to Vestal Pro orders stayed flat at 18%. Bundle socks and accessories at PDP and activate the 2,776 email / 1,447 SMS adds on cross-category journeys.</a:t>
-            </a:r>
-          </a:p>
-        </p:txBody>
-      </p:sp>
-      <p:sp>
-        <p:nvSpPr>
-          <p:cNvPr id="15" name="TextBox 14"/>
+              <a:t>Double down on PDP bundles and item-item recommendations. Message buyers to push cross selling-products and common follow-up purchases.</a:t>
+            </a:r>
+            <a:endParaRPr sz="1150" b="0" i="0" dirty="0">
+              <a:solidFill>
+                <a:srgbClr val="BFD5ED"/>
+              </a:solidFill>
+              <a:latin typeface="Arial"/>
+            </a:endParaRPr>
+          </a:p>
+        </p:txBody>
+      </p:sp>
+      <p:sp>
+        <p:nvSpPr>
+          <p:cNvPr id="17" name="TextBox 16"/>
           <p:cNvSpPr txBox="1"/>
           <p:nvPr/>
         </p:nvSpPr>
         <p:spPr>
           <a:xfrm>
-            <a:off x="822960" y="5532120"/>
-            <a:ext cx="502920" cy="731520"/>
+            <a:off x="822960" y="6510528"/>
+            <a:ext cx="10515600" cy="123111"/>
           </a:xfrm>
           <a:prstGeom prst="rect">
             <a:avLst/>
@@ -6914,96 +7164,13 @@
           <a:p>
             <a:pPr algn="l"/>
             <a:r>
-              <a:rPr sz="2000" b="1" i="0">
-                <a:solidFill>
-                  <a:srgbClr val="0057B8"/>
-                </a:solidFill>
-                <a:latin typeface="Arial"/>
-              </a:rPr>
-              <a:t>6</a:t>
-            </a:r>
-          </a:p>
-        </p:txBody>
-      </p:sp>
-      <p:sp>
-        <p:nvSpPr>
-          <p:cNvPr id="16" name="TextBox 15"/>
-          <p:cNvSpPr txBox="1"/>
-          <p:nvPr/>
-        </p:nvSpPr>
-        <p:spPr>
-          <a:xfrm>
-            <a:off x="1417320" y="4713009"/>
-            <a:ext cx="9966960" cy="749808"/>
-          </a:xfrm>
-          <a:prstGeom prst="rect">
-            <a:avLst/>
-          </a:prstGeom>
-          <a:noFill/>
-        </p:spPr>
-        <p:txBody>
-          <a:bodyPr wrap="square" lIns="0" tIns="0" rIns="0" bIns="0" anchor="t">
-            <a:spAutoFit/>
-          </a:bodyPr>
-          <a:lstStyle/>
-          <a:p>
-            <a:pPr algn="l">
-              <a:lnSpc>
-                <a:spcPct val="108000"/>
-              </a:lnSpc>
-            </a:pPr>
-            <a:r>
-              <a:rPr sz="1250" b="1" i="0" dirty="0">
-                <a:solidFill>
-                  <a:srgbClr val="FFFFFF"/>
-                </a:solidFill>
-                <a:latin typeface="Arial"/>
-              </a:rPr>
-              <a:t>Instrument incrementality before launch day.  </a:t>
-            </a:r>
-            <a:r>
-              <a:rPr sz="1150" b="0" i="0" dirty="0">
-                <a:solidFill>
-                  <a:srgbClr val="BFD5ED"/>
-                </a:solidFill>
-                <a:latin typeface="Arial"/>
-              </a:rPr>
-              <a:t>Field a CRM holdout and a geo split, set numeric revenue / CAC / database targets, and track COGS and unsubscribes so the next readout measures margin, not proxies.</a:t>
-            </a:r>
-          </a:p>
-        </p:txBody>
-      </p:sp>
-      <p:sp>
-        <p:nvSpPr>
-          <p:cNvPr id="17" name="TextBox 16"/>
-          <p:cNvSpPr txBox="1"/>
-          <p:nvPr/>
-        </p:nvSpPr>
-        <p:spPr>
-          <a:xfrm>
-            <a:off x="822960" y="6510528"/>
-            <a:ext cx="10515600" cy="274320"/>
-          </a:xfrm>
-          <a:prstGeom prst="rect">
-            <a:avLst/>
-          </a:prstGeom>
-          <a:noFill/>
-        </p:spPr>
-        <p:txBody>
-          <a:bodyPr wrap="square" lIns="0" tIns="0" rIns="0" bIns="0" anchor="t">
-            <a:spAutoFit/>
-          </a:bodyPr>
-          <a:lstStyle/>
-          <a:p>
-            <a:pPr algn="l"/>
-            <a:r>
-              <a:rPr sz="800" b="0" i="0">
+              <a:rPr sz="800" b="0" i="0" dirty="0">
                 <a:solidFill>
                   <a:srgbClr val="757575"/>
                 </a:solidFill>
                 <a:latin typeface="Arial"/>
               </a:rPr>
-              <a:t>Salomon NA eCommerce · Vestal Pro launch readout · Illustrative synthetic case data</a:t>
+              <a:t>Salomon NA eCommerce · Vestal Pro launch readout</a:t>
             </a:r>
           </a:p>
         </p:txBody>
@@ -7034,10 +7201,10 @@
       </p:pic>
       <p:sp>
         <p:nvSpPr>
-          <p:cNvPr id="20" name="TextBox 19">
+          <p:cNvPr id="22" name="TextBox 21">
             <a:extLst>
               <a:ext uri="{FF2B5EF4-FFF2-40B4-BE49-F238E27FC236}">
-                <a16:creationId xmlns:a16="http://schemas.microsoft.com/office/drawing/2014/main" id="{EF101A08-7E0C-FE45-00DE-CFBC781E078C}"/>
+                <a16:creationId xmlns:a16="http://schemas.microsoft.com/office/drawing/2014/main" id="{79E99627-A663-9D03-0D57-4198FBF9A0FD}"/>
               </a:ext>
             </a:extLst>
           </p:cNvPr>
@@ -7046,8 +7213,8 @@
         </p:nvSpPr>
         <p:spPr>
           <a:xfrm>
-            <a:off x="1417320" y="5513832"/>
-            <a:ext cx="9966960" cy="192297"/>
+            <a:off x="1411304" y="3959352"/>
+            <a:ext cx="9966960" cy="384657"/>
           </a:xfrm>
           <a:prstGeom prst="rect">
             <a:avLst/>
@@ -7060,7 +7227,7 @@
           </a:bodyPr>
           <a:lstStyle/>
           <a:p>
-            <a:pPr algn="l">
+            <a:pPr>
               <a:lnSpc>
                 <a:spcPct val="108000"/>
               </a:lnSpc>
@@ -7072,7 +7239,25 @@
                 </a:solidFill>
                 <a:latin typeface="Arial"/>
               </a:rPr>
-              <a:t>CANNIBALIZATION??????????</a:t>
+              <a:t>Cannibalization Management</a:t>
+            </a:r>
+            <a:r>
+              <a:rPr sz="1250" b="1" i="0" dirty="0">
+                <a:solidFill>
+                  <a:srgbClr val="FFFFFF"/>
+                </a:solidFill>
+                <a:latin typeface="Arial"/>
+              </a:rPr>
+              <a:t>. </a:t>
+            </a:r>
+            <a:r>
+              <a:rPr lang="en-US" sz="1150" dirty="0">
+                <a:solidFill>
+                  <a:srgbClr val="BFD5ED"/>
+                </a:solidFill>
+                <a:latin typeface="Arial"/>
+              </a:rPr>
+              <a:t>~28% of Vestal Pro units shifted from existing shoes displacing with $30.5K.  Next launch, improve product positioning, communication, and audience separation against overlapping models. Monitor cannibalization throughout campaign.</a:t>
             </a:r>
             <a:endParaRPr sz="1150" b="0" i="0" dirty="0">
               <a:solidFill>
@@ -7556,1424 +7741,6 @@
 </p:sld>
 </file>
 
-<file path=ppt/slides/slide16.xml><?xml version="1.0" encoding="utf-8"?>
-<p:sld xmlns:a="http://schemas.openxmlformats.org/drawingml/2006/main" xmlns:r="http://schemas.openxmlformats.org/officeDocument/2006/relationships" xmlns:p="http://schemas.openxmlformats.org/presentationml/2006/main">
-  <p:cSld>
-    <p:spTree>
-      <p:nvGrpSpPr>
-        <p:cNvPr id="1" name=""/>
-        <p:cNvGrpSpPr/>
-        <p:nvPr/>
-      </p:nvGrpSpPr>
-      <p:grpSpPr>
-        <a:xfrm>
-          <a:off x="0" y="0"/>
-          <a:ext cx="0" cy="0"/>
-          <a:chOff x="0" y="0"/>
-          <a:chExt cx="0" cy="0"/>
-        </a:xfrm>
-      </p:grpSpPr>
-      <p:sp>
-        <p:nvSpPr>
-          <p:cNvPr id="2" name="TextBox 1"/>
-          <p:cNvSpPr txBox="1"/>
-          <p:nvPr/>
-        </p:nvSpPr>
-        <p:spPr>
-          <a:xfrm>
-            <a:off x="502920" y="292608"/>
-            <a:ext cx="11155680" cy="274320"/>
-          </a:xfrm>
-          <a:prstGeom prst="rect">
-            <a:avLst/>
-          </a:prstGeom>
-          <a:noFill/>
-        </p:spPr>
-        <p:txBody>
-          <a:bodyPr wrap="square" lIns="0" tIns="0" rIns="0" bIns="0" anchor="t">
-            <a:spAutoFit/>
-          </a:bodyPr>
-          <a:lstStyle/>
-          <a:p>
-            <a:pPr algn="l"/>
-            <a:r>
-              <a:rPr sz="1050" b="1" i="0">
-                <a:solidFill>
-                  <a:srgbClr val="757575"/>
-                </a:solidFill>
-                <a:latin typeface="Arial"/>
-              </a:rPr>
-              <a:t>GUARDRAIL SCORECARD</a:t>
-            </a:r>
-          </a:p>
-        </p:txBody>
-      </p:sp>
-      <p:sp>
-        <p:nvSpPr>
-          <p:cNvPr id="3" name="TextBox 2"/>
-          <p:cNvSpPr txBox="1"/>
-          <p:nvPr/>
-        </p:nvSpPr>
-        <p:spPr>
-          <a:xfrm>
-            <a:off x="502920" y="566928"/>
-            <a:ext cx="11201400" cy="777240"/>
-          </a:xfrm>
-          <a:prstGeom prst="rect">
-            <a:avLst/>
-          </a:prstGeom>
-          <a:noFill/>
-        </p:spPr>
-        <p:txBody>
-          <a:bodyPr wrap="square" lIns="0" tIns="0" rIns="0" bIns="0" anchor="t">
-            <a:spAutoFit/>
-          </a:bodyPr>
-          <a:lstStyle/>
-          <a:p>
-            <a:pPr algn="l"/>
-            <a:r>
-              <a:rPr sz="2300" b="0" i="0">
-                <a:solidFill>
-                  <a:srgbClr val="000000"/>
-                </a:solidFill>
-                <a:latin typeface="Georgia"/>
-              </a:rPr>
-              <a:t>Pricing and basket guardrails held; returns, service load, and availability strained</a:t>
-            </a:r>
-          </a:p>
-        </p:txBody>
-      </p:sp>
-      <p:graphicFrame>
-        <p:nvGraphicFramePr>
-          <p:cNvPr id="4" name="Table 3"/>
-          <p:cNvGraphicFramePr>
-            <a:graphicFrameLocks noGrp="1"/>
-          </p:cNvGraphicFramePr>
-          <p:nvPr/>
-        </p:nvGraphicFramePr>
-        <p:xfrm>
-          <a:off x="502920" y="1554480"/>
-          <a:ext cx="11183112" cy="4256532"/>
-        </p:xfrm>
-        <a:graphic>
-          <a:graphicData uri="http://schemas.openxmlformats.org/drawingml/2006/table">
-            <a:tbl>
-              <a:tblPr>
-                <a:tableStyleId>{5C22544A-7EE6-4342-B048-85BDC9FD1C3A}</a:tableStyleId>
-              </a:tblPr>
-              <a:tblGrid>
-                <a:gridCol w="2743200">
-                  <a:extLst>
-                    <a:ext uri="{9D8B030D-6E8A-4147-A177-3AD203B41FA5}">
-                      <a16:colId xmlns:a16="http://schemas.microsoft.com/office/drawing/2014/main" val="20000"/>
-                    </a:ext>
-                  </a:extLst>
-                </a:gridCol>
-                <a:gridCol w="1143000">
-                  <a:extLst>
-                    <a:ext uri="{9D8B030D-6E8A-4147-A177-3AD203B41FA5}">
-                      <a16:colId xmlns:a16="http://schemas.microsoft.com/office/drawing/2014/main" val="20001"/>
-                    </a:ext>
-                  </a:extLst>
-                </a:gridCol>
-                <a:gridCol w="2148840">
-                  <a:extLst>
-                    <a:ext uri="{9D8B030D-6E8A-4147-A177-3AD203B41FA5}">
-                      <a16:colId xmlns:a16="http://schemas.microsoft.com/office/drawing/2014/main" val="20002"/>
-                    </a:ext>
-                  </a:extLst>
-                </a:gridCol>
-                <a:gridCol w="868680">
-                  <a:extLst>
-                    <a:ext uri="{9D8B030D-6E8A-4147-A177-3AD203B41FA5}">
-                      <a16:colId xmlns:a16="http://schemas.microsoft.com/office/drawing/2014/main" val="20003"/>
-                    </a:ext>
-                  </a:extLst>
-                </a:gridCol>
-                <a:gridCol w="4279392">
-                  <a:extLst>
-                    <a:ext uri="{9D8B030D-6E8A-4147-A177-3AD203B41FA5}">
-                      <a16:colId xmlns:a16="http://schemas.microsoft.com/office/drawing/2014/main" val="20004"/>
-                    </a:ext>
-                  </a:extLst>
-                </a:gridCol>
-              </a:tblGrid>
-              <a:tr h="347472">
-                <a:tc>
-                  <a:txBody>
-                    <a:bodyPr/>
-                    <a:lstStyle/>
-                    <a:p>
-                      <a:r>
-                        <a:rPr sz="1050" b="1">
-                          <a:solidFill>
-                            <a:srgbClr val="FFFFFF"/>
-                          </a:solidFill>
-                          <a:latin typeface="Arial"/>
-                        </a:rPr>
-                        <a:t>Guardrail</a:t>
-                      </a:r>
-                    </a:p>
-                  </a:txBody>
-                  <a:tcPr marL="73152" marR="36576" anchor="ctr">
-                    <a:solidFill>
-                      <a:srgbClr val="000000"/>
-                    </a:solidFill>
-                  </a:tcPr>
-                </a:tc>
-                <a:tc>
-                  <a:txBody>
-                    <a:bodyPr/>
-                    <a:lstStyle/>
-                    <a:p>
-                      <a:r>
-                        <a:rPr sz="1050" b="1">
-                          <a:solidFill>
-                            <a:srgbClr val="FFFFFF"/>
-                          </a:solidFill>
-                          <a:latin typeface="Arial"/>
-                        </a:rPr>
-                        <a:t>Pre</a:t>
-                      </a:r>
-                    </a:p>
-                  </a:txBody>
-                  <a:tcPr marL="73152" marR="36576" anchor="ctr">
-                    <a:solidFill>
-                      <a:srgbClr val="000000"/>
-                    </a:solidFill>
-                  </a:tcPr>
-                </a:tc>
-                <a:tc>
-                  <a:txBody>
-                    <a:bodyPr/>
-                    <a:lstStyle/>
-                    <a:p>
-                      <a:r>
-                        <a:rPr sz="1050" b="1">
-                          <a:solidFill>
-                            <a:srgbClr val="FFFFFF"/>
-                          </a:solidFill>
-                          <a:latin typeface="Arial"/>
-                        </a:rPr>
-                        <a:t>Active flight</a:t>
-                      </a:r>
-                    </a:p>
-                  </a:txBody>
-                  <a:tcPr marL="73152" marR="36576" anchor="ctr">
-                    <a:solidFill>
-                      <a:srgbClr val="000000"/>
-                    </a:solidFill>
-                  </a:tcPr>
-                </a:tc>
-                <a:tc>
-                  <a:txBody>
-                    <a:bodyPr/>
-                    <a:lstStyle/>
-                    <a:p>
-                      <a:r>
-                        <a:rPr sz="1050" b="1">
-                          <a:solidFill>
-                            <a:srgbClr val="FFFFFF"/>
-                          </a:solidFill>
-                          <a:latin typeface="Arial"/>
-                        </a:rPr>
-                        <a:t>Status</a:t>
-                      </a:r>
-                    </a:p>
-                  </a:txBody>
-                  <a:tcPr marL="73152" marR="36576" anchor="ctr">
-                    <a:solidFill>
-                      <a:srgbClr val="000000"/>
-                    </a:solidFill>
-                  </a:tcPr>
-                </a:tc>
-                <a:tc>
-                  <a:txBody>
-                    <a:bodyPr/>
-                    <a:lstStyle/>
-                    <a:p>
-                      <a:r>
-                        <a:rPr sz="1050" b="1">
-                          <a:solidFill>
-                            <a:srgbClr val="FFFFFF"/>
-                          </a:solidFill>
-                          <a:latin typeface="Arial"/>
-                        </a:rPr>
-                        <a:t>Note</a:t>
-                      </a:r>
-                    </a:p>
-                  </a:txBody>
-                  <a:tcPr marL="73152" marR="36576" anchor="ctr">
-                    <a:solidFill>
-                      <a:srgbClr val="000000"/>
-                    </a:solidFill>
-                  </a:tcPr>
-                </a:tc>
-                <a:extLst>
-                  <a:ext uri="{0D108BD9-81ED-4DB2-BD59-A6C34878D82A}">
-                    <a16:rowId xmlns:a16="http://schemas.microsoft.com/office/drawing/2014/main" val="10000"/>
-                  </a:ext>
-                </a:extLst>
-              </a:tr>
-              <a:tr h="434340">
-                <a:tc>
-                  <a:txBody>
-                    <a:bodyPr/>
-                    <a:lstStyle/>
-                    <a:p>
-                      <a:r>
-                        <a:rPr sz="1000" b="1" dirty="0">
-                          <a:solidFill>
-                            <a:srgbClr val="333333"/>
-                          </a:solidFill>
-                          <a:latin typeface="Arial"/>
-                        </a:rPr>
-                        <a:t>Average order value</a:t>
-                      </a:r>
-                    </a:p>
-                  </a:txBody>
-                  <a:tcPr marL="73152" marR="36576" anchor="ctr">
-                    <a:solidFill>
-                      <a:srgbClr val="FFFFFF"/>
-                    </a:solidFill>
-                  </a:tcPr>
-                </a:tc>
-                <a:tc>
-                  <a:txBody>
-                    <a:bodyPr/>
-                    <a:lstStyle/>
-                    <a:p>
-                      <a:r>
-                        <a:rPr sz="1000">
-                          <a:solidFill>
-                            <a:srgbClr val="333333"/>
-                          </a:solidFill>
-                          <a:latin typeface="Arial"/>
-                        </a:rPr>
-                        <a:t>$123</a:t>
-                      </a:r>
-                    </a:p>
-                  </a:txBody>
-                  <a:tcPr marL="73152" marR="36576" anchor="ctr">
-                    <a:solidFill>
-                      <a:srgbClr val="FFFFFF"/>
-                    </a:solidFill>
-                  </a:tcPr>
-                </a:tc>
-                <a:tc>
-                  <a:txBody>
-                    <a:bodyPr/>
-                    <a:lstStyle/>
-                    <a:p>
-                      <a:r>
-                        <a:rPr sz="1000">
-                          <a:solidFill>
-                            <a:srgbClr val="333333"/>
-                          </a:solidFill>
-                          <a:latin typeface="Arial"/>
-                        </a:rPr>
-                        <a:t>$132  (+7.1%)</a:t>
-                      </a:r>
-                    </a:p>
-                  </a:txBody>
-                  <a:tcPr marL="73152" marR="36576" anchor="ctr">
-                    <a:solidFill>
-                      <a:srgbClr val="FFFFFF"/>
-                    </a:solidFill>
-                  </a:tcPr>
-                </a:tc>
-                <a:tc>
-                  <a:txBody>
-                    <a:bodyPr/>
-                    <a:lstStyle/>
-                    <a:p>
-                      <a:r>
-                        <a:rPr sz="1000" b="1">
-                          <a:solidFill>
-                            <a:srgbClr val="1F7A4D"/>
-                          </a:solidFill>
-                          <a:latin typeface="Arial"/>
-                        </a:rPr>
-                        <a:t>PASS</a:t>
-                      </a:r>
-                    </a:p>
-                  </a:txBody>
-                  <a:tcPr marL="73152" marR="36576" anchor="ctr">
-                    <a:solidFill>
-                      <a:srgbClr val="FFFFFF"/>
-                    </a:solidFill>
-                  </a:tcPr>
-                </a:tc>
-                <a:tc>
-                  <a:txBody>
-                    <a:bodyPr/>
-                    <a:lstStyle/>
-                    <a:p>
-                      <a:r>
-                        <a:rPr sz="950">
-                          <a:solidFill>
-                            <a:srgbClr val="757575"/>
-                          </a:solidFill>
-                          <a:latin typeface="Arial"/>
-                        </a:rPr>
-                        <a:t>Footwear mix plus accessory attachment</a:t>
-                      </a:r>
-                    </a:p>
-                  </a:txBody>
-                  <a:tcPr marL="73152" marR="36576" anchor="ctr">
-                    <a:solidFill>
-                      <a:srgbClr val="FFFFFF"/>
-                    </a:solidFill>
-                  </a:tcPr>
-                </a:tc>
-                <a:extLst>
-                  <a:ext uri="{0D108BD9-81ED-4DB2-BD59-A6C34878D82A}">
-                    <a16:rowId xmlns:a16="http://schemas.microsoft.com/office/drawing/2014/main" val="10001"/>
-                  </a:ext>
-                </a:extLst>
-              </a:tr>
-              <a:tr h="434340">
-                <a:tc>
-                  <a:txBody>
-                    <a:bodyPr/>
-                    <a:lstStyle/>
-                    <a:p>
-                      <a:r>
-                        <a:rPr sz="1000" b="1">
-                          <a:solidFill>
-                            <a:srgbClr val="333333"/>
-                          </a:solidFill>
-                          <a:latin typeface="Arial"/>
-                        </a:rPr>
-                        <a:t>Discounting (ASP proxy)</a:t>
-                      </a:r>
-                    </a:p>
-                  </a:txBody>
-                  <a:tcPr marL="73152" marR="36576" anchor="ctr">
-                    <a:solidFill>
-                      <a:srgbClr val="F5F6F7"/>
-                    </a:solidFill>
-                  </a:tcPr>
-                </a:tc>
-                <a:tc>
-                  <a:txBody>
-                    <a:bodyPr/>
-                    <a:lstStyle/>
-                    <a:p>
-                      <a:r>
-                        <a:rPr sz="1000">
-                          <a:solidFill>
-                            <a:srgbClr val="333333"/>
-                          </a:solidFill>
-                          <a:latin typeface="Arial"/>
-                        </a:rPr>
-                        <a:t>—</a:t>
-                      </a:r>
-                    </a:p>
-                  </a:txBody>
-                  <a:tcPr marL="73152" marR="36576" anchor="ctr">
-                    <a:solidFill>
-                      <a:srgbClr val="F5F6F7"/>
-                    </a:solidFill>
-                  </a:tcPr>
-                </a:tc>
-                <a:tc>
-                  <a:txBody>
-                    <a:bodyPr/>
-                    <a:lstStyle/>
-                    <a:p>
-                      <a:r>
-                        <a:rPr sz="1000">
-                          <a:solidFill>
-                            <a:srgbClr val="333333"/>
-                          </a:solidFill>
-                          <a:latin typeface="Arial"/>
-                        </a:rPr>
-                        <a:t>Vestal Pro $145, full price</a:t>
-                      </a:r>
-                    </a:p>
-                  </a:txBody>
-                  <a:tcPr marL="73152" marR="36576" anchor="ctr">
-                    <a:solidFill>
-                      <a:srgbClr val="F5F6F7"/>
-                    </a:solidFill>
-                  </a:tcPr>
-                </a:tc>
-                <a:tc>
-                  <a:txBody>
-                    <a:bodyPr/>
-                    <a:lstStyle/>
-                    <a:p>
-                      <a:r>
-                        <a:rPr sz="1000" b="1">
-                          <a:solidFill>
-                            <a:srgbClr val="1F7A4D"/>
-                          </a:solidFill>
-                          <a:latin typeface="Arial"/>
-                        </a:rPr>
-                        <a:t>PASS</a:t>
-                      </a:r>
-                    </a:p>
-                  </a:txBody>
-                  <a:tcPr marL="73152" marR="36576" anchor="ctr">
-                    <a:solidFill>
-                      <a:srgbClr val="F5F6F7"/>
-                    </a:solidFill>
-                  </a:tcPr>
-                </a:tc>
-                <a:tc>
-                  <a:txBody>
-                    <a:bodyPr/>
-                    <a:lstStyle/>
-                    <a:p>
-                      <a:r>
-                        <a:rPr sz="950">
-                          <a:solidFill>
-                            <a:srgbClr val="757575"/>
-                          </a:solidFill>
-                          <a:latin typeface="Arial"/>
-                        </a:rPr>
-                        <a:t>No launch markdown; post-period ASP eased 7.7% to $134</a:t>
-                      </a:r>
-                    </a:p>
-                  </a:txBody>
-                  <a:tcPr marL="73152" marR="36576" anchor="ctr">
-                    <a:solidFill>
-                      <a:srgbClr val="F5F6F7"/>
-                    </a:solidFill>
-                  </a:tcPr>
-                </a:tc>
-                <a:extLst>
-                  <a:ext uri="{0D108BD9-81ED-4DB2-BD59-A6C34878D82A}">
-                    <a16:rowId xmlns:a16="http://schemas.microsoft.com/office/drawing/2014/main" val="10002"/>
-                  </a:ext>
-                </a:extLst>
-              </a:tr>
-              <a:tr h="434340">
-                <a:tc>
-                  <a:txBody>
-                    <a:bodyPr/>
-                    <a:lstStyle/>
-                    <a:p>
-                      <a:r>
-                        <a:rPr sz="1000" b="1" dirty="0">
-                          <a:solidFill>
-                            <a:srgbClr val="333333"/>
-                          </a:solidFill>
-                          <a:latin typeface="Arial"/>
-                        </a:rPr>
-                        <a:t>Site conversion rate</a:t>
-                      </a:r>
-                    </a:p>
-                  </a:txBody>
-                  <a:tcPr marL="73152" marR="36576" anchor="ctr">
-                    <a:solidFill>
-                      <a:srgbClr val="FFFFFF"/>
-                    </a:solidFill>
-                  </a:tcPr>
-                </a:tc>
-                <a:tc>
-                  <a:txBody>
-                    <a:bodyPr/>
-                    <a:lstStyle/>
-                    <a:p>
-                      <a:r>
-                        <a:rPr sz="1000">
-                          <a:solidFill>
-                            <a:srgbClr val="333333"/>
-                          </a:solidFill>
-                          <a:latin typeface="Arial"/>
-                        </a:rPr>
-                        <a:t>2.33%</a:t>
-                      </a:r>
-                    </a:p>
-                  </a:txBody>
-                  <a:tcPr marL="73152" marR="36576" anchor="ctr">
-                    <a:solidFill>
-                      <a:srgbClr val="FFFFFF"/>
-                    </a:solidFill>
-                  </a:tcPr>
-                </a:tc>
-                <a:tc>
-                  <a:txBody>
-                    <a:bodyPr/>
-                    <a:lstStyle/>
-                    <a:p>
-                      <a:r>
-                        <a:rPr sz="1000">
-                          <a:solidFill>
-                            <a:srgbClr val="333333"/>
-                          </a:solidFill>
-                          <a:latin typeface="Arial"/>
-                        </a:rPr>
-                        <a:t>2.42% avg · 2.23% wk 6</a:t>
-                      </a:r>
-                    </a:p>
-                  </a:txBody>
-                  <a:tcPr marL="73152" marR="36576" anchor="ctr">
-                    <a:solidFill>
-                      <a:srgbClr val="FFFFFF"/>
-                    </a:solidFill>
-                  </a:tcPr>
-                </a:tc>
-                <a:tc>
-                  <a:txBody>
-                    <a:bodyPr/>
-                    <a:lstStyle/>
-                    <a:p>
-                      <a:r>
-                        <a:rPr sz="1000" b="1">
-                          <a:solidFill>
-                            <a:srgbClr val="757575"/>
-                          </a:solidFill>
-                          <a:latin typeface="Arial"/>
-                        </a:rPr>
-                        <a:t>WATCH</a:t>
-                      </a:r>
-                    </a:p>
-                  </a:txBody>
-                  <a:tcPr marL="73152" marR="36576" anchor="ctr">
-                    <a:solidFill>
-                      <a:srgbClr val="FFFFFF"/>
-                    </a:solidFill>
-                  </a:tcPr>
-                </a:tc>
-                <a:tc>
-                  <a:txBody>
-                    <a:bodyPr/>
-                    <a:lstStyle/>
-                    <a:p>
-                      <a:r>
-                        <a:rPr sz="950">
-                          <a:solidFill>
-                            <a:srgbClr val="757575"/>
-                          </a:solidFill>
-                          <a:latin typeface="Arial"/>
-                        </a:rPr>
-                        <a:t>Improved early, then fell below pre-period as core sizes depleted</a:t>
-                      </a:r>
-                    </a:p>
-                  </a:txBody>
-                  <a:tcPr marL="73152" marR="36576" anchor="ctr">
-                    <a:solidFill>
-                      <a:srgbClr val="FFFFFF"/>
-                    </a:solidFill>
-                  </a:tcPr>
-                </a:tc>
-                <a:extLst>
-                  <a:ext uri="{0D108BD9-81ED-4DB2-BD59-A6C34878D82A}">
-                    <a16:rowId xmlns:a16="http://schemas.microsoft.com/office/drawing/2014/main" val="10003"/>
-                  </a:ext>
-                </a:extLst>
-              </a:tr>
-              <a:tr h="434340">
-                <a:tc>
-                  <a:txBody>
-                    <a:bodyPr/>
-                    <a:lstStyle/>
-                    <a:p>
-                      <a:r>
-                        <a:rPr sz="1000" b="1">
-                          <a:solidFill>
-                            <a:srgbClr val="333333"/>
-                          </a:solidFill>
-                          <a:latin typeface="Arial"/>
-                        </a:rPr>
-                        <a:t>Return rate, site-wide</a:t>
-                      </a:r>
-                    </a:p>
-                  </a:txBody>
-                  <a:tcPr marL="73152" marR="36576" anchor="ctr">
-                    <a:solidFill>
-                      <a:srgbClr val="F5F6F7"/>
-                    </a:solidFill>
-                  </a:tcPr>
-                </a:tc>
-                <a:tc>
-                  <a:txBody>
-                    <a:bodyPr/>
-                    <a:lstStyle/>
-                    <a:p>
-                      <a:r>
-                        <a:rPr sz="1000">
-                          <a:solidFill>
-                            <a:srgbClr val="333333"/>
-                          </a:solidFill>
-                          <a:latin typeface="Arial"/>
-                        </a:rPr>
-                        <a:t>6.6%</a:t>
-                      </a:r>
-                    </a:p>
-                  </a:txBody>
-                  <a:tcPr marL="73152" marR="36576" anchor="ctr">
-                    <a:solidFill>
-                      <a:srgbClr val="F5F6F7"/>
-                    </a:solidFill>
-                  </a:tcPr>
-                </a:tc>
-                <a:tc>
-                  <a:txBody>
-                    <a:bodyPr/>
-                    <a:lstStyle/>
-                    <a:p>
-                      <a:r>
-                        <a:rPr sz="1000">
-                          <a:solidFill>
-                            <a:srgbClr val="333333"/>
-                          </a:solidFill>
-                          <a:latin typeface="Arial"/>
-                        </a:rPr>
-                        <a:t>8.7%  (+2.1 pts)</a:t>
-                      </a:r>
-                    </a:p>
-                  </a:txBody>
-                  <a:tcPr marL="73152" marR="36576" anchor="ctr">
-                    <a:solidFill>
-                      <a:srgbClr val="F5F6F7"/>
-                    </a:solidFill>
-                  </a:tcPr>
-                </a:tc>
-                <a:tc>
-                  <a:txBody>
-                    <a:bodyPr/>
-                    <a:lstStyle/>
-                    <a:p>
-                      <a:r>
-                        <a:rPr sz="1000" b="1">
-                          <a:solidFill>
-                            <a:srgbClr val="757575"/>
-                          </a:solidFill>
-                          <a:latin typeface="Arial"/>
-                        </a:rPr>
-                        <a:t>WATCH</a:t>
-                      </a:r>
-                    </a:p>
-                  </a:txBody>
-                  <a:tcPr marL="73152" marR="36576" anchor="ctr">
-                    <a:solidFill>
-                      <a:srgbClr val="F5F6F7"/>
-                    </a:solidFill>
-                  </a:tcPr>
-                </a:tc>
-                <a:tc>
-                  <a:txBody>
-                    <a:bodyPr/>
-                    <a:lstStyle/>
-                    <a:p>
-                      <a:r>
-                        <a:rPr sz="950">
-                          <a:solidFill>
-                            <a:srgbClr val="757575"/>
-                          </a:solidFill>
-                          <a:latin typeface="Arial"/>
-                        </a:rPr>
-                        <a:t>Within the 1–3 pt launch expectation; still maturing post-period (9.4%)</a:t>
-                      </a:r>
-                    </a:p>
-                  </a:txBody>
-                  <a:tcPr marL="73152" marR="36576" anchor="ctr">
-                    <a:solidFill>
-                      <a:srgbClr val="F5F6F7"/>
-                    </a:solidFill>
-                  </a:tcPr>
-                </a:tc>
-                <a:extLst>
-                  <a:ext uri="{0D108BD9-81ED-4DB2-BD59-A6C34878D82A}">
-                    <a16:rowId xmlns:a16="http://schemas.microsoft.com/office/drawing/2014/main" val="10004"/>
-                  </a:ext>
-                </a:extLst>
-              </a:tr>
-              <a:tr h="434340">
-                <a:tc>
-                  <a:txBody>
-                    <a:bodyPr/>
-                    <a:lstStyle/>
-                    <a:p>
-                      <a:r>
-                        <a:rPr sz="1000" b="1">
-                          <a:solidFill>
-                            <a:srgbClr val="333333"/>
-                          </a:solidFill>
-                          <a:latin typeface="Arial"/>
-                        </a:rPr>
-                        <a:t>Return rate, Vestal Pro</a:t>
-                      </a:r>
-                    </a:p>
-                  </a:txBody>
-                  <a:tcPr marL="73152" marR="36576" anchor="ctr">
-                    <a:solidFill>
-                      <a:srgbClr val="FFFFFF"/>
-                    </a:solidFill>
-                  </a:tcPr>
-                </a:tc>
-                <a:tc>
-                  <a:txBody>
-                    <a:bodyPr/>
-                    <a:lstStyle/>
-                    <a:p>
-                      <a:r>
-                        <a:rPr sz="1000">
-                          <a:solidFill>
-                            <a:srgbClr val="333333"/>
-                          </a:solidFill>
-                          <a:latin typeface="Arial"/>
-                        </a:rPr>
-                        <a:t>—</a:t>
-                      </a:r>
-                    </a:p>
-                  </a:txBody>
-                  <a:tcPr marL="73152" marR="36576" anchor="ctr">
-                    <a:solidFill>
-                      <a:srgbClr val="FFFFFF"/>
-                    </a:solidFill>
-                  </a:tcPr>
-                </a:tc>
-                <a:tc>
-                  <a:txBody>
-                    <a:bodyPr/>
-                    <a:lstStyle/>
-                    <a:p>
-                      <a:r>
-                        <a:rPr sz="1000">
-                          <a:solidFill>
-                            <a:srgbClr val="333333"/>
-                          </a:solidFill>
-                          <a:latin typeface="Arial"/>
-                        </a:rPr>
-                        <a:t>14.4% → 19.8% post</a:t>
-                      </a:r>
-                    </a:p>
-                  </a:txBody>
-                  <a:tcPr marL="73152" marR="36576" anchor="ctr">
-                    <a:solidFill>
-                      <a:srgbClr val="FFFFFF"/>
-                    </a:solidFill>
-                  </a:tcPr>
-                </a:tc>
-                <a:tc>
-                  <a:txBody>
-                    <a:bodyPr/>
-                    <a:lstStyle/>
-                    <a:p>
-                      <a:r>
-                        <a:rPr sz="1000" b="1">
-                          <a:solidFill>
-                            <a:srgbClr val="757575"/>
-                          </a:solidFill>
-                          <a:latin typeface="Arial"/>
-                        </a:rPr>
-                        <a:t>WATCH</a:t>
-                      </a:r>
-                    </a:p>
-                  </a:txBody>
-                  <a:tcPr marL="73152" marR="36576" anchor="ctr">
-                    <a:solidFill>
-                      <a:srgbClr val="FFFFFF"/>
-                    </a:solidFill>
-                  </a:tcPr>
-                </a:tc>
-                <a:tc>
-                  <a:txBody>
-                    <a:bodyPr/>
-                    <a:lstStyle/>
-                    <a:p>
-                      <a:r>
-                        <a:rPr sz="950">
-                          <a:solidFill>
-                            <a:srgbClr val="757575"/>
-                          </a:solidFill>
-                          <a:latin typeface="Arial"/>
-                        </a:rPr>
-                        <a:t>≈2× fleet average; sizing-and-fit driven</a:t>
-                      </a:r>
-                    </a:p>
-                  </a:txBody>
-                  <a:tcPr marL="73152" marR="36576" anchor="ctr">
-                    <a:solidFill>
-                      <a:srgbClr val="FFFFFF"/>
-                    </a:solidFill>
-                  </a:tcPr>
-                </a:tc>
-                <a:extLst>
-                  <a:ext uri="{0D108BD9-81ED-4DB2-BD59-A6C34878D82A}">
-                    <a16:rowId xmlns:a16="http://schemas.microsoft.com/office/drawing/2014/main" val="10005"/>
-                  </a:ext>
-                </a:extLst>
-              </a:tr>
-              <a:tr h="434340">
-                <a:tc>
-                  <a:txBody>
-                    <a:bodyPr/>
-                    <a:lstStyle/>
-                    <a:p>
-                      <a:r>
-                        <a:rPr sz="1000" b="1">
-                          <a:solidFill>
-                            <a:srgbClr val="333333"/>
-                          </a:solidFill>
-                          <a:latin typeface="Arial"/>
-                        </a:rPr>
-                        <a:t>Service contact rate</a:t>
-                      </a:r>
-                    </a:p>
-                  </a:txBody>
-                  <a:tcPr marL="73152" marR="36576" anchor="ctr">
-                    <a:solidFill>
-                      <a:srgbClr val="F5F6F7"/>
-                    </a:solidFill>
-                  </a:tcPr>
-                </a:tc>
-                <a:tc>
-                  <a:txBody>
-                    <a:bodyPr/>
-                    <a:lstStyle/>
-                    <a:p>
-                      <a:r>
-                        <a:rPr sz="1000">
-                          <a:solidFill>
-                            <a:srgbClr val="333333"/>
-                          </a:solidFill>
-                          <a:latin typeface="Arial"/>
-                        </a:rPr>
-                        <a:t>3.5%</a:t>
-                      </a:r>
-                    </a:p>
-                  </a:txBody>
-                  <a:tcPr marL="73152" marR="36576" anchor="ctr">
-                    <a:solidFill>
-                      <a:srgbClr val="F5F6F7"/>
-                    </a:solidFill>
-                  </a:tcPr>
-                </a:tc>
-                <a:tc>
-                  <a:txBody>
-                    <a:bodyPr/>
-                    <a:lstStyle/>
-                    <a:p>
-                      <a:r>
-                        <a:rPr sz="1000">
-                          <a:solidFill>
-                            <a:srgbClr val="333333"/>
-                          </a:solidFill>
-                          <a:latin typeface="Arial"/>
-                        </a:rPr>
-                        <a:t>7.7% of orders</a:t>
-                      </a:r>
-                    </a:p>
-                  </a:txBody>
-                  <a:tcPr marL="73152" marR="36576" anchor="ctr">
-                    <a:solidFill>
-                      <a:srgbClr val="F5F6F7"/>
-                    </a:solidFill>
-                  </a:tcPr>
-                </a:tc>
-                <a:tc>
-                  <a:txBody>
-                    <a:bodyPr/>
-                    <a:lstStyle/>
-                    <a:p>
-                      <a:r>
-                        <a:rPr sz="1000" b="1">
-                          <a:solidFill>
-                            <a:srgbClr val="757575"/>
-                          </a:solidFill>
-                          <a:latin typeface="Arial"/>
-                        </a:rPr>
-                        <a:t>WATCH</a:t>
-                      </a:r>
-                    </a:p>
-                  </a:txBody>
-                  <a:tcPr marL="73152" marR="36576" anchor="ctr">
-                    <a:solidFill>
-                      <a:srgbClr val="F5F6F7"/>
-                    </a:solidFill>
-                  </a:tcPr>
-                </a:tc>
-                <a:tc>
-                  <a:txBody>
-                    <a:bodyPr/>
-                    <a:lstStyle/>
-                    <a:p>
-                      <a:r>
-                        <a:rPr sz="950">
-                          <a:solidFill>
-                            <a:srgbClr val="757575"/>
-                          </a:solidFill>
-                          <a:latin typeface="Arial"/>
-                        </a:rPr>
-                        <a:t>Sizing +199%, inventory +152%, comparison +109% vs pre-period</a:t>
-                      </a:r>
-                    </a:p>
-                  </a:txBody>
-                  <a:tcPr marL="73152" marR="36576" anchor="ctr">
-                    <a:solidFill>
-                      <a:srgbClr val="F5F6F7"/>
-                    </a:solidFill>
-                  </a:tcPr>
-                </a:tc>
-                <a:extLst>
-                  <a:ext uri="{0D108BD9-81ED-4DB2-BD59-A6C34878D82A}">
-                    <a16:rowId xmlns:a16="http://schemas.microsoft.com/office/drawing/2014/main" val="10006"/>
-                  </a:ext>
-                </a:extLst>
-              </a:tr>
-              <a:tr h="434340">
-                <a:tc>
-                  <a:txBody>
-                    <a:bodyPr/>
-                    <a:lstStyle/>
-                    <a:p>
-                      <a:r>
-                        <a:rPr sz="1000" b="1">
-                          <a:solidFill>
-                            <a:srgbClr val="333333"/>
-                          </a:solidFill>
-                          <a:latin typeface="Arial"/>
-                        </a:rPr>
-                        <a:t>Core-size availability, Vestal Pro</a:t>
-                      </a:r>
-                    </a:p>
-                  </a:txBody>
-                  <a:tcPr marL="73152" marR="36576" anchor="ctr">
-                    <a:solidFill>
-                      <a:srgbClr val="FFFFFF"/>
-                    </a:solidFill>
-                  </a:tcPr>
-                </a:tc>
-                <a:tc>
-                  <a:txBody>
-                    <a:bodyPr/>
-                    <a:lstStyle/>
-                    <a:p>
-                      <a:r>
-                        <a:rPr sz="1000">
-                          <a:solidFill>
-                            <a:srgbClr val="333333"/>
-                          </a:solidFill>
-                          <a:latin typeface="Arial"/>
-                        </a:rPr>
-                        <a:t>97%</a:t>
-                      </a:r>
-                    </a:p>
-                  </a:txBody>
-                  <a:tcPr marL="73152" marR="36576" anchor="ctr">
-                    <a:solidFill>
-                      <a:srgbClr val="FFFFFF"/>
-                    </a:solidFill>
-                  </a:tcPr>
-                </a:tc>
-                <a:tc>
-                  <a:txBody>
-                    <a:bodyPr/>
-                    <a:lstStyle/>
-                    <a:p>
-                      <a:r>
-                        <a:rPr sz="1000">
-                          <a:solidFill>
-                            <a:srgbClr val="333333"/>
-                          </a:solidFill>
-                          <a:latin typeface="Arial"/>
-                        </a:rPr>
-                        <a:t>56% by week 6</a:t>
-                      </a:r>
-                    </a:p>
-                  </a:txBody>
-                  <a:tcPr marL="73152" marR="36576" anchor="ctr">
-                    <a:solidFill>
-                      <a:srgbClr val="FFFFFF"/>
-                    </a:solidFill>
-                  </a:tcPr>
-                </a:tc>
-                <a:tc>
-                  <a:txBody>
-                    <a:bodyPr/>
-                    <a:lstStyle/>
-                    <a:p>
-                      <a:r>
-                        <a:rPr sz="1000" b="1">
-                          <a:solidFill>
-                            <a:srgbClr val="B3261E"/>
-                          </a:solidFill>
-                          <a:latin typeface="Arial"/>
-                        </a:rPr>
-                        <a:t>MISS</a:t>
-                      </a:r>
-                    </a:p>
-                  </a:txBody>
-                  <a:tcPr marL="73152" marR="36576" anchor="ctr">
-                    <a:solidFill>
-                      <a:srgbClr val="FFFFFF"/>
-                    </a:solidFill>
-                  </a:tcPr>
-                </a:tc>
-                <a:tc>
-                  <a:txBody>
-                    <a:bodyPr/>
-                    <a:lstStyle/>
-                    <a:p>
-                      <a:r>
-                        <a:rPr sz="950">
-                          <a:solidFill>
-                            <a:srgbClr val="757575"/>
-                          </a:solidFill>
-                          <a:latin typeface="Arial"/>
-                        </a:rPr>
-                        <a:t>Below 90% from week 3; ≈$20K modeled unmet demand</a:t>
-                      </a:r>
-                    </a:p>
-                  </a:txBody>
-                  <a:tcPr marL="73152" marR="36576" anchor="ctr">
-                    <a:solidFill>
-                      <a:srgbClr val="FFFFFF"/>
-                    </a:solidFill>
-                  </a:tcPr>
-                </a:tc>
-                <a:extLst>
-                  <a:ext uri="{0D108BD9-81ED-4DB2-BD59-A6C34878D82A}">
-                    <a16:rowId xmlns:a16="http://schemas.microsoft.com/office/drawing/2014/main" val="10007"/>
-                  </a:ext>
-                </a:extLst>
-              </a:tr>
-              <a:tr h="434340">
-                <a:tc>
-                  <a:txBody>
-                    <a:bodyPr/>
-                    <a:lstStyle/>
-                    <a:p>
-                      <a:r>
-                        <a:rPr sz="1000" b="1">
-                          <a:solidFill>
-                            <a:srgbClr val="333333"/>
-                          </a:solidFill>
-                          <a:latin typeface="Arial"/>
-                        </a:rPr>
-                        <a:t>Email / SMS unsubscribes</a:t>
-                      </a:r>
-                    </a:p>
-                  </a:txBody>
-                  <a:tcPr marL="73152" marR="36576" anchor="ctr">
-                    <a:solidFill>
-                      <a:srgbClr val="F5F6F7"/>
-                    </a:solidFill>
-                  </a:tcPr>
-                </a:tc>
-                <a:tc>
-                  <a:txBody>
-                    <a:bodyPr/>
-                    <a:lstStyle/>
-                    <a:p>
-                      <a:r>
-                        <a:rPr sz="1000">
-                          <a:solidFill>
-                            <a:srgbClr val="333333"/>
-                          </a:solidFill>
-                          <a:latin typeface="Arial"/>
-                        </a:rPr>
-                        <a:t>—</a:t>
-                      </a:r>
-                    </a:p>
-                  </a:txBody>
-                  <a:tcPr marL="73152" marR="36576" anchor="ctr">
-                    <a:solidFill>
-                      <a:srgbClr val="F5F6F7"/>
-                    </a:solidFill>
-                  </a:tcPr>
-                </a:tc>
-                <a:tc>
-                  <a:txBody>
-                    <a:bodyPr/>
-                    <a:lstStyle/>
-                    <a:p>
-                      <a:r>
-                        <a:rPr sz="1000">
-                          <a:solidFill>
-                            <a:srgbClr val="333333"/>
-                          </a:solidFill>
-                          <a:latin typeface="Arial"/>
-                        </a:rPr>
-                        <a:t>not measured</a:t>
-                      </a:r>
-                    </a:p>
-                  </a:txBody>
-                  <a:tcPr marL="73152" marR="36576" anchor="ctr">
-                    <a:solidFill>
-                      <a:srgbClr val="F5F6F7"/>
-                    </a:solidFill>
-                  </a:tcPr>
-                </a:tc>
-                <a:tc>
-                  <a:txBody>
-                    <a:bodyPr/>
-                    <a:lstStyle/>
-                    <a:p>
-                      <a:r>
-                        <a:rPr sz="1000" b="0">
-                          <a:solidFill>
-                            <a:srgbClr val="D9D9D9"/>
-                          </a:solidFill>
-                          <a:latin typeface="Arial"/>
-                        </a:rPr>
-                        <a:t>N/A</a:t>
-                      </a:r>
-                    </a:p>
-                  </a:txBody>
-                  <a:tcPr marL="73152" marR="36576" anchor="ctr">
-                    <a:solidFill>
-                      <a:srgbClr val="F5F6F7"/>
-                    </a:solidFill>
-                  </a:tcPr>
-                </a:tc>
-                <a:tc>
-                  <a:txBody>
-                    <a:bodyPr/>
-                    <a:lstStyle/>
-                    <a:p>
-                      <a:r>
-                        <a:rPr sz="950">
-                          <a:solidFill>
-                            <a:srgbClr val="757575"/>
-                          </a:solidFill>
-                          <a:latin typeface="Arial"/>
-                        </a:rPr>
-                        <a:t>No send-level CRM data captured — instrument next flight</a:t>
-                      </a:r>
-                    </a:p>
-                  </a:txBody>
-                  <a:tcPr marL="73152" marR="36576" anchor="ctr">
-                    <a:solidFill>
-                      <a:srgbClr val="F5F6F7"/>
-                    </a:solidFill>
-                  </a:tcPr>
-                </a:tc>
-                <a:extLst>
-                  <a:ext uri="{0D108BD9-81ED-4DB2-BD59-A6C34878D82A}">
-                    <a16:rowId xmlns:a16="http://schemas.microsoft.com/office/drawing/2014/main" val="10008"/>
-                  </a:ext>
-                </a:extLst>
-              </a:tr>
-              <a:tr h="434340">
-                <a:tc>
-                  <a:txBody>
-                    <a:bodyPr/>
-                    <a:lstStyle/>
-                    <a:p>
-                      <a:r>
-                        <a:rPr sz="1000" b="1">
-                          <a:solidFill>
-                            <a:srgbClr val="333333"/>
-                          </a:solidFill>
-                          <a:latin typeface="Arial"/>
-                        </a:rPr>
-                        <a:t>Gross margin</a:t>
-                      </a:r>
-                    </a:p>
-                  </a:txBody>
-                  <a:tcPr marL="73152" marR="36576" anchor="ctr">
-                    <a:solidFill>
-                      <a:srgbClr val="FFFFFF"/>
-                    </a:solidFill>
-                  </a:tcPr>
-                </a:tc>
-                <a:tc>
-                  <a:txBody>
-                    <a:bodyPr/>
-                    <a:lstStyle/>
-                    <a:p>
-                      <a:r>
-                        <a:rPr sz="1000">
-                          <a:solidFill>
-                            <a:srgbClr val="333333"/>
-                          </a:solidFill>
-                          <a:latin typeface="Arial"/>
-                        </a:rPr>
-                        <a:t>—</a:t>
-                      </a:r>
-                    </a:p>
-                  </a:txBody>
-                  <a:tcPr marL="73152" marR="36576" anchor="ctr">
-                    <a:solidFill>
-                      <a:srgbClr val="FFFFFF"/>
-                    </a:solidFill>
-                  </a:tcPr>
-                </a:tc>
-                <a:tc>
-                  <a:txBody>
-                    <a:bodyPr/>
-                    <a:lstStyle/>
-                    <a:p>
-                      <a:r>
-                        <a:rPr sz="1000">
-                          <a:solidFill>
-                            <a:srgbClr val="333333"/>
-                          </a:solidFill>
-                          <a:latin typeface="Arial"/>
-                        </a:rPr>
-                        <a:t>not measured</a:t>
-                      </a:r>
-                    </a:p>
-                  </a:txBody>
-                  <a:tcPr marL="73152" marR="36576" anchor="ctr">
-                    <a:solidFill>
-                      <a:srgbClr val="FFFFFF"/>
-                    </a:solidFill>
-                  </a:tcPr>
-                </a:tc>
-                <a:tc>
-                  <a:txBody>
-                    <a:bodyPr/>
-                    <a:lstStyle/>
-                    <a:p>
-                      <a:r>
-                        <a:rPr sz="1000" b="0">
-                          <a:solidFill>
-                            <a:srgbClr val="D9D9D9"/>
-                          </a:solidFill>
-                          <a:latin typeface="Arial"/>
-                        </a:rPr>
-                        <a:t>N/A</a:t>
-                      </a:r>
-                    </a:p>
-                  </a:txBody>
-                  <a:tcPr marL="73152" marR="36576" anchor="ctr">
-                    <a:solidFill>
-                      <a:srgbClr val="FFFFFF"/>
-                    </a:solidFill>
-                  </a:tcPr>
-                </a:tc>
-                <a:tc>
-                  <a:txBody>
-                    <a:bodyPr/>
-                    <a:lstStyle/>
-                    <a:p>
-                      <a:r>
-                        <a:rPr sz="950" dirty="0">
-                          <a:solidFill>
-                            <a:srgbClr val="757575"/>
-                          </a:solidFill>
-                          <a:latin typeface="Arial"/>
-                        </a:rPr>
-                        <a:t>COGS not tracked; price and discount proxies look healthy</a:t>
-                      </a:r>
-                    </a:p>
-                  </a:txBody>
-                  <a:tcPr marL="73152" marR="36576" anchor="ctr">
-                    <a:solidFill>
-                      <a:srgbClr val="FFFFFF"/>
-                    </a:solidFill>
-                  </a:tcPr>
-                </a:tc>
-                <a:extLst>
-                  <a:ext uri="{0D108BD9-81ED-4DB2-BD59-A6C34878D82A}">
-                    <a16:rowId xmlns:a16="http://schemas.microsoft.com/office/drawing/2014/main" val="10009"/>
-                  </a:ext>
-                </a:extLst>
-              </a:tr>
-            </a:tbl>
-          </a:graphicData>
-        </a:graphic>
-      </p:graphicFrame>
-      <p:sp>
-        <p:nvSpPr>
-          <p:cNvPr id="5" name="TextBox 4"/>
-          <p:cNvSpPr txBox="1"/>
-          <p:nvPr/>
-        </p:nvSpPr>
-        <p:spPr>
-          <a:xfrm>
-            <a:off x="502920" y="6510528"/>
-            <a:ext cx="10515600" cy="274320"/>
-          </a:xfrm>
-          <a:prstGeom prst="rect">
-            <a:avLst/>
-          </a:prstGeom>
-          <a:noFill/>
-        </p:spPr>
-        <p:txBody>
-          <a:bodyPr wrap="square" lIns="0" tIns="0" rIns="0" bIns="0" anchor="t">
-            <a:spAutoFit/>
-          </a:bodyPr>
-          <a:lstStyle/>
-          <a:p>
-            <a:pPr algn="l"/>
-            <a:r>
-              <a:rPr sz="800" b="0" i="0">
-                <a:solidFill>
-                  <a:srgbClr val="757575"/>
-                </a:solidFill>
-                <a:latin typeface="Arial"/>
-              </a:rPr>
-              <a:t>Salomon NA eCommerce · Vestal Pro launch readout · Illustrative synthetic case data</a:t>
-            </a:r>
-          </a:p>
-        </p:txBody>
-      </p:sp>
-      <p:sp>
-        <p:nvSpPr>
-          <p:cNvPr id="6" name="TextBox 5"/>
-          <p:cNvSpPr txBox="1"/>
-          <p:nvPr/>
-        </p:nvSpPr>
-        <p:spPr>
-          <a:xfrm>
-            <a:off x="11292840" y="6510528"/>
-            <a:ext cx="411480" cy="274320"/>
-          </a:xfrm>
-          <a:prstGeom prst="rect">
-            <a:avLst/>
-          </a:prstGeom>
-          <a:noFill/>
-        </p:spPr>
-        <p:txBody>
-          <a:bodyPr wrap="square" lIns="0" tIns="0" rIns="0" bIns="0" anchor="t">
-            <a:spAutoFit/>
-          </a:bodyPr>
-          <a:lstStyle/>
-          <a:p>
-            <a:pPr algn="r"/>
-            <a:r>
-              <a:rPr sz="800" b="0" i="0">
-                <a:solidFill>
-                  <a:srgbClr val="757575"/>
-                </a:solidFill>
-                <a:latin typeface="Arial"/>
-              </a:rPr>
-              <a:t>11</a:t>
-            </a:r>
-          </a:p>
-        </p:txBody>
-      </p:sp>
-      <p:pic>
-        <p:nvPicPr>
-          <p:cNvPr id="7" name="Picture 6" descr="salomon_wordmark_black.png"/>
-          <p:cNvPicPr>
-            <a:picLocks noChangeAspect="1"/>
-          </p:cNvPicPr>
-          <p:nvPr/>
-        </p:nvPicPr>
-        <p:blipFill>
-          <a:blip r:embed="rId2"/>
-          <a:stretch>
-            <a:fillRect/>
-          </a:stretch>
-        </p:blipFill>
-        <p:spPr>
-          <a:xfrm>
-            <a:off x="10698480" y="292608"/>
-            <a:ext cx="960120" cy="110013"/>
-          </a:xfrm>
-          <a:prstGeom prst="rect">
-            <a:avLst/>
-          </a:prstGeom>
-        </p:spPr>
-      </p:pic>
-    </p:spTree>
-  </p:cSld>
-  <p:clrMapOvr>
-    <a:masterClrMapping/>
-  </p:clrMapOvr>
-</p:sld>
-</file>
-
 <file path=ppt/slides/slide2.xml><?xml version="1.0" encoding="utf-8"?>
 <p:sld xmlns:a="http://schemas.openxmlformats.org/drawingml/2006/main" xmlns:r="http://schemas.openxmlformats.org/officeDocument/2006/relationships" xmlns:p="http://schemas.openxmlformats.org/presentationml/2006/main">
   <p:cSld>
@@ -9372,7 +8139,7 @@
         <p:spPr>
           <a:xfrm>
             <a:off x="6309360" y="1783080"/>
-            <a:ext cx="5394960" cy="1538883"/>
+            <a:ext cx="5394960" cy="1269578"/>
           </a:xfrm>
           <a:prstGeom prst="rect">
             <a:avLst/>
@@ -9493,22 +8260,6 @@
               </a:solidFill>
               <a:latin typeface="Arial"/>
             </a:endParaRPr>
-          </a:p>
-          <a:p>
-            <a:pPr algn="l">
-              <a:spcAft>
-                <a:spcPts val="600"/>
-              </a:spcAft>
-            </a:pPr>
-            <a:r>
-              <a:rPr sz="1250" b="0" i="0" dirty="0">
-                <a:solidFill>
-                  <a:srgbClr val="333333"/>
-                </a:solidFill>
-                <a:latin typeface="Arial"/>
-              </a:rPr>
-              <a:t>•  Guardrails: margin, returns, conversion, availability, service</a:t>
-            </a:r>
           </a:p>
         </p:txBody>
       </p:sp>
@@ -10215,7 +8966,7 @@
           <p:nvPr/>
         </p:nvPicPr>
         <p:blipFill>
-          <a:blip r:embed="rId2"/>
+          <a:blip r:embed="rId3"/>
           <a:stretch>
             <a:fillRect/>
           </a:stretch>
@@ -10235,6 +8986,11 @@
   <p:clrMapOvr>
     <a:masterClrMapping/>
   </p:clrMapOvr>
+  <p:extLst>
+    <p:ext uri="{6950BFC3-D8DA-4A85-94F7-54DA5524770B}">
+      <p188:commentRel xmlns:p188="http://schemas.microsoft.com/office/powerpoint/2018/8/main" r:id="rId2"/>
+    </p:ext>
+  </p:extLst>
 </p:sld>
 </file>
 
@@ -15424,7 +14180,7 @@
       </p:grpSpPr>
       <p:pic>
         <p:nvPicPr>
-          <p:cNvPr id="14" name="Picture 13" descr="The image shows a bar chart comparing actual revenue growth for adjacent categories (Adjacent-category revenue vs. expected baseline) in an active flight segment, with Trail Apparel and Trail Accessories, where the success criterion of a minimum 5% growth has been met, indicating significant positive results.&#10;&#10;AI-generated content may be incorrect.">
+          <p:cNvPr id="14" name="Picture 13">
             <a:extLst>
               <a:ext uri="{FF2B5EF4-FFF2-40B4-BE49-F238E27FC236}">
                 <a16:creationId xmlns:a16="http://schemas.microsoft.com/office/drawing/2014/main" id="{4A335441-E4DE-8121-4407-C74C03AA7598}"/>
@@ -15438,14 +14194,13 @@
         </p:nvPicPr>
         <p:blipFill>
           <a:blip r:embed="rId2"/>
-          <a:stretch>
-            <a:fillRect/>
-          </a:stretch>
+          <a:srcRect/>
+          <a:stretch/>
         </p:blipFill>
         <p:spPr>
           <a:xfrm>
             <a:off x="-1" y="1308688"/>
-            <a:ext cx="6832397" cy="4081459"/>
+            <a:ext cx="6832397" cy="4081458"/>
           </a:xfrm>
           <a:prstGeom prst="rect">
             <a:avLst/>

</xml_diff>